<commit_message>
deck_dyson_3k: TO's step-0 corrections -- the paper's smile bound is 1.8 um = 0.10 of our pixel (not 0.05); the SRF floor with pixel and diffraction is 2.010-2.023 px, the Dyson adds <= 0.0015 px (0.03 um), not 0.025; ARF 18.4 um; fast suite 566/0
Co-Authored-By: Claude Fable 5.1 <noreply@anthropic.com>
</commit_message>
<xml_diff>
--- a/demo_session/deck_dyson_3k.pptx
+++ b/demo_session/deck_dyson_3k.pptx
@@ -5124,7 +5124,7 @@
                 </a:solidFill>
                 <a:latin typeface="Arial"/>
               </a:rPr>
-              <a:t>SRF 2.025 px is the two-pixel slit's 2.000 plus 0.45 µm of blur, and in the paper's units it is 36.5 µm against 64.8; the open spectrometer work is tolerances, the aspheric-lens form, and throughput by band</a:t>
+              <a:t>SRF 2.025 px is the two-pixel slit with the pixel and diffraction (2.010–2.023) plus at most 0.03 µm of blur, and in the paper's units it is 36.5 µm against 64.8; the open spectrometer work is tolerances, the aspheric-lens form, and throughput by band</a:t>
             </a:r>
           </a:p>
         </p:txBody>
@@ -5225,7 +5225,7 @@
                 </a:solidFill>
                 <a:latin typeface="Arial"/>
               </a:rPr>
-              <a:t>  The scorer's SRF is slit ⊗ LSF ⊗ pixel ⊗ Airy; with a 2-pixel slit a perfect spectrometer gives exactly 2.000 px.  The Dyson of record gives 2.024 alone and 2.025 behind the telescope: 0.45 µm of blur.  Joe's "1.5–2.0" is met at its floor; 1.5 would need a narrower slit, not a better spectrometer.  In the paper's co-added pixels our SRF is 1.01 against its 1.33 design and 1.8 requirement; our CRF 21 µm against its 50.</a:t>
+              <a:t>  The scorer's SRF is slit ⊗ LSF ⊗ pixel ⊗ Airy; with a 2-pixel slit a perfect spectrometer gives 2.010 px at 380 nm and 2.023 at 2500 nm — the slit, the pixel and diffraction.  The Dyson of record sits 0.0001–0.0015 px above that floor at every wavelength, alone and behind the telescope: at most 0.03 µm of blur.  Joe's "1.5–2.0" is met at its floor; 1.5 would need a narrower slit, not a better spectrometer.  In the paper's co-added pixels our SRF is 1.01 against its 1.33 design and 1.8 requirement; our CRF 21 µm against its 50.</a:t>
             </a:r>
           </a:p>
           <a:p>
@@ -6728,7 +6728,7 @@
                 </a:solidFill>
                 <a:latin typeface="Arial"/>
               </a:rPr>
-              <a:t>  With a 2-pixel slit the SRF floor is 2.0 px (36 µm), where this design sits; the paper's bound is 64.8 µm.  Is the 1.5–2.0 px range read against a 2-pixel slit, or does the project want a narrower slit at the throughput's expense?</a:t>
+              <a:t>  With a 2-pixel slit the SRF floor is 2.01–2.02 px (36 µm) with the pixel and diffraction, where this design sits to 0.03 µm; the paper's bound is 64.8 µm.  Is the 1.5–2.0 px range read against a 2-pixel slit, or does the project want a narrower slit at the throughput's expense?</a:t>
             </a:r>
           </a:p>
           <a:p>
@@ -7529,7 +7529,7 @@
                 </a:solidFill>
                 <a:latin typeface="Arial"/>
               </a:rPr>
-              <a:t> ./run_mmacos_tests.sh tTmaLongslit tSpectrometerRx tTelescopeRx tStopReload and the grating, glass, propagation and root-pick classes, all in the fast suite (559 pass, 0 fail, 2026-10-07).  tTmaLongslit re-scores the deck of record by name.</a:t>
+              <a:t> ./run_mmacos_tests.sh tTmaLongslit tSpectrometerRx tTelescopeRx tStopReload and the grating, glass, propagation and root-pick classes, all in the fast suite (566 pass, 0 fail, 2026-10-07).  tTmaLongslit re-scores the deck of record by name.</a:t>
             </a:r>
           </a:p>
         </p:txBody>
@@ -11276,7 +11276,7 @@
         </p:nvGraphicFramePr>
         <p:xfrm>
           <a:off x="411480" y="1298448"/>
-          <a:ext cx="5806438" cy="3646170"/>
+          <a:ext cx="5806438" cy="4211955"/>
         </p:xfrm>
         <a:graphic>
           <a:graphicData uri="http://schemas.openxmlformats.org/drawingml/2006/table">
@@ -11285,9 +11285,9 @@
                 <a:tableStyleId>{5C22544A-7EE6-4342-B048-85BDC9FD1C3A}</a:tableStyleId>
               </a:tblPr>
               <a:tblGrid>
-                <a:gridCol w="1705065"/>
-                <a:gridCol w="1705065"/>
-                <a:gridCol w="2396308"/>
+                <a:gridCol w="1512945"/>
+                <a:gridCol w="1512945"/>
+                <a:gridCol w="2780548"/>
               </a:tblGrid>
               <a:tr h="280035">
                 <a:tc>
@@ -11425,7 +11425,7 @@
                   </a:tcPr>
                 </a:tc>
               </a:tr>
-              <a:tr h="280035">
+              <a:tr h="468630">
                 <a:tc>
                   <a:txBody>
                     <a:bodyPr wrap="square"/>
@@ -11561,7 +11561,7 @@
                   </a:tcPr>
                 </a:tc>
               </a:tr>
-              <a:tr h="280035">
+              <a:tr h="468630">
                 <a:tc>
                   <a:txBody>
                     <a:bodyPr wrap="square"/>
@@ -11754,7 +11754,7 @@
                           </a:solidFill>
                           <a:latin typeface="Arial"/>
                         </a:rPr>
-                        <a:t>5 % of a co-added px (1.8 µm); 10 % of a px (1.8 µm)</a:t>
+                        <a:t>1.8 µm each (5 % of a co-added px; 10 % of a px) = 0.10 of our pixel</a:t>
                       </a:r>
                     </a:p>
                   </a:txBody>
@@ -11765,7 +11765,7 @@
                   </a:tcPr>
                 </a:tc>
               </a:tr>
-              <a:tr h="280035">
+              <a:tr h="468630">
                 <a:tc>
                   <a:txBody>
                     <a:bodyPr wrap="square"/>
@@ -12145,7 +12145,7 @@
                 </a:solidFill>
                 <a:latin typeface="Arial"/>
               </a:rPr>
-              <a:t> slit ⊗ line-spread function ⊗ pixel ⊗ Airy, FWHM (Mouroulis &amp; Green 2018).  With a 2-pixel slit a perfect spectrometer gives SRF = 2.000 px exactly: the slit's floor.</a:t>
+              <a:t> slit ⊗ line-spread function ⊗ pixel ⊗ Airy, FWHM (Mouroulis &amp; Green 2018).  With a 2-pixel slit a perfect spectrometer gives SRF = 2.010–2.023 px over the band (slit, pixel and diffraction): the floor.</a:t>
             </a:r>
           </a:p>
           <a:p>
@@ -12260,7 +12260,7 @@
         </p:nvSpPr>
         <p:spPr>
           <a:xfrm>
-            <a:off x="6400800" y="4809744"/>
+            <a:off x="6400800" y="5007864"/>
             <a:ext cx="5394960" cy="274320"/>
           </a:xfrm>
           <a:prstGeom prst="rect">
@@ -14624,7 +14624,7 @@
         </p:nvGraphicFramePr>
         <p:xfrm>
           <a:off x="411480" y="1298448"/>
-          <a:ext cx="11368730" cy="4680585"/>
+          <a:ext cx="11368733" cy="4303395"/>
         </p:xfrm>
         <a:graphic>
           <a:graphicData uri="http://schemas.openxmlformats.org/drawingml/2006/table">
@@ -14633,12 +14633,12 @@
                 <a:tableStyleId>{5C22544A-7EE6-4342-B048-85BDC9FD1C3A}</a:tableStyleId>
               </a:tblPr>
               <a:tblGrid>
-                <a:gridCol w="1632743"/>
-                <a:gridCol w="665191"/>
-                <a:gridCol w="1511799"/>
-                <a:gridCol w="2297935"/>
-                <a:gridCol w="1753687"/>
-                <a:gridCol w="3507375"/>
+                <a:gridCol w="2107692"/>
+                <a:gridCol w="945388"/>
+                <a:gridCol w="1962404"/>
+                <a:gridCol w="1815214"/>
+                <a:gridCol w="1767445"/>
+                <a:gridCol w="2770590"/>
               </a:tblGrid>
               <a:tr h="468630">
                 <a:tc>
@@ -14858,7 +14858,7 @@
                           </a:solidFill>
                           <a:latin typeface="Arial"/>
                         </a:rPr>
-                        <a:t>&lt; 1.8 µm</a:t>
+                        <a:t>&lt; 1.8 µm (0.10 px)</a:t>
                       </a:r>
                     </a:p>
                   </a:txBody>
@@ -14992,7 +14992,7 @@
                           </a:solidFill>
                           <a:latin typeface="Arial"/>
                         </a:rPr>
-                        <a:t>&lt; 1.8 µm</a:t>
+                        <a:t>&lt; 1.8 µm (0.10 px)</a:t>
                       </a:r>
                     </a:p>
                   </a:txBody>
@@ -15304,7 +15304,7 @@
                           </a:solidFill>
                           <a:latin typeface="Arial"/>
                         </a:rPr>
-                        <a:t>1.02 px across the slit (ARF)</a:t>
+                        <a:t>1.02 px across the slit (ARF 18.4 µm)</a:t>
                       </a:r>
                     </a:p>
                   </a:txBody>
@@ -15327,6 +15327,542 @@
                           <a:latin typeface="Arial"/>
                         </a:rPr>
                         <a:t>2.025 px (36.5 µm)</a:t>
+                      </a:r>
+                    </a:p>
+                  </a:txBody>
+                  <a:tcPr marL="54864" marR="54864" marT="18288" marB="18288">
+                    <a:solidFill>
+                      <a:srgbClr val="ECF1F6"/>
+                    </a:solidFill>
+                  </a:tcPr>
+                </a:tc>
+              </a:tr>
+              <a:tr h="280035">
+                <a:tc>
+                  <a:txBody>
+                    <a:bodyPr wrap="square"/>
+                    <a:lstStyle/>
+                    <a:p>
+                      <a:r>
+                        <a:rPr sz="1100" b="0">
+                          <a:solidFill>
+                            <a:srgbClr val="282828"/>
+                          </a:solidFill>
+                          <a:latin typeface="Arial"/>
+                        </a:rPr>
+                        <a:t>energy in one 18 µm pixel</a:t>
+                      </a:r>
+                    </a:p>
+                  </a:txBody>
+                  <a:tcPr marL="54864" marR="54864" marT="18288" marB="18288">
+                    <a:solidFill>
+                      <a:srgbClr val="FFFFFF"/>
+                    </a:solidFill>
+                  </a:tcPr>
+                </a:tc>
+                <a:tc>
+                  <a:txBody>
+                    <a:bodyPr wrap="square"/>
+                    <a:lstStyle/>
+                    <a:p>
+                      <a:r>
+                        <a:rPr sz="1100" b="0">
+                          <a:solidFill>
+                            <a:srgbClr val="282828"/>
+                          </a:solidFill>
+                          <a:latin typeface="Arial"/>
+                        </a:rPr>
+                        <a:t>&gt; 0.75</a:t>
+                      </a:r>
+                    </a:p>
+                  </a:txBody>
+                  <a:tcPr marL="54864" marR="54864" marT="18288" marB="18288">
+                    <a:solidFill>
+                      <a:srgbClr val="FFFFFF"/>
+                    </a:solidFill>
+                  </a:tcPr>
+                </a:tc>
+                <a:tc>
+                  <a:txBody>
+                    <a:bodyPr wrap="square"/>
+                    <a:lstStyle/>
+                    <a:p>
+                      <a:r>
+                        <a:rPr sz="1100" b="0">
+                          <a:solidFill>
+                            <a:srgbClr val="282828"/>
+                          </a:solidFill>
+                          <a:latin typeface="Arial"/>
+                        </a:rPr>
+                        <a:t>–</a:t>
+                      </a:r>
+                    </a:p>
+                  </a:txBody>
+                  <a:tcPr marL="54864" marR="54864" marT="18288" marB="18288">
+                    <a:solidFill>
+                      <a:srgbClr val="FFFFFF"/>
+                    </a:solidFill>
+                  </a:tcPr>
+                </a:tc>
+                <a:tc>
+                  <a:txBody>
+                    <a:bodyPr wrap="square"/>
+                    <a:lstStyle/>
+                    <a:p>
+                      <a:r>
+                        <a:rPr sz="1100" b="0">
+                          <a:solidFill>
+                            <a:srgbClr val="282828"/>
+                          </a:solidFill>
+                          <a:latin typeface="Arial"/>
+                        </a:rPr>
+                        <a:t>0.82</a:t>
+                      </a:r>
+                    </a:p>
+                  </a:txBody>
+                  <a:tcPr marL="54864" marR="54864" marT="18288" marB="18288">
+                    <a:solidFill>
+                      <a:srgbClr val="FFFFFF"/>
+                    </a:solidFill>
+                  </a:tcPr>
+                </a:tc>
+                <a:tc>
+                  <a:txBody>
+                    <a:bodyPr wrap="square"/>
+                    <a:lstStyle/>
+                    <a:p>
+                      <a:r>
+                        <a:rPr sz="1100" b="0">
+                          <a:solidFill>
+                            <a:srgbClr val="282828"/>
+                          </a:solidFill>
+                          <a:latin typeface="Arial"/>
+                        </a:rPr>
+                        <a:t>1.00</a:t>
+                      </a:r>
+                    </a:p>
+                  </a:txBody>
+                  <a:tcPr marL="54864" marR="54864" marT="18288" marB="18288">
+                    <a:solidFill>
+                      <a:srgbClr val="FFFFFF"/>
+                    </a:solidFill>
+                  </a:tcPr>
+                </a:tc>
+                <a:tc>
+                  <a:txBody>
+                    <a:bodyPr wrap="square"/>
+                    <a:lstStyle/>
+                    <a:p>
+                      <a:r>
+                        <a:rPr sz="1100" b="0">
+                          <a:solidFill>
+                            <a:srgbClr val="282828"/>
+                          </a:solidFill>
+                          <a:latin typeface="Arial"/>
+                        </a:rPr>
+                        <a:t>0.85 (0.81 at roll 180°)</a:t>
+                      </a:r>
+                    </a:p>
+                  </a:txBody>
+                  <a:tcPr marL="54864" marR="54864" marT="18288" marB="18288">
+                    <a:solidFill>
+                      <a:srgbClr val="FFFFFF"/>
+                    </a:solidFill>
+                  </a:tcPr>
+                </a:tc>
+              </a:tr>
+              <a:tr h="280035">
+                <a:tc>
+                  <a:txBody>
+                    <a:bodyPr wrap="square"/>
+                    <a:lstStyle/>
+                    <a:p>
+                      <a:r>
+                        <a:rPr sz="1100" b="0">
+                          <a:solidFill>
+                            <a:srgbClr val="282828"/>
+                          </a:solidFill>
+                          <a:latin typeface="Arial"/>
+                        </a:rPr>
+                        <a:t>image blur (rms, as placed)</a:t>
+                      </a:r>
+                    </a:p>
+                  </a:txBody>
+                  <a:tcPr marL="54864" marR="54864" marT="18288" marB="18288">
+                    <a:solidFill>
+                      <a:srgbClr val="ECF1F6"/>
+                    </a:solidFill>
+                  </a:tcPr>
+                </a:tc>
+                <a:tc>
+                  <a:txBody>
+                    <a:bodyPr wrap="square"/>
+                    <a:lstStyle/>
+                    <a:p>
+                      <a:r>
+                        <a:rPr sz="1100" b="0">
+                          <a:solidFill>
+                            <a:srgbClr val="282828"/>
+                          </a:solidFill>
+                          <a:latin typeface="Arial"/>
+                        </a:rPr>
+                        <a:t>–</a:t>
+                      </a:r>
+                    </a:p>
+                  </a:txBody>
+                  <a:tcPr marL="54864" marR="54864" marT="18288" marB="18288">
+                    <a:solidFill>
+                      <a:srgbClr val="ECF1F6"/>
+                    </a:solidFill>
+                  </a:tcPr>
+                </a:tc>
+                <a:tc>
+                  <a:txBody>
+                    <a:bodyPr wrap="square"/>
+                    <a:lstStyle/>
+                    <a:p>
+                      <a:r>
+                        <a:rPr sz="1100" b="0">
+                          <a:solidFill>
+                            <a:srgbClr val="282828"/>
+                          </a:solidFill>
+                          <a:latin typeface="Arial"/>
+                        </a:rPr>
+                        <a:t>2–3 µm (paper)</a:t>
+                      </a:r>
+                    </a:p>
+                  </a:txBody>
+                  <a:tcPr marL="54864" marR="54864" marT="18288" marB="18288">
+                    <a:solidFill>
+                      <a:srgbClr val="ECF1F6"/>
+                    </a:solidFill>
+                  </a:tcPr>
+                </a:tc>
+                <a:tc>
+                  <a:txBody>
+                    <a:bodyPr wrap="square"/>
+                    <a:lstStyle/>
+                    <a:p>
+                      <a:r>
+                        <a:rPr sz="1100" b="0">
+                          <a:solidFill>
+                            <a:srgbClr val="282828"/>
+                          </a:solidFill>
+                          <a:latin typeface="Arial"/>
+                        </a:rPr>
+                        <a:t>–</a:t>
+                      </a:r>
+                    </a:p>
+                  </a:txBody>
+                  <a:tcPr marL="54864" marR="54864" marT="18288" marB="18288">
+                    <a:solidFill>
+                      <a:srgbClr val="ECF1F6"/>
+                    </a:solidFill>
+                  </a:tcPr>
+                </a:tc>
+                <a:tc>
+                  <a:txBody>
+                    <a:bodyPr wrap="square"/>
+                    <a:lstStyle/>
+                    <a:p>
+                      <a:r>
+                        <a:rPr sz="1100" b="0">
+                          <a:solidFill>
+                            <a:srgbClr val="282828"/>
+                          </a:solidFill>
+                          <a:latin typeface="Arial"/>
+                        </a:rPr>
+                        <a:t>1.8–2.5 µm</a:t>
+                      </a:r>
+                    </a:p>
+                  </a:txBody>
+                  <a:tcPr marL="54864" marR="54864" marT="18288" marB="18288">
+                    <a:solidFill>
+                      <a:srgbClr val="ECF1F6"/>
+                    </a:solidFill>
+                  </a:tcPr>
+                </a:tc>
+                <a:tc>
+                  <a:txBody>
+                    <a:bodyPr wrap="square"/>
+                    <a:lstStyle/>
+                    <a:p>
+                      <a:r>
+                        <a:rPr sz="1100" b="0">
+                          <a:solidFill>
+                            <a:srgbClr val="282828"/>
+                          </a:solidFill>
+                          <a:latin typeface="Arial"/>
+                        </a:rPr>
+                        <a:t>–</a:t>
+                      </a:r>
+                    </a:p>
+                  </a:txBody>
+                  <a:tcPr marL="54864" marR="54864" marT="18288" marB="18288">
+                    <a:solidFill>
+                      <a:srgbClr val="ECF1F6"/>
+                    </a:solidFill>
+                  </a:tcPr>
+                </a:tc>
+              </a:tr>
+              <a:tr h="280035">
+                <a:tc>
+                  <a:txBody>
+                    <a:bodyPr wrap="square"/>
+                    <a:lstStyle/>
+                    <a:p>
+                      <a:r>
+                        <a:rPr sz="1100" b="0">
+                          <a:solidFill>
+                            <a:srgbClr val="282828"/>
+                          </a:solidFill>
+                          <a:latin typeface="Arial"/>
+                        </a:rPr>
+                        <a:t>plate scale</a:t>
+                      </a:r>
+                    </a:p>
+                  </a:txBody>
+                  <a:tcPr marL="54864" marR="54864" marT="18288" marB="18288">
+                    <a:solidFill>
+                      <a:srgbClr val="FFFFFF"/>
+                    </a:solidFill>
+                  </a:tcPr>
+                </a:tc>
+                <a:tc>
+                  <a:txBody>
+                    <a:bodyPr wrap="square"/>
+                    <a:lstStyle/>
+                    <a:p>
+                      <a:r>
+                        <a:rPr sz="1100" b="0">
+                          <a:solidFill>
+                            <a:srgbClr val="282828"/>
+                          </a:solidFill>
+                          <a:latin typeface="Arial"/>
+                        </a:rPr>
+                        <a:t>330 mm</a:t>
+                      </a:r>
+                    </a:p>
+                  </a:txBody>
+                  <a:tcPr marL="54864" marR="54864" marT="18288" marB="18288">
+                    <a:solidFill>
+                      <a:srgbClr val="FFFFFF"/>
+                    </a:solidFill>
+                  </a:tcPr>
+                </a:tc>
+                <a:tc>
+                  <a:txBody>
+                    <a:bodyPr wrap="square"/>
+                    <a:lstStyle/>
+                    <a:p>
+                      <a:r>
+                        <a:rPr sz="1100" b="0">
+                          <a:solidFill>
+                            <a:srgbClr val="282828"/>
+                          </a:solidFill>
+                          <a:latin typeface="Arial"/>
+                        </a:rPr>
+                        <a:t>345</a:t>
+                      </a:r>
+                    </a:p>
+                  </a:txBody>
+                  <a:tcPr marL="54864" marR="54864" marT="18288" marB="18288">
+                    <a:solidFill>
+                      <a:srgbClr val="FFFFFF"/>
+                    </a:solidFill>
+                  </a:tcPr>
+                </a:tc>
+                <a:tc>
+                  <a:txBody>
+                    <a:bodyPr wrap="square"/>
+                    <a:lstStyle/>
+                    <a:p>
+                      <a:r>
+                        <a:rPr sz="1100" b="0">
+                          <a:solidFill>
+                            <a:srgbClr val="282828"/>
+                          </a:solidFill>
+                          <a:latin typeface="Arial"/>
+                        </a:rPr>
+                        <a:t>–</a:t>
+                      </a:r>
+                    </a:p>
+                  </a:txBody>
+                  <a:tcPr marL="54864" marR="54864" marT="18288" marB="18288">
+                    <a:solidFill>
+                      <a:srgbClr val="FFFFFF"/>
+                    </a:solidFill>
+                  </a:tcPr>
+                </a:tc>
+                <a:tc>
+                  <a:txBody>
+                    <a:bodyPr wrap="square"/>
+                    <a:lstStyle/>
+                    <a:p>
+                      <a:r>
+                        <a:rPr sz="1100" b="0">
+                          <a:solidFill>
+                            <a:srgbClr val="282828"/>
+                          </a:solidFill>
+                          <a:latin typeface="Arial"/>
+                        </a:rPr>
+                        <a:t>329.9 / 330.1 mm</a:t>
+                      </a:r>
+                    </a:p>
+                  </a:txBody>
+                  <a:tcPr marL="54864" marR="54864" marT="18288" marB="18288">
+                    <a:solidFill>
+                      <a:srgbClr val="FFFFFF"/>
+                    </a:solidFill>
+                  </a:tcPr>
+                </a:tc>
+                <a:tc>
+                  <a:txBody>
+                    <a:bodyPr wrap="square"/>
+                    <a:lstStyle/>
+                    <a:p>
+                      <a:r>
+                        <a:rPr sz="1100" b="0">
+                          <a:solidFill>
+                            <a:srgbClr val="282828"/>
+                          </a:solidFill>
+                          <a:latin typeface="Arial"/>
+                        </a:rPr>
+                        <a:t>330.1 mm</a:t>
+                      </a:r>
+                    </a:p>
+                  </a:txBody>
+                  <a:tcPr marL="54864" marR="54864" marT="18288" marB="18288">
+                    <a:solidFill>
+                      <a:srgbClr val="FFFFFF"/>
+                    </a:solidFill>
+                  </a:tcPr>
+                </a:tc>
+              </a:tr>
+              <a:tr h="280035">
+                <a:tc>
+                  <a:txBody>
+                    <a:bodyPr wrap="square"/>
+                    <a:lstStyle/>
+                    <a:p>
+                      <a:r>
+                        <a:rPr sz="1100" b="0">
+                          <a:solidFill>
+                            <a:srgbClr val="282828"/>
+                          </a:solidFill>
+                          <a:latin typeface="Arial"/>
+                        </a:rPr>
+                        <a:t>chief rays at the slit</a:t>
+                      </a:r>
+                    </a:p>
+                  </a:txBody>
+                  <a:tcPr marL="54864" marR="54864" marT="18288" marB="18288">
+                    <a:solidFill>
+                      <a:srgbClr val="ECF1F6"/>
+                    </a:solidFill>
+                  </a:tcPr>
+                </a:tc>
+                <a:tc>
+                  <a:txBody>
+                    <a:bodyPr wrap="square"/>
+                    <a:lstStyle/>
+                    <a:p>
+                      <a:r>
+                        <a:rPr sz="1100" b="0">
+                          <a:solidFill>
+                            <a:srgbClr val="282828"/>
+                          </a:solidFill>
+                          <a:latin typeface="Arial"/>
+                        </a:rPr>
+                        <a:t>telecentric</a:t>
+                      </a:r>
+                    </a:p>
+                  </a:txBody>
+                  <a:tcPr marL="54864" marR="54864" marT="18288" marB="18288">
+                    <a:solidFill>
+                      <a:srgbClr val="ECF1F6"/>
+                    </a:solidFill>
+                  </a:tcPr>
+                </a:tc>
+                <a:tc>
+                  <a:txBody>
+                    <a:bodyPr wrap="square"/>
+                    <a:lstStyle/>
+                    <a:p>
+                      <a:r>
+                        <a:rPr sz="1100" b="0">
+                          <a:solidFill>
+                            <a:srgbClr val="282828"/>
+                          </a:solidFill>
+                          <a:latin typeface="Arial"/>
+                        </a:rPr>
+                        <a:t>telecentric</a:t>
+                      </a:r>
+                    </a:p>
+                  </a:txBody>
+                  <a:tcPr marL="54864" marR="54864" marT="18288" marB="18288">
+                    <a:solidFill>
+                      <a:srgbClr val="ECF1F6"/>
+                    </a:solidFill>
+                  </a:tcPr>
+                </a:tc>
+                <a:tc>
+                  <a:txBody>
+                    <a:bodyPr wrap="square"/>
+                    <a:lstStyle/>
+                    <a:p>
+                      <a:r>
+                        <a:rPr sz="1100" b="0">
+                          <a:solidFill>
+                            <a:srgbClr val="282828"/>
+                          </a:solidFill>
+                          <a:latin typeface="Arial"/>
+                        </a:rPr>
+                        <a:t>–</a:t>
+                      </a:r>
+                    </a:p>
+                  </a:txBody>
+                  <a:tcPr marL="54864" marR="54864" marT="18288" marB="18288">
+                    <a:solidFill>
+                      <a:srgbClr val="ECF1F6"/>
+                    </a:solidFill>
+                  </a:tcPr>
+                </a:tc>
+                <a:tc>
+                  <a:txBody>
+                    <a:bodyPr wrap="square"/>
+                    <a:lstStyle/>
+                    <a:p>
+                      <a:r>
+                        <a:rPr sz="1100" b="0">
+                          <a:solidFill>
+                            <a:srgbClr val="282828"/>
+                          </a:solidFill>
+                          <a:latin typeface="Arial"/>
+                        </a:rPr>
+                        <a:t>within 0.033°</a:t>
+                      </a:r>
+                    </a:p>
+                  </a:txBody>
+                  <a:tcPr marL="54864" marR="54864" marT="18288" marB="18288">
+                    <a:solidFill>
+                      <a:srgbClr val="ECF1F6"/>
+                    </a:solidFill>
+                  </a:tcPr>
+                </a:tc>
+                <a:tc>
+                  <a:txBody>
+                    <a:bodyPr wrap="square"/>
+                    <a:lstStyle/>
+                    <a:p>
+                      <a:r>
+                        <a:rPr sz="1100" b="0">
+                          <a:solidFill>
+                            <a:srgbClr val="282828"/>
+                          </a:solidFill>
+                          <a:latin typeface="Arial"/>
+                        </a:rPr>
+                        <a:t>–</a:t>
                       </a:r>
                     </a:p>
                   </a:txBody>
@@ -15350,7 +15886,7 @@
                           </a:solidFill>
                           <a:latin typeface="Arial"/>
                         </a:rPr>
-                        <a:t>energy in one 18 µm pixel</a:t>
+                        <a:t>marginal rays at the slit</a:t>
                       </a:r>
                     </a:p>
                   </a:txBody>
@@ -15372,7 +15908,7 @@
                           </a:solidFill>
                           <a:latin typeface="Arial"/>
                         </a:rPr>
-                        <a:t>&gt; 0.75</a:t>
+                        <a:t>–</a:t>
                       </a:r>
                     </a:p>
                   </a:txBody>
@@ -15394,6 +15930,28 @@
                           </a:solidFill>
                           <a:latin typeface="Arial"/>
                         </a:rPr>
+                        <a:t>F/# anamorphicity bounded</a:t>
+                      </a:r>
+                    </a:p>
+                  </a:txBody>
+                  <a:tcPr marL="54864" marR="54864" marT="18288" marB="18288">
+                    <a:solidFill>
+                      <a:srgbClr val="FFFFFF"/>
+                    </a:solidFill>
+                  </a:tcPr>
+                </a:tc>
+                <a:tc>
+                  <a:txBody>
+                    <a:bodyPr wrap="square"/>
+                    <a:lstStyle/>
+                    <a:p>
+                      <a:r>
+                        <a:rPr sz="1100" b="0">
+                          <a:solidFill>
+                            <a:srgbClr val="282828"/>
+                          </a:solidFill>
+                          <a:latin typeface="Arial"/>
+                        </a:rPr>
                         <a:t>–</a:t>
                       </a:r>
                     </a:p>
@@ -15416,7 +15974,7 @@
                           </a:solidFill>
                           <a:latin typeface="Arial"/>
                         </a:rPr>
-                        <a:t>0.82</a:t>
+                        <a:t>F/1.80–1.89, none below 1.7</a:t>
                       </a:r>
                     </a:p>
                   </a:txBody>
@@ -15438,29 +15996,7 @@
                           </a:solidFill>
                           <a:latin typeface="Arial"/>
                         </a:rPr>
-                        <a:t>1.00</a:t>
-                      </a:r>
-                    </a:p>
-                  </a:txBody>
-                  <a:tcPr marL="54864" marR="54864" marT="18288" marB="18288">
-                    <a:solidFill>
-                      <a:srgbClr val="FFFFFF"/>
-                    </a:solidFill>
-                  </a:tcPr>
-                </a:tc>
-                <a:tc>
-                  <a:txBody>
-                    <a:bodyPr wrap="square"/>
-                    <a:lstStyle/>
-                    <a:p>
-                      <a:r>
-                        <a:rPr sz="1100" b="0">
-                          <a:solidFill>
-                            <a:srgbClr val="282828"/>
-                          </a:solidFill>
-                          <a:latin typeface="Arial"/>
-                        </a:rPr>
-                        <a:t>0.85 (0.81 at roll 180°)</a:t>
+                        <a:t>grating admits 98.9 %</a:t>
                       </a:r>
                     </a:p>
                   </a:txBody>
@@ -15472,542 +16008,6 @@
                 </a:tc>
               </a:tr>
               <a:tr h="468630">
-                <a:tc>
-                  <a:txBody>
-                    <a:bodyPr wrap="square"/>
-                    <a:lstStyle/>
-                    <a:p>
-                      <a:r>
-                        <a:rPr sz="1100" b="0">
-                          <a:solidFill>
-                            <a:srgbClr val="282828"/>
-                          </a:solidFill>
-                          <a:latin typeface="Arial"/>
-                        </a:rPr>
-                        <a:t>image blur (rms, as placed)</a:t>
-                      </a:r>
-                    </a:p>
-                  </a:txBody>
-                  <a:tcPr marL="54864" marR="54864" marT="18288" marB="18288">
-                    <a:solidFill>
-                      <a:srgbClr val="ECF1F6"/>
-                    </a:solidFill>
-                  </a:tcPr>
-                </a:tc>
-                <a:tc>
-                  <a:txBody>
-                    <a:bodyPr wrap="square"/>
-                    <a:lstStyle/>
-                    <a:p>
-                      <a:r>
-                        <a:rPr sz="1100" b="0">
-                          <a:solidFill>
-                            <a:srgbClr val="282828"/>
-                          </a:solidFill>
-                          <a:latin typeface="Arial"/>
-                        </a:rPr>
-                        <a:t>–</a:t>
-                      </a:r>
-                    </a:p>
-                  </a:txBody>
-                  <a:tcPr marL="54864" marR="54864" marT="18288" marB="18288">
-                    <a:solidFill>
-                      <a:srgbClr val="ECF1F6"/>
-                    </a:solidFill>
-                  </a:tcPr>
-                </a:tc>
-                <a:tc>
-                  <a:txBody>
-                    <a:bodyPr wrap="square"/>
-                    <a:lstStyle/>
-                    <a:p>
-                      <a:r>
-                        <a:rPr sz="1100" b="0">
-                          <a:solidFill>
-                            <a:srgbClr val="282828"/>
-                          </a:solidFill>
-                          <a:latin typeface="Arial"/>
-                        </a:rPr>
-                        <a:t>2–3 µm (paper)</a:t>
-                      </a:r>
-                    </a:p>
-                  </a:txBody>
-                  <a:tcPr marL="54864" marR="54864" marT="18288" marB="18288">
-                    <a:solidFill>
-                      <a:srgbClr val="ECF1F6"/>
-                    </a:solidFill>
-                  </a:tcPr>
-                </a:tc>
-                <a:tc>
-                  <a:txBody>
-                    <a:bodyPr wrap="square"/>
-                    <a:lstStyle/>
-                    <a:p>
-                      <a:r>
-                        <a:rPr sz="1100" b="0">
-                          <a:solidFill>
-                            <a:srgbClr val="282828"/>
-                          </a:solidFill>
-                          <a:latin typeface="Arial"/>
-                        </a:rPr>
-                        <a:t>–</a:t>
-                      </a:r>
-                    </a:p>
-                  </a:txBody>
-                  <a:tcPr marL="54864" marR="54864" marT="18288" marB="18288">
-                    <a:solidFill>
-                      <a:srgbClr val="ECF1F6"/>
-                    </a:solidFill>
-                  </a:tcPr>
-                </a:tc>
-                <a:tc>
-                  <a:txBody>
-                    <a:bodyPr wrap="square"/>
-                    <a:lstStyle/>
-                    <a:p>
-                      <a:r>
-                        <a:rPr sz="1100" b="0">
-                          <a:solidFill>
-                            <a:srgbClr val="282828"/>
-                          </a:solidFill>
-                          <a:latin typeface="Arial"/>
-                        </a:rPr>
-                        <a:t>1.8–2.5 µm</a:t>
-                      </a:r>
-                    </a:p>
-                  </a:txBody>
-                  <a:tcPr marL="54864" marR="54864" marT="18288" marB="18288">
-                    <a:solidFill>
-                      <a:srgbClr val="ECF1F6"/>
-                    </a:solidFill>
-                  </a:tcPr>
-                </a:tc>
-                <a:tc>
-                  <a:txBody>
-                    <a:bodyPr wrap="square"/>
-                    <a:lstStyle/>
-                    <a:p>
-                      <a:r>
-                        <a:rPr sz="1100" b="0">
-                          <a:solidFill>
-                            <a:srgbClr val="282828"/>
-                          </a:solidFill>
-                          <a:latin typeface="Arial"/>
-                        </a:rPr>
-                        <a:t>–</a:t>
-                      </a:r>
-                    </a:p>
-                  </a:txBody>
-                  <a:tcPr marL="54864" marR="54864" marT="18288" marB="18288">
-                    <a:solidFill>
-                      <a:srgbClr val="ECF1F6"/>
-                    </a:solidFill>
-                  </a:tcPr>
-                </a:tc>
-              </a:tr>
-              <a:tr h="280035">
-                <a:tc>
-                  <a:txBody>
-                    <a:bodyPr wrap="square"/>
-                    <a:lstStyle/>
-                    <a:p>
-                      <a:r>
-                        <a:rPr sz="1100" b="0">
-                          <a:solidFill>
-                            <a:srgbClr val="282828"/>
-                          </a:solidFill>
-                          <a:latin typeface="Arial"/>
-                        </a:rPr>
-                        <a:t>plate scale</a:t>
-                      </a:r>
-                    </a:p>
-                  </a:txBody>
-                  <a:tcPr marL="54864" marR="54864" marT="18288" marB="18288">
-                    <a:solidFill>
-                      <a:srgbClr val="FFFFFF"/>
-                    </a:solidFill>
-                  </a:tcPr>
-                </a:tc>
-                <a:tc>
-                  <a:txBody>
-                    <a:bodyPr wrap="square"/>
-                    <a:lstStyle/>
-                    <a:p>
-                      <a:r>
-                        <a:rPr sz="1100" b="0">
-                          <a:solidFill>
-                            <a:srgbClr val="282828"/>
-                          </a:solidFill>
-                          <a:latin typeface="Arial"/>
-                        </a:rPr>
-                        <a:t>330 mm</a:t>
-                      </a:r>
-                    </a:p>
-                  </a:txBody>
-                  <a:tcPr marL="54864" marR="54864" marT="18288" marB="18288">
-                    <a:solidFill>
-                      <a:srgbClr val="FFFFFF"/>
-                    </a:solidFill>
-                  </a:tcPr>
-                </a:tc>
-                <a:tc>
-                  <a:txBody>
-                    <a:bodyPr wrap="square"/>
-                    <a:lstStyle/>
-                    <a:p>
-                      <a:r>
-                        <a:rPr sz="1100" b="0">
-                          <a:solidFill>
-                            <a:srgbClr val="282828"/>
-                          </a:solidFill>
-                          <a:latin typeface="Arial"/>
-                        </a:rPr>
-                        <a:t>345</a:t>
-                      </a:r>
-                    </a:p>
-                  </a:txBody>
-                  <a:tcPr marL="54864" marR="54864" marT="18288" marB="18288">
-                    <a:solidFill>
-                      <a:srgbClr val="FFFFFF"/>
-                    </a:solidFill>
-                  </a:tcPr>
-                </a:tc>
-                <a:tc>
-                  <a:txBody>
-                    <a:bodyPr wrap="square"/>
-                    <a:lstStyle/>
-                    <a:p>
-                      <a:r>
-                        <a:rPr sz="1100" b="0">
-                          <a:solidFill>
-                            <a:srgbClr val="282828"/>
-                          </a:solidFill>
-                          <a:latin typeface="Arial"/>
-                        </a:rPr>
-                        <a:t>–</a:t>
-                      </a:r>
-                    </a:p>
-                  </a:txBody>
-                  <a:tcPr marL="54864" marR="54864" marT="18288" marB="18288">
-                    <a:solidFill>
-                      <a:srgbClr val="FFFFFF"/>
-                    </a:solidFill>
-                  </a:tcPr>
-                </a:tc>
-                <a:tc>
-                  <a:txBody>
-                    <a:bodyPr wrap="square"/>
-                    <a:lstStyle/>
-                    <a:p>
-                      <a:r>
-                        <a:rPr sz="1100" b="0">
-                          <a:solidFill>
-                            <a:srgbClr val="282828"/>
-                          </a:solidFill>
-                          <a:latin typeface="Arial"/>
-                        </a:rPr>
-                        <a:t>329.9 / 330.1 mm</a:t>
-                      </a:r>
-                    </a:p>
-                  </a:txBody>
-                  <a:tcPr marL="54864" marR="54864" marT="18288" marB="18288">
-                    <a:solidFill>
-                      <a:srgbClr val="FFFFFF"/>
-                    </a:solidFill>
-                  </a:tcPr>
-                </a:tc>
-                <a:tc>
-                  <a:txBody>
-                    <a:bodyPr wrap="square"/>
-                    <a:lstStyle/>
-                    <a:p>
-                      <a:r>
-                        <a:rPr sz="1100" b="0">
-                          <a:solidFill>
-                            <a:srgbClr val="282828"/>
-                          </a:solidFill>
-                          <a:latin typeface="Arial"/>
-                        </a:rPr>
-                        <a:t>330.1 mm</a:t>
-                      </a:r>
-                    </a:p>
-                  </a:txBody>
-                  <a:tcPr marL="54864" marR="54864" marT="18288" marB="18288">
-                    <a:solidFill>
-                      <a:srgbClr val="FFFFFF"/>
-                    </a:solidFill>
-                  </a:tcPr>
-                </a:tc>
-              </a:tr>
-              <a:tr h="468630">
-                <a:tc>
-                  <a:txBody>
-                    <a:bodyPr wrap="square"/>
-                    <a:lstStyle/>
-                    <a:p>
-                      <a:r>
-                        <a:rPr sz="1100" b="0">
-                          <a:solidFill>
-                            <a:srgbClr val="282828"/>
-                          </a:solidFill>
-                          <a:latin typeface="Arial"/>
-                        </a:rPr>
-                        <a:t>chief rays at the slit</a:t>
-                      </a:r>
-                    </a:p>
-                  </a:txBody>
-                  <a:tcPr marL="54864" marR="54864" marT="18288" marB="18288">
-                    <a:solidFill>
-                      <a:srgbClr val="ECF1F6"/>
-                    </a:solidFill>
-                  </a:tcPr>
-                </a:tc>
-                <a:tc>
-                  <a:txBody>
-                    <a:bodyPr wrap="square"/>
-                    <a:lstStyle/>
-                    <a:p>
-                      <a:r>
-                        <a:rPr sz="1100" b="0">
-                          <a:solidFill>
-                            <a:srgbClr val="282828"/>
-                          </a:solidFill>
-                          <a:latin typeface="Arial"/>
-                        </a:rPr>
-                        <a:t>telecentric</a:t>
-                      </a:r>
-                    </a:p>
-                  </a:txBody>
-                  <a:tcPr marL="54864" marR="54864" marT="18288" marB="18288">
-                    <a:solidFill>
-                      <a:srgbClr val="ECF1F6"/>
-                    </a:solidFill>
-                  </a:tcPr>
-                </a:tc>
-                <a:tc>
-                  <a:txBody>
-                    <a:bodyPr wrap="square"/>
-                    <a:lstStyle/>
-                    <a:p>
-                      <a:r>
-                        <a:rPr sz="1100" b="0">
-                          <a:solidFill>
-                            <a:srgbClr val="282828"/>
-                          </a:solidFill>
-                          <a:latin typeface="Arial"/>
-                        </a:rPr>
-                        <a:t>telecentric</a:t>
-                      </a:r>
-                    </a:p>
-                  </a:txBody>
-                  <a:tcPr marL="54864" marR="54864" marT="18288" marB="18288">
-                    <a:solidFill>
-                      <a:srgbClr val="ECF1F6"/>
-                    </a:solidFill>
-                  </a:tcPr>
-                </a:tc>
-                <a:tc>
-                  <a:txBody>
-                    <a:bodyPr wrap="square"/>
-                    <a:lstStyle/>
-                    <a:p>
-                      <a:r>
-                        <a:rPr sz="1100" b="0">
-                          <a:solidFill>
-                            <a:srgbClr val="282828"/>
-                          </a:solidFill>
-                          <a:latin typeface="Arial"/>
-                        </a:rPr>
-                        <a:t>–</a:t>
-                      </a:r>
-                    </a:p>
-                  </a:txBody>
-                  <a:tcPr marL="54864" marR="54864" marT="18288" marB="18288">
-                    <a:solidFill>
-                      <a:srgbClr val="ECF1F6"/>
-                    </a:solidFill>
-                  </a:tcPr>
-                </a:tc>
-                <a:tc>
-                  <a:txBody>
-                    <a:bodyPr wrap="square"/>
-                    <a:lstStyle/>
-                    <a:p>
-                      <a:r>
-                        <a:rPr sz="1100" b="0">
-                          <a:solidFill>
-                            <a:srgbClr val="282828"/>
-                          </a:solidFill>
-                          <a:latin typeface="Arial"/>
-                        </a:rPr>
-                        <a:t>within 0.033°</a:t>
-                      </a:r>
-                    </a:p>
-                  </a:txBody>
-                  <a:tcPr marL="54864" marR="54864" marT="18288" marB="18288">
-                    <a:solidFill>
-                      <a:srgbClr val="ECF1F6"/>
-                    </a:solidFill>
-                  </a:tcPr>
-                </a:tc>
-                <a:tc>
-                  <a:txBody>
-                    <a:bodyPr wrap="square"/>
-                    <a:lstStyle/>
-                    <a:p>
-                      <a:r>
-                        <a:rPr sz="1100" b="0">
-                          <a:solidFill>
-                            <a:srgbClr val="282828"/>
-                          </a:solidFill>
-                          <a:latin typeface="Arial"/>
-                        </a:rPr>
-                        <a:t>–</a:t>
-                      </a:r>
-                    </a:p>
-                  </a:txBody>
-                  <a:tcPr marL="54864" marR="54864" marT="18288" marB="18288">
-                    <a:solidFill>
-                      <a:srgbClr val="ECF1F6"/>
-                    </a:solidFill>
-                  </a:tcPr>
-                </a:tc>
-              </a:tr>
-              <a:tr h="468630">
-                <a:tc>
-                  <a:txBody>
-                    <a:bodyPr wrap="square"/>
-                    <a:lstStyle/>
-                    <a:p>
-                      <a:r>
-                        <a:rPr sz="1100" b="0">
-                          <a:solidFill>
-                            <a:srgbClr val="282828"/>
-                          </a:solidFill>
-                          <a:latin typeface="Arial"/>
-                        </a:rPr>
-                        <a:t>marginal rays at the slit</a:t>
-                      </a:r>
-                    </a:p>
-                  </a:txBody>
-                  <a:tcPr marL="54864" marR="54864" marT="18288" marB="18288">
-                    <a:solidFill>
-                      <a:srgbClr val="FFFFFF"/>
-                    </a:solidFill>
-                  </a:tcPr>
-                </a:tc>
-                <a:tc>
-                  <a:txBody>
-                    <a:bodyPr wrap="square"/>
-                    <a:lstStyle/>
-                    <a:p>
-                      <a:r>
-                        <a:rPr sz="1100" b="0">
-                          <a:solidFill>
-                            <a:srgbClr val="282828"/>
-                          </a:solidFill>
-                          <a:latin typeface="Arial"/>
-                        </a:rPr>
-                        <a:t>–</a:t>
-                      </a:r>
-                    </a:p>
-                  </a:txBody>
-                  <a:tcPr marL="54864" marR="54864" marT="18288" marB="18288">
-                    <a:solidFill>
-                      <a:srgbClr val="FFFFFF"/>
-                    </a:solidFill>
-                  </a:tcPr>
-                </a:tc>
-                <a:tc>
-                  <a:txBody>
-                    <a:bodyPr wrap="square"/>
-                    <a:lstStyle/>
-                    <a:p>
-                      <a:r>
-                        <a:rPr sz="1100" b="0">
-                          <a:solidFill>
-                            <a:srgbClr val="282828"/>
-                          </a:solidFill>
-                          <a:latin typeface="Arial"/>
-                        </a:rPr>
-                        <a:t>F/# anamorphicity bounded</a:t>
-                      </a:r>
-                    </a:p>
-                  </a:txBody>
-                  <a:tcPr marL="54864" marR="54864" marT="18288" marB="18288">
-                    <a:solidFill>
-                      <a:srgbClr val="FFFFFF"/>
-                    </a:solidFill>
-                  </a:tcPr>
-                </a:tc>
-                <a:tc>
-                  <a:txBody>
-                    <a:bodyPr wrap="square"/>
-                    <a:lstStyle/>
-                    <a:p>
-                      <a:r>
-                        <a:rPr sz="1100" b="0">
-                          <a:solidFill>
-                            <a:srgbClr val="282828"/>
-                          </a:solidFill>
-                          <a:latin typeface="Arial"/>
-                        </a:rPr>
-                        <a:t>–</a:t>
-                      </a:r>
-                    </a:p>
-                  </a:txBody>
-                  <a:tcPr marL="54864" marR="54864" marT="18288" marB="18288">
-                    <a:solidFill>
-                      <a:srgbClr val="FFFFFF"/>
-                    </a:solidFill>
-                  </a:tcPr>
-                </a:tc>
-                <a:tc>
-                  <a:txBody>
-                    <a:bodyPr wrap="square"/>
-                    <a:lstStyle/>
-                    <a:p>
-                      <a:r>
-                        <a:rPr sz="1100" b="0">
-                          <a:solidFill>
-                            <a:srgbClr val="282828"/>
-                          </a:solidFill>
-                          <a:latin typeface="Arial"/>
-                        </a:rPr>
-                        <a:t>F/1.80–1.89, none below 1.7</a:t>
-                      </a:r>
-                    </a:p>
-                  </a:txBody>
-                  <a:tcPr marL="54864" marR="54864" marT="18288" marB="18288">
-                    <a:solidFill>
-                      <a:srgbClr val="FFFFFF"/>
-                    </a:solidFill>
-                  </a:tcPr>
-                </a:tc>
-                <a:tc>
-                  <a:txBody>
-                    <a:bodyPr wrap="square"/>
-                    <a:lstStyle/>
-                    <a:p>
-                      <a:r>
-                        <a:rPr sz="1100" b="0">
-                          <a:solidFill>
-                            <a:srgbClr val="282828"/>
-                          </a:solidFill>
-                          <a:latin typeface="Arial"/>
-                        </a:rPr>
-                        <a:t>grating admits 98.9 %</a:t>
-                      </a:r>
-                    </a:p>
-                  </a:txBody>
-                  <a:tcPr marL="54864" marR="54864" marT="18288" marB="18288">
-                    <a:solidFill>
-                      <a:srgbClr val="FFFFFF"/>
-                    </a:solidFill>
-                  </a:tcPr>
-                </a:tc>
-              </a:tr>
-              <a:tr h="280035">
                 <a:tc>
                   <a:txBody>
                     <a:bodyPr wrap="square"/>
@@ -16287,7 +16287,7 @@
         </p:nvSpPr>
         <p:spPr>
           <a:xfrm>
-            <a:off x="411480" y="6125337"/>
+            <a:off x="411480" y="5748147"/>
             <a:ext cx="11368735" cy="274320"/>
           </a:xfrm>
           <a:prstGeom prst="rect">
@@ -16313,7 +16313,7 @@
                 </a:solidFill>
                 <a:latin typeface="Arial"/>
               </a:rPr>
-              <a:t>Spectrometer: dyson5_jim_3a.txt (size:F:240); telescope: dyson5_cprime_3k.in, REPORT_dyson5_cprime.md; together: dyson5_t5f_cprime_centroid_roll000.txt / _roll180, _chief_roll000 (the point-source shift), 7 fields × 7 wavelengths.  No coatings, no tolerances in any column.  SRF 2.025 against a 2.000 floor: the Dyson adds 0.45 µm.</a:t>
+              <a:t>Spectrometer: dyson5_jim_3a.txt (size:F:240); telescope: dyson5_cprime_3k.in, REPORT_dyson5_cprime.md; together: dyson5_t5f_cprime_centroid_roll000.txt / _roll180, _chief_roll000 (the point-source shift), 7 fields × 7 wavelengths.  No coatings, no tolerances in any column.  SRF 2.025 against a floor of 2.010–2.023 (slit, pixel, diffraction): the Dyson adds at most 0.0015 px, 0.03 µm.</a:t>
             </a:r>
           </a:p>
         </p:txBody>

</xml_diff>

<commit_message>
deck_dyson_3k: the spectrometer slide rewritten on TO's steps 1-2 -- the Dyson of record IS the paper's Option A (aspheric lens, spherical grating); the 21-row tolerance ladder (focus terms refocus-compensable; keystone sets 26 um / 35 urad / 88 urad for the paper's CBE, 47 / 47 / 64 / 162 for Joe; thermal terms); Option B (grating conic) CRF 1.21 -> 1.03, EiP 0.82 -> 0.99 alone, e2e 1.06 / 0.955 -- nominal margin, not insensitivity; a backup slide with the ladder's numbers; questions and next steps updated
Co-Authored-By: Claude Fable 5.1 <noreply@anthropic.com>
</commit_message>
<xml_diff>
--- a/demo_session/deck_dyson_3k.pptx
+++ b/demo_session/deck_dyson_3k.pptx
@@ -27,6 +27,7 @@
     <p:sldId id="275" r:id="rId26"/>
     <p:sldId id="276" r:id="rId27"/>
     <p:sldId id="277" r:id="rId28"/>
+    <p:sldId id="278" r:id="rId29"/>
   </p:sldIdLst>
   <p:sldSz cx="12191695" cy="6858000" type="screen4x3"/>
   <p:notesSz cx="6858000" cy="9144000"/>
@@ -5108,7 +5109,7 @@
                 </a:solidFill>
                 <a:latin typeface="Arial"/>
               </a:rPr>
-              <a:t>The spectrometer: at the slit floor; what is left</a:t>
+              <a:t>The spectrometer: toleranced, and a conic grating for margin</a:t>
             </a:r>
           </a:p>
           <a:p>
@@ -5124,7 +5125,7 @@
                 </a:solidFill>
                 <a:latin typeface="Arial"/>
               </a:rPr>
-              <a:t>SRF 2.025 px is the two-pixel slit with the pixel and diffraction (2.010–2.023) plus at most 0.03 µm of blur, and in the paper's units it is 36.5 µm against 64.8; the open spectrometer work is tolerances, the aspheric-lens form, and throughput by band</a:t>
+              <a:t>SRF sits at the two-pixel slit's floor; every large tolerance is a focus term the detector's focus removes; keystone sets the alignment tolerances at 26 µm and 35 µrad; a conic on the grating takes the energy in a pixel from 0.82 to 0.99</a:t>
             </a:r>
           </a:p>
         </p:txBody>
@@ -5225,7 +5226,7 @@
                 </a:solidFill>
                 <a:latin typeface="Arial"/>
               </a:rPr>
-              <a:t>  The scorer's SRF is slit ⊗ LSF ⊗ pixel ⊗ Airy; with a 2-pixel slit a perfect spectrometer gives 2.010 px at 380 nm and 2.023 at 2500 nm — the slit, the pixel and diffraction.  The Dyson of record sits 0.0001–0.0015 px above that floor at every wavelength, alone and behind the telescope: at most 0.03 µm of blur.  Joe's "1.5–2.0" is met at its floor; 1.5 would need a narrower slit, not a better spectrometer.  In the paper's co-added pixels our SRF is 1.01 against its 1.33 design and 1.8 requirement; our CRF 21 µm against its 50.</a:t>
+              <a:t>  Slit ⊗ LSF ⊗ pixel ⊗ Airy for a perfect spectrometer is 2.010 px at 380 nm and 2.023 at 2500 nm; the Dyson of record sits 0.0001–0.0015 px above that at every wavelength, alone and behind the telescope.  In the paper's units 36.5 µm against 64.8.  Joe's "1.5–2.0" is met at its floor; 1.5 would need a narrower slit.</a:t>
             </a:r>
           </a:p>
           <a:p>
@@ -5250,7 +5251,7 @@
                 </a:solidFill>
                 <a:latin typeface="Arial"/>
               </a:rPr>
-              <a:t>The spectrometer of record for 3k</a:t>
+              <a:t>The Dyson of record is the paper's Option A:</a:t>
             </a:r>
             <a:r>
               <a:rPr sz="1200" b="0">
@@ -5259,7 +5260,7 @@
                 </a:solidFill>
                 <a:latin typeface="Arial"/>
               </a:rPr>
-              <a:t> stands: 240 mm </a:t>
+              <a:t> 240 mm </a:t>
             </a:r>
             <a:r>
               <a:rPr sz="1200" b="0">
@@ -5286,7 +5287,41 @@
                 </a:solidFill>
                 <a:latin typeface="Arial"/>
               </a:rPr>
-              <a:t>, spherical lens face and spherical grating, no meniscus; smile 0.005, keystone 0.006, CRF 1.21, 0.82 of the energy in a pixel; 4.5 L, 14.3 kg; the slit's package clears the block face by 0.54 mm.</a:t>
+              <a:t>, an aspheric lens (K 0.043 with h⁴, h⁶) and a spherical grating, no meniscus; smile 0.005, keystone 0.006, CRF 1.21, 0.82 of the energy in a pixel; 4.5 L, 14.3 kg.</a:t>
+            </a:r>
+          </a:p>
+          <a:p>
+            <a:pPr>
+              <a:spcAft>
+                <a:spcPts val="600"/>
+              </a:spcAft>
+            </a:pPr>
+            <a:r>
+              <a:rPr sz="1200" b="0">
+                <a:solidFill>
+                  <a:srgbClr val="282828"/>
+                </a:solidFill>
+                <a:latin typeface="Arial"/>
+              </a:rPr>
+              <a:t>•  </a:t>
+            </a:r>
+            <a:r>
+              <a:rPr sz="1200" b="1">
+                <a:solidFill>
+                  <a:srgbClr val="282828"/>
+                </a:solidFill>
+                <a:latin typeface="Arial"/>
+              </a:rPr>
+              <a:t>Toleranced, 21 rows, alone and through the join:</a:t>
+            </a:r>
+            <a:r>
+              <a:rPr sz="1200" b="0">
+                <a:solidFill>
+                  <a:srgbClr val="282828"/>
+                </a:solidFill>
+                <a:latin typeface="Arial"/>
+              </a:rPr>
+              <a:t> every large sensitivity is a focus term — lens radius and thickness, the air space, slit and detector defocus, grating radius (the strongest: dR/R 10⁻⁴ costs CRF +1.9 px uncompensated, and a 76 µm detector refocus removes it to 0.006).  One-axis detector focus is the compensator; x/y adds nothing.  Smile is loose (≥ 300 µm or µrad).</a:t>
             </a:r>
           </a:p>
         </p:txBody>
@@ -5334,7 +5369,7 @@
                 </a:solidFill>
                 <a:latin typeface="Arial"/>
               </a:rPr>
-              <a:t>Tolerances, first.</a:t>
+              <a:t>Keystone sets the tolerances, and no compensator helps</a:t>
             </a:r>
             <a:r>
               <a:rPr sz="1200" b="0">
@@ -5343,7 +5378,7 @@
                 </a:solidFill>
                 <a:latin typeface="Arial"/>
               </a:rPr>
-              <a:t>  Nothing on either module is toleranced, and the paper chose both its forms for tolerance insensitivity (its spherical-grating option lost on exactly that: smile 0.3 % designed, 3.5 % as built).  Next: a sensitivity ladder on both Dysons — lens and grating decenter, tilt, radius, index (the thermal soak), grating period and clocking, slit and detector position — scored alone and through the join with R9, each with its compensator, summed to a budget against the paper's as-built margins.</a:t>
+              <a:t> (it is lateral color).  For the paper's as-built keystone (1.03 µm = 0.057 px): lens and grating decenter along the slit 26 µm, grating tilt 35 µrad, clocking 88 µrad; for Joe's 0.1 px: 47 µm, 47 µm, 64 µrad, 162 µrad.  The 1.5k Dyson is twice as sensitive (13 µm).  Linear where it matters (keystone vs decenter 1.10; CRF vs grating radius 1.03).</a:t>
             </a:r>
           </a:p>
           <a:p>
@@ -5368,7 +5403,7 @@
                 </a:solidFill>
                 <a:latin typeface="Arial"/>
               </a:rPr>
-              <a:t>Then the paper's form for margin:</a:t>
+              <a:t>Thermal:</a:t>
             </a:r>
             <a:r>
               <a:rPr sz="1200" b="0">
@@ -5377,7 +5412,7 @@
                 </a:solidFill>
                 <a:latin typeface="Arial"/>
               </a:rPr>
-              <a:t> an aspheric </a:t>
+              <a:t> 1 K of </a:t>
             </a:r>
             <a:r>
               <a:rPr sz="1200" b="0">
@@ -5404,7 +5439,34 @@
                 </a:solidFill>
                 <a:latin typeface="Arial"/>
               </a:rPr>
-              <a:t> lens with a conic grating (their Option B) on our 3k geometry, nominal and its own ladder — the claim to test is insensitivity, not nominal performance.</a:t>
+              <a:t> index is negligible (CRF +0.001); </a:t>
+            </a:r>
+            <a:r>
+              <a:rPr sz="1200" b="0">
+                <a:solidFill>
+                  <a:srgbClr val="282828"/>
+                </a:solidFill>
+                <a:latin typeface="Arial"/>
+              </a:rPr>
+              <a:t>CaF</a:t>
+            </a:r>
+            <a:r>
+              <a:rPr sz="1200" b="0" baseline="-25000">
+                <a:solidFill>
+                  <a:srgbClr val="282828"/>
+                </a:solidFill>
+                <a:latin typeface="Arial"/>
+              </a:rPr>
+              <a:t>2</a:t>
+            </a:r>
+            <a:r>
+              <a:rPr sz="1200" b="0">
+                <a:solidFill>
+                  <a:srgbClr val="282828"/>
+                </a:solidFill>
+                <a:latin typeface="Arial"/>
+              </a:rPr>
+              <a:t>'s radius and thickness terms cancel (+0.050 / −0.051 px per K); the open terms are the aluminum air space (−0.22 px per K) and the N-BK7 grating radius (+0.14) — focus terms, refocus-compensable, which is the paper's "CRF limits the spectrometer's temperature requirements."</a:t>
             </a:r>
           </a:p>
           <a:p>
@@ -5429,7 +5491,7 @@
                 </a:solidFill>
                 <a:latin typeface="Arial"/>
               </a:rPr>
-              <a:t>Throughput by band:</a:t>
+              <a:t>Option B — a conic on the grating (K −0.004) with the lens re-solved:</a:t>
             </a:r>
             <a:r>
               <a:rPr sz="1200" b="0">
@@ -5438,7 +5500,25 @@
                 </a:solidFill>
                 <a:latin typeface="Arial"/>
               </a:rPr>
-              <a:t> six crossings uncoated (0.81), a single- and a two-layer AR optimized for 2.0–2.5 µm, the blaze; per band, both modules.</a:t>
+              <a:t> alone CRF 1.03 (1.21), energy in a pixel 0.99 (0.82), keystone 0.002 (0.006); behind R9: CRF 1.06, energy 0.955, smile 0.012; SRF the floor in both.  Its keystone sensitivities are 6–45 % higher than A's (clocking most): </a:t>
+            </a:r>
+            <a:r>
+              <a:rPr sz="1200" b="1">
+                <a:solidFill>
+                  <a:srgbClr val="282828"/>
+                </a:solidFill>
+                <a:latin typeface="Arial"/>
+              </a:rPr>
+              <a:t>it buys nominal margin, not alignment insensitivity</a:t>
+            </a:r>
+            <a:r>
+              <a:rPr sz="1200" b="0">
+                <a:solidFill>
+                  <a:srgbClr val="282828"/>
+                </a:solidFill>
+                <a:latin typeface="Arial"/>
+              </a:rPr>
+              <a:t> — the paper's preference for B on tolerances is not reproduced by alignment alone (its as-built numbers include fabrication and thermal, not modeled here).  Recommended as the spectrometer candidate for its margin.</a:t>
             </a:r>
           </a:p>
         </p:txBody>
@@ -5451,7 +5531,7 @@
         </p:nvSpPr>
         <p:spPr>
           <a:xfrm>
-            <a:off x="6400800" y="4529328"/>
+            <a:off x="6400800" y="5519928"/>
             <a:ext cx="5394960" cy="274320"/>
           </a:xfrm>
           <a:prstGeom prst="rect">
@@ -5477,7 +5557,7 @@
                 </a:solidFill>
                 <a:latin typeface="Arial"/>
               </a:rPr>
-              <a:t>BRIEF_to_dyson5.md addendum 49 (in progress).  Energy in a pixel 0.82 alone is the one spectrometer number with room; the paper's Option B is where it would come from.</a:t>
+              <a:t>REPORT_dyson5_spec.md (the ladder, 3k and 1.5k, Option B and its ladder); spectrometer_sens, gate tSpectrometerSens.  The compensator residuals are given for detector focus alone and focus + x/y.  A full every-CTE soak is the next row.  Throughput by band follows.</a:t>
             </a:r>
           </a:p>
         </p:txBody>
@@ -6762,34 +6842,7 @@
                 </a:solidFill>
                 <a:latin typeface="Arial"/>
               </a:rPr>
-              <a:t>  The spherical-faced </a:t>
-            </a:r>
-            <a:r>
-              <a:rPr sz="1500" b="0">
-                <a:solidFill>
-                  <a:srgbClr val="282828"/>
-                </a:solidFill>
-                <a:latin typeface="Arial"/>
-              </a:rPr>
-              <a:t>CaF</a:t>
-            </a:r>
-            <a:r>
-              <a:rPr sz="1500" b="0" baseline="-25000">
-                <a:solidFill>
-                  <a:srgbClr val="282828"/>
-                </a:solidFill>
-                <a:latin typeface="Arial"/>
-              </a:rPr>
-              <a:t>2</a:t>
-            </a:r>
-            <a:r>
-              <a:rPr sz="1500" b="0">
-                <a:solidFill>
-                  <a:srgbClr val="282828"/>
-                </a:solidFill>
-                <a:latin typeface="Arial"/>
-              </a:rPr>
-              <a:t> Dyson meets the specification at nominal.  The paper went to an aspheric lens and a conic grating for tolerances; before we build that ladder, what drove it in the build — smile and keystone as built, or energy in a pixel?</a:t>
+              <a:t>  Our Dyson of record is the paper's Option A and meets the specification; its Option B (the conic grating) buys energy in a pixel 0.82 → 0.99 here but not alignment insensitivity.  What drove B in the build — fabrication, thermal, or the margin?</a:t>
             </a:r>
           </a:p>
         </p:txBody>
@@ -6993,7 +7046,7 @@
                 </a:solidFill>
                 <a:latin typeface="Arial"/>
               </a:rPr>
-              <a:t>Spectrometer (in progress):</a:t>
+              <a:t>Spectrometer:</a:t>
             </a:r>
             <a:r>
               <a:rPr sz="1200" b="0">
@@ -7002,7 +7055,7 @@
                 </a:solidFill>
                 <a:latin typeface="Arial"/>
               </a:rPr>
-              <a:t> the sensitivity ladder on both Dysons with compensators, alone and through the join; the aspheric-lens + conic-grating form and its ladder; throughput by band with the blaze.</a:t>
+              <a:t> the every-CTE thermal soak row; fabrication terms (figure, the grating's period and groove errors) in the ladder; throughput by band with the blaze; Option B as the candidate, its keystone tolerances (25 µm, 33 µrad) stated beside its margin.</a:t>
             </a:r>
           </a:p>
           <a:p>
@@ -9862,7 +9915,7 @@
                 </a:solidFill>
                 <a:latin typeface="Arial"/>
               </a:rPr>
-              <a:t> The spectrometer: at the slit floor; what is left</a:t>
+              <a:t> The spectrometer: toleranced, and a conic grating for margin</a:t>
             </a:r>
           </a:p>
           <a:p>
@@ -10032,7 +10085,7 @@
                 </a:solidFill>
                 <a:latin typeface="Arial"/>
               </a:rPr>
-              <a:t> Backup: the first order by the numbers; the rungs per field; the chief-tilt diagnostic; the engine finding; records</a:t>
+              <a:t> Backup: the first order by the numbers; the rungs per field; the chief-tilt diagnostic; the tolerance ladder by the numbers; the engine finding; records</a:t>
             </a:r>
           </a:p>
         </p:txBody>
@@ -10404,7 +10457,7 @@
                 </a:solidFill>
                 <a:latin typeface="Arial"/>
               </a:rPr>
-              <a:t>An engine finding from this round</a:t>
+              <a:t>The tolerance ladder by the numbers</a:t>
             </a:r>
           </a:p>
           <a:p>
@@ -10420,7 +10473,7 @@
                 </a:solidFill>
                 <a:latin typeface="Arial"/>
               </a:rPr>
-              <a:t>The api refused an element stop on the secondary of a four-element telescope</a:t>
+              <a:t>One perturbation at a time on the 3k Dyson of record, scored alone and through the R9 join; the compensator is the detector's focus</a:t>
             </a:r>
           </a:p>
         </p:txBody>
@@ -10469,15 +10522,1200 @@
           </a:p>
         </p:txBody>
       </p:sp>
+      <p:graphicFrame>
+        <p:nvGraphicFramePr>
+          <p:cNvPr id="4" name="Table 3"/>
+          <p:cNvGraphicFramePr>
+            <a:graphicFrameLocks noGrp="1"/>
+          </p:cNvGraphicFramePr>
+          <p:nvPr/>
+        </p:nvGraphicFramePr>
+        <p:xfrm>
+          <a:off x="411480" y="1298448"/>
+          <a:ext cx="11368735" cy="3366135"/>
+        </p:xfrm>
+        <a:graphic>
+          <a:graphicData uri="http://schemas.openxmlformats.org/drawingml/2006/table">
+            <a:tbl>
+              <a:tblPr firstRow="1" bandRow="1">
+                <a:tableStyleId>{5C22544A-7EE6-4342-B048-85BDC9FD1C3A}</a:tableStyleId>
+              </a:tblPr>
+              <a:tblGrid>
+                <a:gridCol w="3104034"/>
+                <a:gridCol w="1817116"/>
+                <a:gridCol w="2035048"/>
+                <a:gridCol w="1090676"/>
+                <a:gridCol w="3321861"/>
+              </a:tblGrid>
+              <a:tr h="468630">
+                <a:tc>
+                  <a:txBody>
+                    <a:bodyPr wrap="square"/>
+                    <a:lstStyle/>
+                    <a:p>
+                      <a:r>
+                        <a:rPr sz="1100" b="1">
+                          <a:solidFill>
+                            <a:srgbClr val="FFFFFF"/>
+                          </a:solidFill>
+                          <a:latin typeface="Arial"/>
+                        </a:rPr>
+                        <a:t>perturbation (unit)</a:t>
+                      </a:r>
+                    </a:p>
+                  </a:txBody>
+                  <a:tcPr marL="54864" marR="54864" marT="18288" marB="18288">
+                    <a:solidFill>
+                      <a:srgbClr val="1F4E79"/>
+                    </a:solidFill>
+                  </a:tcPr>
+                </a:tc>
+                <a:tc>
+                  <a:txBody>
+                    <a:bodyPr wrap="square"/>
+                    <a:lstStyle/>
+                    <a:p>
+                      <a:r>
+                        <a:rPr sz="1100" b="1">
+                          <a:solidFill>
+                            <a:srgbClr val="FFFFFF"/>
+                          </a:solidFill>
+                          <a:latin typeface="Arial"/>
+                        </a:rPr>
+                        <a:t>CRF, uncompensated (px)</a:t>
+                      </a:r>
+                    </a:p>
+                  </a:txBody>
+                  <a:tcPr marL="54864" marR="54864" marT="18288" marB="18288">
+                    <a:solidFill>
+                      <a:srgbClr val="1F4E79"/>
+                    </a:solidFill>
+                  </a:tcPr>
+                </a:tc>
+                <a:tc>
+                  <a:txBody>
+                    <a:bodyPr wrap="square"/>
+                    <a:lstStyle/>
+                    <a:p>
+                      <a:r>
+                        <a:rPr sz="1100" b="1">
+                          <a:solidFill>
+                            <a:srgbClr val="FFFFFF"/>
+                          </a:solidFill>
+                          <a:latin typeface="Arial"/>
+                        </a:rPr>
+                        <a:t>CRF after detector refocus</a:t>
+                      </a:r>
+                    </a:p>
+                  </a:txBody>
+                  <a:tcPr marL="54864" marR="54864" marT="18288" marB="18288">
+                    <a:solidFill>
+                      <a:srgbClr val="1F4E79"/>
+                    </a:solidFill>
+                  </a:tcPr>
+                </a:tc>
+                <a:tc>
+                  <a:txBody>
+                    <a:bodyPr wrap="square"/>
+                    <a:lstStyle/>
+                    <a:p>
+                      <a:r>
+                        <a:rPr sz="1100" b="1">
+                          <a:solidFill>
+                            <a:srgbClr val="FFFFFF"/>
+                          </a:solidFill>
+                          <a:latin typeface="Arial"/>
+                        </a:rPr>
+                        <a:t>keystone (px)</a:t>
+                      </a:r>
+                    </a:p>
+                  </a:txBody>
+                  <a:tcPr marL="54864" marR="54864" marT="18288" marB="18288">
+                    <a:solidFill>
+                      <a:srgbClr val="1F4E79"/>
+                    </a:solidFill>
+                  </a:tcPr>
+                </a:tc>
+                <a:tc>
+                  <a:txBody>
+                    <a:bodyPr wrap="square"/>
+                    <a:lstStyle/>
+                    <a:p>
+                      <a:r>
+                        <a:rPr sz="1100" b="1">
+                          <a:solidFill>
+                            <a:srgbClr val="FFFFFF"/>
+                          </a:solidFill>
+                          <a:latin typeface="Arial"/>
+                        </a:rPr>
+                        <a:t>the tolerance for the paper's keystone CBE / for Joe's 0.1 px</a:t>
+                      </a:r>
+                    </a:p>
+                  </a:txBody>
+                  <a:tcPr marL="54864" marR="54864" marT="18288" marB="18288">
+                    <a:solidFill>
+                      <a:srgbClr val="1F4E79"/>
+                    </a:solidFill>
+                  </a:tcPr>
+                </a:tc>
+              </a:tr>
+              <a:tr h="280035">
+                <a:tc>
+                  <a:txBody>
+                    <a:bodyPr wrap="square"/>
+                    <a:lstStyle/>
+                    <a:p>
+                      <a:r>
+                        <a:rPr sz="1100" b="0">
+                          <a:solidFill>
+                            <a:srgbClr val="282828"/>
+                          </a:solidFill>
+                          <a:latin typeface="Arial"/>
+                        </a:rPr>
+                        <a:t>lens decenter along the slit, 10 µm</a:t>
+                      </a:r>
+                    </a:p>
+                  </a:txBody>
+                  <a:tcPr marL="54864" marR="54864" marT="18288" marB="18288">
+                    <a:solidFill>
+                      <a:srgbClr val="FFFFFF"/>
+                    </a:solidFill>
+                  </a:tcPr>
+                </a:tc>
+                <a:tc>
+                  <a:txBody>
+                    <a:bodyPr wrap="square"/>
+                    <a:lstStyle/>
+                    <a:p>
+                      <a:r>
+                        <a:rPr sz="1100" b="0">
+                          <a:solidFill>
+                            <a:srgbClr val="282828"/>
+                          </a:solidFill>
+                          <a:latin typeface="Arial"/>
+                        </a:rPr>
+                        <a:t>–</a:t>
+                      </a:r>
+                    </a:p>
+                  </a:txBody>
+                  <a:tcPr marL="54864" marR="54864" marT="18288" marB="18288">
+                    <a:solidFill>
+                      <a:srgbClr val="FFFFFF"/>
+                    </a:solidFill>
+                  </a:tcPr>
+                </a:tc>
+                <a:tc>
+                  <a:txBody>
+                    <a:bodyPr wrap="square"/>
+                    <a:lstStyle/>
+                    <a:p>
+                      <a:r>
+                        <a:rPr sz="1100" b="0">
+                          <a:solidFill>
+                            <a:srgbClr val="282828"/>
+                          </a:solidFill>
+                          <a:latin typeface="Arial"/>
+                        </a:rPr>
+                        <a:t>–</a:t>
+                      </a:r>
+                    </a:p>
+                  </a:txBody>
+                  <a:tcPr marL="54864" marR="54864" marT="18288" marB="18288">
+                    <a:solidFill>
+                      <a:srgbClr val="FFFFFF"/>
+                    </a:solidFill>
+                  </a:tcPr>
+                </a:tc>
+                <a:tc>
+                  <a:txBody>
+                    <a:bodyPr wrap="square"/>
+                    <a:lstStyle/>
+                    <a:p>
+                      <a:r>
+                        <a:rPr sz="1100" b="0">
+                          <a:solidFill>
+                            <a:srgbClr val="282828"/>
+                          </a:solidFill>
+                          <a:latin typeface="Arial"/>
+                        </a:rPr>
+                        <a:t>0.0099</a:t>
+                      </a:r>
+                    </a:p>
+                  </a:txBody>
+                  <a:tcPr marL="54864" marR="54864" marT="18288" marB="18288">
+                    <a:solidFill>
+                      <a:srgbClr val="FFFFFF"/>
+                    </a:solidFill>
+                  </a:tcPr>
+                </a:tc>
+                <a:tc>
+                  <a:txBody>
+                    <a:bodyPr wrap="square"/>
+                    <a:lstStyle/>
+                    <a:p>
+                      <a:r>
+                        <a:rPr sz="1100" b="0">
+                          <a:solidFill>
+                            <a:srgbClr val="282828"/>
+                          </a:solidFill>
+                          <a:latin typeface="Arial"/>
+                        </a:rPr>
+                        <a:t>26 µm / 47 µm</a:t>
+                      </a:r>
+                    </a:p>
+                  </a:txBody>
+                  <a:tcPr marL="54864" marR="54864" marT="18288" marB="18288">
+                    <a:solidFill>
+                      <a:srgbClr val="FFFFFF"/>
+                    </a:solidFill>
+                  </a:tcPr>
+                </a:tc>
+              </a:tr>
+              <a:tr h="280035">
+                <a:tc>
+                  <a:txBody>
+                    <a:bodyPr wrap="square"/>
+                    <a:lstStyle/>
+                    <a:p>
+                      <a:r>
+                        <a:rPr sz="1100" b="0">
+                          <a:solidFill>
+                            <a:srgbClr val="282828"/>
+                          </a:solidFill>
+                          <a:latin typeface="Arial"/>
+                        </a:rPr>
+                        <a:t>grating decenter along the slit, 10 µm</a:t>
+                      </a:r>
+                    </a:p>
+                  </a:txBody>
+                  <a:tcPr marL="54864" marR="54864" marT="18288" marB="18288">
+                    <a:solidFill>
+                      <a:srgbClr val="ECF1F6"/>
+                    </a:solidFill>
+                  </a:tcPr>
+                </a:tc>
+                <a:tc>
+                  <a:txBody>
+                    <a:bodyPr wrap="square"/>
+                    <a:lstStyle/>
+                    <a:p>
+                      <a:r>
+                        <a:rPr sz="1100" b="0">
+                          <a:solidFill>
+                            <a:srgbClr val="282828"/>
+                          </a:solidFill>
+                          <a:latin typeface="Arial"/>
+                        </a:rPr>
+                        <a:t>–</a:t>
+                      </a:r>
+                    </a:p>
+                  </a:txBody>
+                  <a:tcPr marL="54864" marR="54864" marT="18288" marB="18288">
+                    <a:solidFill>
+                      <a:srgbClr val="ECF1F6"/>
+                    </a:solidFill>
+                  </a:tcPr>
+                </a:tc>
+                <a:tc>
+                  <a:txBody>
+                    <a:bodyPr wrap="square"/>
+                    <a:lstStyle/>
+                    <a:p>
+                      <a:r>
+                        <a:rPr sz="1100" b="0">
+                          <a:solidFill>
+                            <a:srgbClr val="282828"/>
+                          </a:solidFill>
+                          <a:latin typeface="Arial"/>
+                        </a:rPr>
+                        <a:t>–</a:t>
+                      </a:r>
+                    </a:p>
+                  </a:txBody>
+                  <a:tcPr marL="54864" marR="54864" marT="18288" marB="18288">
+                    <a:solidFill>
+                      <a:srgbClr val="ECF1F6"/>
+                    </a:solidFill>
+                  </a:tcPr>
+                </a:tc>
+                <a:tc>
+                  <a:txBody>
+                    <a:bodyPr wrap="square"/>
+                    <a:lstStyle/>
+                    <a:p>
+                      <a:r>
+                        <a:rPr sz="1100" b="0">
+                          <a:solidFill>
+                            <a:srgbClr val="282828"/>
+                          </a:solidFill>
+                          <a:latin typeface="Arial"/>
+                        </a:rPr>
+                        <a:t>0.0099</a:t>
+                      </a:r>
+                    </a:p>
+                  </a:txBody>
+                  <a:tcPr marL="54864" marR="54864" marT="18288" marB="18288">
+                    <a:solidFill>
+                      <a:srgbClr val="ECF1F6"/>
+                    </a:solidFill>
+                  </a:tcPr>
+                </a:tc>
+                <a:tc>
+                  <a:txBody>
+                    <a:bodyPr wrap="square"/>
+                    <a:lstStyle/>
+                    <a:p>
+                      <a:r>
+                        <a:rPr sz="1100" b="0">
+                          <a:solidFill>
+                            <a:srgbClr val="282828"/>
+                          </a:solidFill>
+                          <a:latin typeface="Arial"/>
+                        </a:rPr>
+                        <a:t>26 µm / 47 µm</a:t>
+                      </a:r>
+                    </a:p>
+                  </a:txBody>
+                  <a:tcPr marL="54864" marR="54864" marT="18288" marB="18288">
+                    <a:solidFill>
+                      <a:srgbClr val="ECF1F6"/>
+                    </a:solidFill>
+                  </a:tcPr>
+                </a:tc>
+              </a:tr>
+              <a:tr h="280035">
+                <a:tc>
+                  <a:txBody>
+                    <a:bodyPr wrap="square"/>
+                    <a:lstStyle/>
+                    <a:p>
+                      <a:r>
+                        <a:rPr sz="1100" b="0">
+                          <a:solidFill>
+                            <a:srgbClr val="282828"/>
+                          </a:solidFill>
+                          <a:latin typeface="Arial"/>
+                        </a:rPr>
+                        <a:t>grating tilt about the slit, 10 µrad</a:t>
+                      </a:r>
+                    </a:p>
+                  </a:txBody>
+                  <a:tcPr marL="54864" marR="54864" marT="18288" marB="18288">
+                    <a:solidFill>
+                      <a:srgbClr val="FFFFFF"/>
+                    </a:solidFill>
+                  </a:tcPr>
+                </a:tc>
+                <a:tc>
+                  <a:txBody>
+                    <a:bodyPr wrap="square"/>
+                    <a:lstStyle/>
+                    <a:p>
+                      <a:r>
+                        <a:rPr sz="1100" b="0">
+                          <a:solidFill>
+                            <a:srgbClr val="282828"/>
+                          </a:solidFill>
+                          <a:latin typeface="Arial"/>
+                        </a:rPr>
+                        <a:t>–</a:t>
+                      </a:r>
+                    </a:p>
+                  </a:txBody>
+                  <a:tcPr marL="54864" marR="54864" marT="18288" marB="18288">
+                    <a:solidFill>
+                      <a:srgbClr val="FFFFFF"/>
+                    </a:solidFill>
+                  </a:tcPr>
+                </a:tc>
+                <a:tc>
+                  <a:txBody>
+                    <a:bodyPr wrap="square"/>
+                    <a:lstStyle/>
+                    <a:p>
+                      <a:r>
+                        <a:rPr sz="1100" b="0">
+                          <a:solidFill>
+                            <a:srgbClr val="282828"/>
+                          </a:solidFill>
+                          <a:latin typeface="Arial"/>
+                        </a:rPr>
+                        <a:t>–</a:t>
+                      </a:r>
+                    </a:p>
+                  </a:txBody>
+                  <a:tcPr marL="54864" marR="54864" marT="18288" marB="18288">
+                    <a:solidFill>
+                      <a:srgbClr val="FFFFFF"/>
+                    </a:solidFill>
+                  </a:tcPr>
+                </a:tc>
+                <a:tc>
+                  <a:txBody>
+                    <a:bodyPr wrap="square"/>
+                    <a:lstStyle/>
+                    <a:p>
+                      <a:r>
+                        <a:rPr sz="1100" b="0">
+                          <a:solidFill>
+                            <a:srgbClr val="282828"/>
+                          </a:solidFill>
+                          <a:latin typeface="Arial"/>
+                        </a:rPr>
+                        <a:t>0.0074</a:t>
+                      </a:r>
+                    </a:p>
+                  </a:txBody>
+                  <a:tcPr marL="54864" marR="54864" marT="18288" marB="18288">
+                    <a:solidFill>
+                      <a:srgbClr val="FFFFFF"/>
+                    </a:solidFill>
+                  </a:tcPr>
+                </a:tc>
+                <a:tc>
+                  <a:txBody>
+                    <a:bodyPr wrap="square"/>
+                    <a:lstStyle/>
+                    <a:p>
+                      <a:r>
+                        <a:rPr sz="1100" b="0">
+                          <a:solidFill>
+                            <a:srgbClr val="282828"/>
+                          </a:solidFill>
+                          <a:latin typeface="Arial"/>
+                        </a:rPr>
+                        <a:t>35 µrad / 64 µrad</a:t>
+                      </a:r>
+                    </a:p>
+                  </a:txBody>
+                  <a:tcPr marL="54864" marR="54864" marT="18288" marB="18288">
+                    <a:solidFill>
+                      <a:srgbClr val="FFFFFF"/>
+                    </a:solidFill>
+                  </a:tcPr>
+                </a:tc>
+              </a:tr>
+              <a:tr h="280035">
+                <a:tc>
+                  <a:txBody>
+                    <a:bodyPr wrap="square"/>
+                    <a:lstStyle/>
+                    <a:p>
+                      <a:r>
+                        <a:rPr sz="1100" b="0">
+                          <a:solidFill>
+                            <a:srgbClr val="282828"/>
+                          </a:solidFill>
+                          <a:latin typeface="Arial"/>
+                        </a:rPr>
+                        <a:t>grating clocking, 10 µrad</a:t>
+                      </a:r>
+                    </a:p>
+                  </a:txBody>
+                  <a:tcPr marL="54864" marR="54864" marT="18288" marB="18288">
+                    <a:solidFill>
+                      <a:srgbClr val="ECF1F6"/>
+                    </a:solidFill>
+                  </a:tcPr>
+                </a:tc>
+                <a:tc>
+                  <a:txBody>
+                    <a:bodyPr wrap="square"/>
+                    <a:lstStyle/>
+                    <a:p>
+                      <a:r>
+                        <a:rPr sz="1100" b="0">
+                          <a:solidFill>
+                            <a:srgbClr val="282828"/>
+                          </a:solidFill>
+                          <a:latin typeface="Arial"/>
+                        </a:rPr>
+                        <a:t>–</a:t>
+                      </a:r>
+                    </a:p>
+                  </a:txBody>
+                  <a:tcPr marL="54864" marR="54864" marT="18288" marB="18288">
+                    <a:solidFill>
+                      <a:srgbClr val="ECF1F6"/>
+                    </a:solidFill>
+                  </a:tcPr>
+                </a:tc>
+                <a:tc>
+                  <a:txBody>
+                    <a:bodyPr wrap="square"/>
+                    <a:lstStyle/>
+                    <a:p>
+                      <a:r>
+                        <a:rPr sz="1100" b="0">
+                          <a:solidFill>
+                            <a:srgbClr val="282828"/>
+                          </a:solidFill>
+                          <a:latin typeface="Arial"/>
+                        </a:rPr>
+                        <a:t>–</a:t>
+                      </a:r>
+                    </a:p>
+                  </a:txBody>
+                  <a:tcPr marL="54864" marR="54864" marT="18288" marB="18288">
+                    <a:solidFill>
+                      <a:srgbClr val="ECF1F6"/>
+                    </a:solidFill>
+                  </a:tcPr>
+                </a:tc>
+                <a:tc>
+                  <a:txBody>
+                    <a:bodyPr wrap="square"/>
+                    <a:lstStyle/>
+                    <a:p>
+                      <a:r>
+                        <a:rPr sz="1100" b="0">
+                          <a:solidFill>
+                            <a:srgbClr val="282828"/>
+                          </a:solidFill>
+                          <a:latin typeface="Arial"/>
+                        </a:rPr>
+                        <a:t>0.0029</a:t>
+                      </a:r>
+                    </a:p>
+                  </a:txBody>
+                  <a:tcPr marL="54864" marR="54864" marT="18288" marB="18288">
+                    <a:solidFill>
+                      <a:srgbClr val="ECF1F6"/>
+                    </a:solidFill>
+                  </a:tcPr>
+                </a:tc>
+                <a:tc>
+                  <a:txBody>
+                    <a:bodyPr wrap="square"/>
+                    <a:lstStyle/>
+                    <a:p>
+                      <a:r>
+                        <a:rPr sz="1100" b="0">
+                          <a:solidFill>
+                            <a:srgbClr val="282828"/>
+                          </a:solidFill>
+                          <a:latin typeface="Arial"/>
+                        </a:rPr>
+                        <a:t>88 µrad / 162 µrad</a:t>
+                      </a:r>
+                    </a:p>
+                  </a:txBody>
+                  <a:tcPr marL="54864" marR="54864" marT="18288" marB="18288">
+                    <a:solidFill>
+                      <a:srgbClr val="ECF1F6"/>
+                    </a:solidFill>
+                  </a:tcPr>
+                </a:tc>
+              </a:tr>
+              <a:tr h="280035">
+                <a:tc>
+                  <a:txBody>
+                    <a:bodyPr wrap="square"/>
+                    <a:lstStyle/>
+                    <a:p>
+                      <a:r>
+                        <a:rPr sz="1100" b="0">
+                          <a:solidFill>
+                            <a:srgbClr val="282828"/>
+                          </a:solidFill>
+                          <a:latin typeface="Arial"/>
+                        </a:rPr>
+                        <a:t>grating radius dR/R 10⁻⁴</a:t>
+                      </a:r>
+                    </a:p>
+                  </a:txBody>
+                  <a:tcPr marL="54864" marR="54864" marT="18288" marB="18288">
+                    <a:solidFill>
+                      <a:srgbClr val="FFFFFF"/>
+                    </a:solidFill>
+                  </a:tcPr>
+                </a:tc>
+                <a:tc>
+                  <a:txBody>
+                    <a:bodyPr wrap="square"/>
+                    <a:lstStyle/>
+                    <a:p>
+                      <a:r>
+                        <a:rPr sz="1100" b="0">
+                          <a:solidFill>
+                            <a:srgbClr val="282828"/>
+                          </a:solidFill>
+                          <a:latin typeface="Arial"/>
+                        </a:rPr>
+                        <a:t>+1.93</a:t>
+                      </a:r>
+                    </a:p>
+                  </a:txBody>
+                  <a:tcPr marL="54864" marR="54864" marT="18288" marB="18288">
+                    <a:solidFill>
+                      <a:srgbClr val="FFFFFF"/>
+                    </a:solidFill>
+                  </a:tcPr>
+                </a:tc>
+                <a:tc>
+                  <a:txBody>
+                    <a:bodyPr wrap="square"/>
+                    <a:lstStyle/>
+                    <a:p>
+                      <a:r>
+                        <a:rPr sz="1100" b="0">
+                          <a:solidFill>
+                            <a:srgbClr val="282828"/>
+                          </a:solidFill>
+                          <a:latin typeface="Arial"/>
+                        </a:rPr>
+                        <a:t>+0.006</a:t>
+                      </a:r>
+                    </a:p>
+                  </a:txBody>
+                  <a:tcPr marL="54864" marR="54864" marT="18288" marB="18288">
+                    <a:solidFill>
+                      <a:srgbClr val="FFFFFF"/>
+                    </a:solidFill>
+                  </a:tcPr>
+                </a:tc>
+                <a:tc>
+                  <a:txBody>
+                    <a:bodyPr wrap="square"/>
+                    <a:lstStyle/>
+                    <a:p>
+                      <a:r>
+                        <a:rPr sz="1100" b="0">
+                          <a:solidFill>
+                            <a:srgbClr val="282828"/>
+                          </a:solidFill>
+                          <a:latin typeface="Arial"/>
+                        </a:rPr>
+                        <a:t>–</a:t>
+                      </a:r>
+                    </a:p>
+                  </a:txBody>
+                  <a:tcPr marL="54864" marR="54864" marT="18288" marB="18288">
+                    <a:solidFill>
+                      <a:srgbClr val="FFFFFF"/>
+                    </a:solidFill>
+                  </a:tcPr>
+                </a:tc>
+                <a:tc>
+                  <a:txBody>
+                    <a:bodyPr wrap="square"/>
+                    <a:lstStyle/>
+                    <a:p>
+                      <a:r>
+                        <a:rPr sz="1100" b="0">
+                          <a:solidFill>
+                            <a:srgbClr val="282828"/>
+                          </a:solidFill>
+                          <a:latin typeface="Arial"/>
+                        </a:rPr>
+                        <a:t>focus-compensated</a:t>
+                      </a:r>
+                    </a:p>
+                  </a:txBody>
+                  <a:tcPr marL="54864" marR="54864" marT="18288" marB="18288">
+                    <a:solidFill>
+                      <a:srgbClr val="FFFFFF"/>
+                    </a:solidFill>
+                  </a:tcPr>
+                </a:tc>
+              </a:tr>
+              <a:tr h="468630">
+                <a:tc>
+                  <a:txBody>
+                    <a:bodyPr wrap="square"/>
+                    <a:lstStyle/>
+                    <a:p>
+                      <a:r>
+                        <a:rPr sz="1100" b="0">
+                          <a:solidFill>
+                            <a:srgbClr val="282828"/>
+                          </a:solidFill>
+                          <a:latin typeface="Arial"/>
+                        </a:rPr>
+                        <a:t>lens radius, thickness; air space; slit, detector defocus</a:t>
+                      </a:r>
+                    </a:p>
+                  </a:txBody>
+                  <a:tcPr marL="54864" marR="54864" marT="18288" marB="18288">
+                    <a:solidFill>
+                      <a:srgbClr val="ECF1F6"/>
+                    </a:solidFill>
+                  </a:tcPr>
+                </a:tc>
+                <a:tc>
+                  <a:txBody>
+                    <a:bodyPr wrap="square"/>
+                    <a:lstStyle/>
+                    <a:p>
+                      <a:r>
+                        <a:rPr sz="1100" b="0">
+                          <a:solidFill>
+                            <a:srgbClr val="282828"/>
+                          </a:solidFill>
+                          <a:latin typeface="Arial"/>
+                        </a:rPr>
+                        <a:t>focus terms</a:t>
+                      </a:r>
+                    </a:p>
+                  </a:txBody>
+                  <a:tcPr marL="54864" marR="54864" marT="18288" marB="18288">
+                    <a:solidFill>
+                      <a:srgbClr val="ECF1F6"/>
+                    </a:solidFill>
+                  </a:tcPr>
+                </a:tc>
+                <a:tc>
+                  <a:txBody>
+                    <a:bodyPr wrap="square"/>
+                    <a:lstStyle/>
+                    <a:p>
+                      <a:r>
+                        <a:rPr sz="1100" b="0">
+                          <a:solidFill>
+                            <a:srgbClr val="282828"/>
+                          </a:solidFill>
+                          <a:latin typeface="Arial"/>
+                        </a:rPr>
+                        <a:t>≤ 0.006</a:t>
+                      </a:r>
+                    </a:p>
+                  </a:txBody>
+                  <a:tcPr marL="54864" marR="54864" marT="18288" marB="18288">
+                    <a:solidFill>
+                      <a:srgbClr val="ECF1F6"/>
+                    </a:solidFill>
+                  </a:tcPr>
+                </a:tc>
+                <a:tc>
+                  <a:txBody>
+                    <a:bodyPr wrap="square"/>
+                    <a:lstStyle/>
+                    <a:p>
+                      <a:r>
+                        <a:rPr sz="1100" b="0">
+                          <a:solidFill>
+                            <a:srgbClr val="282828"/>
+                          </a:solidFill>
+                          <a:latin typeface="Arial"/>
+                        </a:rPr>
+                        <a:t>–</a:t>
+                      </a:r>
+                    </a:p>
+                  </a:txBody>
+                  <a:tcPr marL="54864" marR="54864" marT="18288" marB="18288">
+                    <a:solidFill>
+                      <a:srgbClr val="ECF1F6"/>
+                    </a:solidFill>
+                  </a:tcPr>
+                </a:tc>
+                <a:tc>
+                  <a:txBody>
+                    <a:bodyPr wrap="square"/>
+                    <a:lstStyle/>
+                    <a:p>
+                      <a:r>
+                        <a:rPr sz="1100" b="0">
+                          <a:solidFill>
+                            <a:srgbClr val="282828"/>
+                          </a:solidFill>
+                          <a:latin typeface="Arial"/>
+                        </a:rPr>
+                        <a:t>focus-compensated</a:t>
+                      </a:r>
+                    </a:p>
+                  </a:txBody>
+                  <a:tcPr marL="54864" marR="54864" marT="18288" marB="18288">
+                    <a:solidFill>
+                      <a:srgbClr val="ECF1F6"/>
+                    </a:solidFill>
+                  </a:tcPr>
+                </a:tc>
+              </a:tr>
+              <a:tr h="280035">
+                <a:tc>
+                  <a:txBody>
+                    <a:bodyPr wrap="square"/>
+                    <a:lstStyle/>
+                    <a:p>
+                      <a:r>
+                        <a:rPr sz="1100" b="0">
+                          <a:solidFill>
+                            <a:srgbClr val="282828"/>
+                          </a:solidFill>
+                          <a:latin typeface="Arial"/>
+                        </a:rPr>
+                        <a:t>CaF</a:t>
+                      </a:r>
+                      <a:r>
+                        <a:rPr sz="1100" b="0" baseline="-25000">
+                          <a:solidFill>
+                            <a:srgbClr val="282828"/>
+                          </a:solidFill>
+                          <a:latin typeface="Arial"/>
+                        </a:rPr>
+                        <a:t>2</a:t>
+                      </a:r>
+                      <a:r>
+                        <a:rPr sz="1100" b="0">
+                          <a:solidFill>
+                            <a:srgbClr val="282828"/>
+                          </a:solidFill>
+                          <a:latin typeface="Arial"/>
+                        </a:rPr>
+                        <a:t> index, 10⁻⁵ (1 K)</a:t>
+                      </a:r>
+                    </a:p>
+                  </a:txBody>
+                  <a:tcPr marL="54864" marR="54864" marT="18288" marB="18288">
+                    <a:solidFill>
+                      <a:srgbClr val="FFFFFF"/>
+                    </a:solidFill>
+                  </a:tcPr>
+                </a:tc>
+                <a:tc>
+                  <a:txBody>
+                    <a:bodyPr wrap="square"/>
+                    <a:lstStyle/>
+                    <a:p>
+                      <a:r>
+                        <a:rPr sz="1100" b="0">
+                          <a:solidFill>
+                            <a:srgbClr val="282828"/>
+                          </a:solidFill>
+                          <a:latin typeface="Arial"/>
+                        </a:rPr>
+                        <a:t>+0.0014</a:t>
+                      </a:r>
+                    </a:p>
+                  </a:txBody>
+                  <a:tcPr marL="54864" marR="54864" marT="18288" marB="18288">
+                    <a:solidFill>
+                      <a:srgbClr val="FFFFFF"/>
+                    </a:solidFill>
+                  </a:tcPr>
+                </a:tc>
+                <a:tc>
+                  <a:txBody>
+                    <a:bodyPr wrap="square"/>
+                    <a:lstStyle/>
+                    <a:p>
+                      <a:r>
+                        <a:rPr sz="1100" b="0">
+                          <a:solidFill>
+                            <a:srgbClr val="282828"/>
+                          </a:solidFill>
+                          <a:latin typeface="Arial"/>
+                        </a:rPr>
+                        <a:t>–</a:t>
+                      </a:r>
+                    </a:p>
+                  </a:txBody>
+                  <a:tcPr marL="54864" marR="54864" marT="18288" marB="18288">
+                    <a:solidFill>
+                      <a:srgbClr val="FFFFFF"/>
+                    </a:solidFill>
+                  </a:tcPr>
+                </a:tc>
+                <a:tc>
+                  <a:txBody>
+                    <a:bodyPr wrap="square"/>
+                    <a:lstStyle/>
+                    <a:p>
+                      <a:r>
+                        <a:rPr sz="1100" b="0">
+                          <a:solidFill>
+                            <a:srgbClr val="282828"/>
+                          </a:solidFill>
+                          <a:latin typeface="Arial"/>
+                        </a:rPr>
+                        <a:t>–</a:t>
+                      </a:r>
+                    </a:p>
+                  </a:txBody>
+                  <a:tcPr marL="54864" marR="54864" marT="18288" marB="18288">
+                    <a:solidFill>
+                      <a:srgbClr val="FFFFFF"/>
+                    </a:solidFill>
+                  </a:tcPr>
+                </a:tc>
+                <a:tc>
+                  <a:txBody>
+                    <a:bodyPr wrap="square"/>
+                    <a:lstStyle/>
+                    <a:p>
+                      <a:r>
+                        <a:rPr sz="1100" b="0">
+                          <a:solidFill>
+                            <a:srgbClr val="282828"/>
+                          </a:solidFill>
+                          <a:latin typeface="Arial"/>
+                        </a:rPr>
+                        <a:t>negligible</a:t>
+                      </a:r>
+                    </a:p>
+                  </a:txBody>
+                  <a:tcPr marL="54864" marR="54864" marT="18288" marB="18288">
+                    <a:solidFill>
+                      <a:srgbClr val="FFFFFF"/>
+                    </a:solidFill>
+                  </a:tcPr>
+                </a:tc>
+              </a:tr>
+              <a:tr h="280035">
+                <a:tc>
+                  <a:txBody>
+                    <a:bodyPr wrap="square"/>
+                    <a:lstStyle/>
+                    <a:p>
+                      <a:r>
+                        <a:rPr sz="1100" b="0">
+                          <a:solidFill>
+                            <a:srgbClr val="282828"/>
+                          </a:solidFill>
+                          <a:latin typeface="Arial"/>
+                        </a:rPr>
+                        <a:t>CaF</a:t>
+                      </a:r>
+                      <a:r>
+                        <a:rPr sz="1100" b="0" baseline="-25000">
+                          <a:solidFill>
+                            <a:srgbClr val="282828"/>
+                          </a:solidFill>
+                          <a:latin typeface="Arial"/>
+                        </a:rPr>
+                        <a:t>2</a:t>
+                      </a:r>
+                      <a:r>
+                        <a:rPr sz="1100" b="0">
+                          <a:solidFill>
+                            <a:srgbClr val="282828"/>
+                          </a:solidFill>
+                          <a:latin typeface="Arial"/>
+                        </a:rPr>
+                        <a:t> radius + thickness per K (CTE)</a:t>
+                      </a:r>
+                    </a:p>
+                  </a:txBody>
+                  <a:tcPr marL="54864" marR="54864" marT="18288" marB="18288">
+                    <a:solidFill>
+                      <a:srgbClr val="ECF1F6"/>
+                    </a:solidFill>
+                  </a:tcPr>
+                </a:tc>
+                <a:tc>
+                  <a:txBody>
+                    <a:bodyPr wrap="square"/>
+                    <a:lstStyle/>
+                    <a:p>
+                      <a:r>
+                        <a:rPr sz="1100" b="0">
+                          <a:solidFill>
+                            <a:srgbClr val="282828"/>
+                          </a:solidFill>
+                          <a:latin typeface="Arial"/>
+                        </a:rPr>
+                        <a:t>+0.050 − 0.051</a:t>
+                      </a:r>
+                    </a:p>
+                  </a:txBody>
+                  <a:tcPr marL="54864" marR="54864" marT="18288" marB="18288">
+                    <a:solidFill>
+                      <a:srgbClr val="ECF1F6"/>
+                    </a:solidFill>
+                  </a:tcPr>
+                </a:tc>
+                <a:tc>
+                  <a:txBody>
+                    <a:bodyPr wrap="square"/>
+                    <a:lstStyle/>
+                    <a:p>
+                      <a:r>
+                        <a:rPr sz="1100" b="0">
+                          <a:solidFill>
+                            <a:srgbClr val="282828"/>
+                          </a:solidFill>
+                          <a:latin typeface="Arial"/>
+                        </a:rPr>
+                        <a:t>–</a:t>
+                      </a:r>
+                    </a:p>
+                  </a:txBody>
+                  <a:tcPr marL="54864" marR="54864" marT="18288" marB="18288">
+                    <a:solidFill>
+                      <a:srgbClr val="ECF1F6"/>
+                    </a:solidFill>
+                  </a:tcPr>
+                </a:tc>
+                <a:tc>
+                  <a:txBody>
+                    <a:bodyPr wrap="square"/>
+                    <a:lstStyle/>
+                    <a:p>
+                      <a:r>
+                        <a:rPr sz="1100" b="0">
+                          <a:solidFill>
+                            <a:srgbClr val="282828"/>
+                          </a:solidFill>
+                          <a:latin typeface="Arial"/>
+                        </a:rPr>
+                        <a:t>–</a:t>
+                      </a:r>
+                    </a:p>
+                  </a:txBody>
+                  <a:tcPr marL="54864" marR="54864" marT="18288" marB="18288">
+                    <a:solidFill>
+                      <a:srgbClr val="ECF1F6"/>
+                    </a:solidFill>
+                  </a:tcPr>
+                </a:tc>
+                <a:tc>
+                  <a:txBody>
+                    <a:bodyPr wrap="square"/>
+                    <a:lstStyle/>
+                    <a:p>
+                      <a:r>
+                        <a:rPr sz="1100" b="0">
+                          <a:solidFill>
+                            <a:srgbClr val="282828"/>
+                          </a:solidFill>
+                          <a:latin typeface="Arial"/>
+                        </a:rPr>
+                        <a:t>cancel</a:t>
+                      </a:r>
+                    </a:p>
+                  </a:txBody>
+                  <a:tcPr marL="54864" marR="54864" marT="18288" marB="18288">
+                    <a:solidFill>
+                      <a:srgbClr val="ECF1F6"/>
+                    </a:solidFill>
+                  </a:tcPr>
+                </a:tc>
+              </a:tr>
+              <a:tr h="468630">
+                <a:tc>
+                  <a:txBody>
+                    <a:bodyPr wrap="square"/>
+                    <a:lstStyle/>
+                    <a:p>
+                      <a:r>
+                        <a:rPr sz="1100" b="0">
+                          <a:solidFill>
+                            <a:srgbClr val="282828"/>
+                          </a:solidFill>
+                          <a:latin typeface="Arial"/>
+                        </a:rPr>
+                        <a:t>aluminum air space per K; N-BK7 grating radius per K</a:t>
+                      </a:r>
+                    </a:p>
+                  </a:txBody>
+                  <a:tcPr marL="54864" marR="54864" marT="18288" marB="18288">
+                    <a:solidFill>
+                      <a:srgbClr val="FFFFFF"/>
+                    </a:solidFill>
+                  </a:tcPr>
+                </a:tc>
+                <a:tc>
+                  <a:txBody>
+                    <a:bodyPr wrap="square"/>
+                    <a:lstStyle/>
+                    <a:p>
+                      <a:r>
+                        <a:rPr sz="1100" b="0">
+                          <a:solidFill>
+                            <a:srgbClr val="282828"/>
+                          </a:solidFill>
+                          <a:latin typeface="Arial"/>
+                        </a:rPr>
+                        <a:t>−0.22; +0.14</a:t>
+                      </a:r>
+                    </a:p>
+                  </a:txBody>
+                  <a:tcPr marL="54864" marR="54864" marT="18288" marB="18288">
+                    <a:solidFill>
+                      <a:srgbClr val="FFFFFF"/>
+                    </a:solidFill>
+                  </a:tcPr>
+                </a:tc>
+                <a:tc>
+                  <a:txBody>
+                    <a:bodyPr wrap="square"/>
+                    <a:lstStyle/>
+                    <a:p>
+                      <a:r>
+                        <a:rPr sz="1100" b="0">
+                          <a:solidFill>
+                            <a:srgbClr val="282828"/>
+                          </a:solidFill>
+                          <a:latin typeface="Arial"/>
+                        </a:rPr>
+                        <a:t>focus terms</a:t>
+                      </a:r>
+                    </a:p>
+                  </a:txBody>
+                  <a:tcPr marL="54864" marR="54864" marT="18288" marB="18288">
+                    <a:solidFill>
+                      <a:srgbClr val="FFFFFF"/>
+                    </a:solidFill>
+                  </a:tcPr>
+                </a:tc>
+                <a:tc>
+                  <a:txBody>
+                    <a:bodyPr wrap="square"/>
+                    <a:lstStyle/>
+                    <a:p>
+                      <a:r>
+                        <a:rPr sz="1100" b="0">
+                          <a:solidFill>
+                            <a:srgbClr val="282828"/>
+                          </a:solidFill>
+                          <a:latin typeface="Arial"/>
+                        </a:rPr>
+                        <a:t>–</a:t>
+                      </a:r>
+                    </a:p>
+                  </a:txBody>
+                  <a:tcPr marL="54864" marR="54864" marT="18288" marB="18288">
+                    <a:solidFill>
+                      <a:srgbClr val="FFFFFF"/>
+                    </a:solidFill>
+                  </a:tcPr>
+                </a:tc>
+                <a:tc>
+                  <a:txBody>
+                    <a:bodyPr wrap="square"/>
+                    <a:lstStyle/>
+                    <a:p>
+                      <a:r>
+                        <a:rPr sz="1100" b="0">
+                          <a:solidFill>
+                            <a:srgbClr val="282828"/>
+                          </a:solidFill>
+                          <a:latin typeface="Arial"/>
+                        </a:rPr>
+                        <a:t>refocus-compensated</a:t>
+                      </a:r>
+                    </a:p>
+                  </a:txBody>
+                  <a:tcPr marL="54864" marR="54864" marT="18288" marB="18288">
+                    <a:solidFill>
+                      <a:srgbClr val="FFFFFF"/>
+                    </a:solidFill>
+                  </a:tcPr>
+                </a:tc>
+              </a:tr>
+            </a:tbl>
+          </a:graphicData>
+        </a:graphic>
+      </p:graphicFrame>
       <p:sp>
         <p:nvSpPr>
-          <p:cNvPr id="4" name="TextBox 3"/>
+          <p:cNvPr id="5" name="TextBox 4"/>
           <p:cNvSpPr txBox="1"/>
           <p:nvPr/>
         </p:nvSpPr>
         <p:spPr>
           <a:xfrm>
-            <a:off x="411480" y="1298448"/>
+            <a:off x="411480" y="4810887"/>
             <a:ext cx="11368735" cy="274320"/>
           </a:xfrm>
           <a:prstGeom prst="rect">
@@ -10512,7 +11750,7 @@
                 </a:solidFill>
                 <a:latin typeface="Arial"/>
               </a:rPr>
-              <a:t>stop_info_set refused iElt ≥ nElt−2 and nElt ≤ 3</a:t>
+              <a:t>Keystone is lateral color: no compensator touches it.</a:t>
             </a:r>
             <a:r>
               <a:rPr sz="1500" b="0">
@@ -10521,7 +11759,7 @@
                 </a:solidFill>
                 <a:latin typeface="Arial"/>
               </a:rPr>
-              <a:t> — the original wrapper's range, with no engine reason — so macos.stop(2) failed on every M1-M2-M3-FP deck while the prescription keyword ApStop= and the CLI's STOP (1..nElt) accepted it.  The template worked around it with one deck per field until the fix.  Now the CLI's range; gate tStopReload/test_stop_accepts_the_secondary_of_a_four_element_deck.</a:t>
+              <a:t>  Smile is loose everywhere (≥ 300 µm or µrad).  Linearity at 2×: keystone vs decenter 1.10, CRF vs grating radius 1.03, SRF 2.6 (quadratic, and at the floor).</a:t>
             </a:r>
           </a:p>
           <a:p>
@@ -10546,7 +11784,7 @@
                 </a:solidFill>
                 <a:latin typeface="Arial"/>
               </a:rPr>
-              <a:t>Also from this round, in the tools:</a:t>
+              <a:t>The 1.5k Dyson</a:t>
             </a:r>
             <a:r>
               <a:rPr sz="1500" b="0">
@@ -10555,20 +11793,38 @@
                 </a:solidFill>
                 <a:latin typeface="Arial"/>
               </a:rPr>
-              <a:t> both launch conventions in the join scorer (dyson5_t5f, tel5f_launch), the per-field chief-angle components in every rung table, the spectrometer's chief-tilt diagnostic.</a:t>
+              <a:t> has the same pattern at twice the keystone sensitivity (1.82 × 10⁻³ px per µm: 13 µm for the paper's CBE, 25 µm for Joe).  </a:t>
+            </a:r>
+            <a:r>
+              <a:rPr sz="1500" b="1">
+                <a:solidFill>
+                  <a:srgbClr val="282828"/>
+                </a:solidFill>
+                <a:latin typeface="Arial"/>
+              </a:rPr>
+              <a:t>Option B</a:t>
+            </a:r>
+            <a:r>
+              <a:rPr sz="1500" b="0">
+                <a:solidFill>
+                  <a:srgbClr val="282828"/>
+                </a:solidFill>
+                <a:latin typeface="Arial"/>
+              </a:rPr>
+              <a:t> raises the keystone sensitivities 6–45 % (clocking most): 25 µm, 33 µrad, 64 µrad.</a:t>
             </a:r>
           </a:p>
         </p:txBody>
       </p:sp>
       <p:sp>
         <p:nvSpPr>
-          <p:cNvPr id="5" name="TextBox 4"/>
+          <p:cNvPr id="6" name="TextBox 5"/>
           <p:cNvSpPr txBox="1"/>
           <p:nvPr/>
         </p:nvSpPr>
         <p:spPr>
           <a:xfrm>
-            <a:off x="411480" y="3101339"/>
+            <a:off x="411480" y="6118479"/>
             <a:ext cx="11368735" cy="274320"/>
           </a:xfrm>
           <a:prstGeom prst="rect">
@@ -10594,7 +11850,7 @@
                 </a:solidFill>
                 <a:latin typeface="Arial"/>
               </a:rPr>
-              <a:t>macos a09cd59; resources 9845c2d.</a:t>
+              <a:t>REPORT_dyson5_spec.md; 21 rows; the paper's Option A as-built keystone 5.7 % of a pixel = 1.03 µm (Table 2).  Compensator residuals for focus alone and focus + x/y are both in the report (x/y adds nothing: the metrics are relative).</a:t>
             </a:r>
           </a:p>
         </p:txBody>
@@ -10651,7 +11907,7 @@
                 </a:solidFill>
                 <a:latin typeface="Arial"/>
               </a:rPr>
-              <a:t>Records behind each slide</a:t>
+              <a:t>An engine finding from this round</a:t>
             </a:r>
           </a:p>
           <a:p>
@@ -10667,7 +11923,7 @@
                 </a:solidFill>
                 <a:latin typeface="Arial"/>
               </a:rPr>
-              <a:t>Every number traces to a runner stage and its record file</a:t>
+              <a:t>The api refused an element stop on the secondary of a four-element telescope</a:t>
             </a:r>
           </a:p>
         </p:txBody>
@@ -10716,6 +11972,253 @@
           </a:p>
         </p:txBody>
       </p:sp>
+      <p:sp>
+        <p:nvSpPr>
+          <p:cNvPr id="4" name="TextBox 3"/>
+          <p:cNvSpPr txBox="1"/>
+          <p:nvPr/>
+        </p:nvSpPr>
+        <p:spPr>
+          <a:xfrm>
+            <a:off x="411480" y="1298448"/>
+            <a:ext cx="11368735" cy="274320"/>
+          </a:xfrm>
+          <a:prstGeom prst="rect">
+            <a:avLst/>
+          </a:prstGeom>
+          <a:noFill/>
+        </p:spPr>
+        <p:txBody>
+          <a:bodyPr wrap="square">
+            <a:spAutoFit/>
+          </a:bodyPr>
+          <a:lstStyle/>
+          <a:p>
+            <a:pPr>
+              <a:spcAft>
+                <a:spcPts val="600"/>
+              </a:spcAft>
+            </a:pPr>
+            <a:r>
+              <a:rPr sz="1500" b="0">
+                <a:solidFill>
+                  <a:srgbClr val="282828"/>
+                </a:solidFill>
+                <a:latin typeface="Arial"/>
+              </a:rPr>
+              <a:t>•  </a:t>
+            </a:r>
+            <a:r>
+              <a:rPr sz="1500" b="1">
+                <a:solidFill>
+                  <a:srgbClr val="282828"/>
+                </a:solidFill>
+                <a:latin typeface="Arial"/>
+              </a:rPr>
+              <a:t>stop_info_set refused iElt ≥ nElt−2 and nElt ≤ 3</a:t>
+            </a:r>
+            <a:r>
+              <a:rPr sz="1500" b="0">
+                <a:solidFill>
+                  <a:srgbClr val="282828"/>
+                </a:solidFill>
+                <a:latin typeface="Arial"/>
+              </a:rPr>
+              <a:t> — the original wrapper's range, with no engine reason — so macos.stop(2) failed on every M1-M2-M3-FP deck while the prescription keyword ApStop= and the CLI's STOP (1..nElt) accepted it.  The template worked around it with one deck per field until the fix.  Now the CLI's range; gate tStopReload/test_stop_accepts_the_secondary_of_a_four_element_deck.</a:t>
+            </a:r>
+          </a:p>
+          <a:p>
+            <a:pPr>
+              <a:spcAft>
+                <a:spcPts val="600"/>
+              </a:spcAft>
+            </a:pPr>
+            <a:r>
+              <a:rPr sz="1500" b="0">
+                <a:solidFill>
+                  <a:srgbClr val="282828"/>
+                </a:solidFill>
+                <a:latin typeface="Arial"/>
+              </a:rPr>
+              <a:t>•  </a:t>
+            </a:r>
+            <a:r>
+              <a:rPr sz="1500" b="1">
+                <a:solidFill>
+                  <a:srgbClr val="282828"/>
+                </a:solidFill>
+                <a:latin typeface="Arial"/>
+              </a:rPr>
+              <a:t>Also from this round, in the tools:</a:t>
+            </a:r>
+            <a:r>
+              <a:rPr sz="1500" b="0">
+                <a:solidFill>
+                  <a:srgbClr val="282828"/>
+                </a:solidFill>
+                <a:latin typeface="Arial"/>
+              </a:rPr>
+              <a:t> both launch conventions in the join scorer (dyson5_t5f, tel5f_launch), the per-field chief-angle components in every rung table, the spectrometer's chief-tilt diagnostic.</a:t>
+            </a:r>
+          </a:p>
+        </p:txBody>
+      </p:sp>
+      <p:sp>
+        <p:nvSpPr>
+          <p:cNvPr id="5" name="TextBox 4"/>
+          <p:cNvSpPr txBox="1"/>
+          <p:nvPr/>
+        </p:nvSpPr>
+        <p:spPr>
+          <a:xfrm>
+            <a:off x="411480" y="3101339"/>
+            <a:ext cx="11368735" cy="274320"/>
+          </a:xfrm>
+          <a:prstGeom prst="rect">
+            <a:avLst/>
+          </a:prstGeom>
+          <a:noFill/>
+        </p:spPr>
+        <p:txBody>
+          <a:bodyPr wrap="square">
+            <a:spAutoFit/>
+          </a:bodyPr>
+          <a:lstStyle/>
+          <a:p>
+            <a:pPr>
+              <a:spcAft>
+                <a:spcPts val="600"/>
+              </a:spcAft>
+            </a:pPr>
+            <a:r>
+              <a:rPr sz="1050" b="0">
+                <a:solidFill>
+                  <a:srgbClr val="6E6E6E"/>
+                </a:solidFill>
+                <a:latin typeface="Arial"/>
+              </a:rPr>
+              <a:t>macos a09cd59; resources 9845c2d.</a:t>
+            </a:r>
+          </a:p>
+        </p:txBody>
+      </p:sp>
+    </p:spTree>
+  </p:cSld>
+  <p:clrMapOvr>
+    <a:masterClrMapping/>
+  </p:clrMapOvr>
+</p:sld>
+</file>
+
+<file path=ppt/slides/slide23.xml><?xml version="1.0" encoding="utf-8"?>
+<p:sld xmlns:a="http://schemas.openxmlformats.org/drawingml/2006/main" xmlns:p="http://schemas.openxmlformats.org/presentationml/2006/main" xmlns:r="http://schemas.openxmlformats.org/officeDocument/2006/relationships">
+  <p:cSld>
+    <p:spTree>
+      <p:nvGrpSpPr>
+        <p:cNvPr id="1" name=""/>
+        <p:cNvGrpSpPr/>
+        <p:nvPr/>
+      </p:nvGrpSpPr>
+      <p:grpSpPr/>
+      <p:sp>
+        <p:nvSpPr>
+          <p:cNvPr id="2" name="TextBox 1"/>
+          <p:cNvSpPr txBox="1"/>
+          <p:nvPr/>
+        </p:nvSpPr>
+        <p:spPr>
+          <a:xfrm>
+            <a:off x="411480" y="201168"/>
+            <a:ext cx="11368735" cy="914400"/>
+          </a:xfrm>
+          <a:prstGeom prst="rect">
+            <a:avLst/>
+          </a:prstGeom>
+          <a:noFill/>
+        </p:spPr>
+        <p:txBody>
+          <a:bodyPr wrap="square">
+            <a:spAutoFit/>
+          </a:bodyPr>
+          <a:lstStyle/>
+          <a:p>
+            <a:pPr>
+              <a:spcAft>
+                <a:spcPts val="400"/>
+              </a:spcAft>
+            </a:pPr>
+            <a:r>
+              <a:rPr sz="2400" b="1">
+                <a:solidFill>
+                  <a:srgbClr val="1F4E79"/>
+                </a:solidFill>
+                <a:latin typeface="Arial"/>
+              </a:rPr>
+              <a:t>Records behind each slide</a:t>
+            </a:r>
+          </a:p>
+          <a:p>
+            <a:pPr>
+              <a:spcAft>
+                <a:spcPts val="0"/>
+              </a:spcAft>
+            </a:pPr>
+            <a:r>
+              <a:rPr sz="1250" b="0">
+                <a:solidFill>
+                  <a:srgbClr val="6E6E6E"/>
+                </a:solidFill>
+                <a:latin typeface="Arial"/>
+              </a:rPr>
+              <a:t>Every number traces to a runner stage and its record file</a:t>
+            </a:r>
+          </a:p>
+        </p:txBody>
+      </p:sp>
+      <p:sp>
+        <p:nvSpPr>
+          <p:cNvPr id="3" name="Rectangle 2"/>
+          <p:cNvSpPr/>
+          <p:nvPr/>
+        </p:nvSpPr>
+        <p:spPr>
+          <a:xfrm>
+            <a:off x="411480" y="1133856"/>
+            <a:ext cx="11368735" cy="20320"/>
+          </a:xfrm>
+          <a:prstGeom prst="rect">
+            <a:avLst/>
+          </a:prstGeom>
+          <a:solidFill>
+            <a:srgbClr val="B8C6D4"/>
+          </a:solidFill>
+          <a:ln>
+            <a:noFill/>
+          </a:ln>
+          <a:effectLst/>
+        </p:spPr>
+        <p:style>
+          <a:lnRef idx="1">
+            <a:schemeClr val="accent1"/>
+          </a:lnRef>
+          <a:fillRef idx="3">
+            <a:schemeClr val="accent1"/>
+          </a:fillRef>
+          <a:effectRef idx="2">
+            <a:schemeClr val="accent1"/>
+          </a:effectRef>
+          <a:fontRef idx="minor">
+            <a:schemeClr val="lt1"/>
+          </a:fontRef>
+        </p:style>
+        <p:txBody>
+          <a:bodyPr rtlCol="0" anchor="ctr"/>
+          <a:lstStyle/>
+          <a:p>
+            <a:pPr algn="ctr"/>
+          </a:p>
+        </p:txBody>
+      </p:sp>
       <p:graphicFrame>
         <p:nvGraphicFramePr>
           <p:cNvPr id="4" name="Table 3"/>
@@ -11049,7 +12552,7 @@
                           </a:solidFill>
                           <a:latin typeface="Arial"/>
                         </a:rPr>
-                        <a:t>dyson5_jim_3a.txt; BRIEF_to_dyson5.md addendum 49</a:t>
+                        <a:t>dyson5_jim_3a.txt; REPORT_dyson5_spec.md; spectrometer_sens, tSpectrometerSens; BRIEF_to_dyson5.md addendum 49</a:t>
                       </a:r>
                     </a:p>
                   </a:txBody>

</xml_diff>

<commit_message>
deck_dyson_3k: the 1.5k module through the template (TO, R5 ffc: 1.02 px at every field, e2e smile 0.009 / CRF 1.03 / SRF 2.024 floor / EiP 0.97; the four-module block 494 L, 21.4 kg vs the three-asphere record's 300 L, 14.6 kg) on the comparison slide
Co-Authored-By: Claude Fable 5.1 <noreply@anthropic.com>
</commit_message>
<xml_diff>
--- a/demo_session/deck_dyson_3k.pptx
+++ b/demo_session/deck_dyson_3k.pptx
@@ -8907,7 +8907,7 @@
         </p:nvGraphicFramePr>
         <p:xfrm>
           <a:off x="411480" y="1298448"/>
-          <a:ext cx="11368734" cy="4583430"/>
+          <a:ext cx="11368733" cy="5149215"/>
         </p:xfrm>
         <a:graphic>
           <a:graphicData uri="http://schemas.openxmlformats.org/drawingml/2006/table">
@@ -8916,9 +8916,9 @@
                 <a:tableStyleId>{5C22544A-7EE6-4342-B048-85BDC9FD1C3A}</a:tableStyleId>
               </a:tblPr>
               <a:tblGrid>
-                <a:gridCol w="3268511"/>
-                <a:gridCol w="3126402"/>
-                <a:gridCol w="4973821"/>
+                <a:gridCol w="2949032"/>
+                <a:gridCol w="2820813"/>
+                <a:gridCol w="5598888"/>
               </a:tblGrid>
               <a:tr h="280035">
                 <a:tc>
@@ -9198,7 +9198,7 @@
                           </a:solidFill>
                           <a:latin typeface="Arial"/>
                         </a:rPr>
-                        <a:t>three off-axis aspheres: 0.4 px center, 0.8 px at the strip ends (the template's 1.5k run is in progress)</a:t>
+                        <a:t>the same form through the same template (R5 ffc): 1.02 px at every field; aspheres alone did not reach the floor</a:t>
                       </a:r>
                     </a:p>
                   </a:txBody>
@@ -9266,13 +9266,81 @@
                           </a:solidFill>
                           <a:latin typeface="Arial"/>
                         </a:rPr>
-                        <a:t>0.08 / 0.50 / 0.01 / 1.26 / 2.21 px</a:t>
+                        <a:t>0.009 / 0.009 / 0.009 / 1.03 / 2.024 px</a:t>
                       </a:r>
                     </a:p>
                   </a:txBody>
                   <a:tcPr marL="54864" marR="54864" marT="18288" marB="18288">
                     <a:solidFill>
                       <a:srgbClr val="ECF1F6"/>
+                    </a:solidFill>
+                  </a:tcPr>
+                </a:tc>
+              </a:tr>
+              <a:tr h="468630">
+                <a:tc>
+                  <a:txBody>
+                    <a:bodyPr wrap="square"/>
+                    <a:lstStyle/>
+                    <a:p>
+                      <a:r>
+                        <a:rPr sz="1100" b="0">
+                          <a:solidFill>
+                            <a:srgbClr val="282828"/>
+                          </a:solidFill>
+                          <a:latin typeface="Arial"/>
+                        </a:rPr>
+                        <a:t>end to end: energy in one pixel, worst field</a:t>
+                      </a:r>
+                    </a:p>
+                  </a:txBody>
+                  <a:tcPr marL="54864" marR="54864" marT="18288" marB="18288">
+                    <a:solidFill>
+                      <a:srgbClr val="FFFFFF"/>
+                    </a:solidFill>
+                  </a:tcPr>
+                </a:tc>
+                <a:tc>
+                  <a:txBody>
+                    <a:bodyPr wrap="square"/>
+                    <a:lstStyle/>
+                    <a:p>
+                      <a:r>
+                        <a:rPr sz="1100" b="0">
+                          <a:solidFill>
+                            <a:srgbClr val="282828"/>
+                          </a:solidFill>
+                          <a:latin typeface="Arial"/>
+                        </a:rPr>
+                        <a:t>0.85</a:t>
+                      </a:r>
+                    </a:p>
+                  </a:txBody>
+                  <a:tcPr marL="54864" marR="54864" marT="18288" marB="18288">
+                    <a:solidFill>
+                      <a:srgbClr val="FFFFFF"/>
+                    </a:solidFill>
+                  </a:tcPr>
+                </a:tc>
+                <a:tc>
+                  <a:txBody>
+                    <a:bodyPr wrap="square"/>
+                    <a:lstStyle/>
+                    <a:p>
+                      <a:r>
+                        <a:rPr sz="1100" b="0">
+                          <a:solidFill>
+                            <a:srgbClr val="282828"/>
+                          </a:solidFill>
+                          <a:latin typeface="Arial"/>
+                        </a:rPr>
+                        <a:t>0.97</a:t>
+                      </a:r>
+                    </a:p>
+                  </a:txBody>
+                  <a:tcPr marL="54864" marR="54864" marT="18288" marB="18288">
+                    <a:solidFill>
+                      <a:srgbClr val="FFFFFF"/>
                     </a:solidFill>
                   </a:tcPr>
                 </a:tc>
@@ -9290,57 +9358,57 @@
                           </a:solidFill>
                           <a:latin typeface="Arial"/>
                         </a:rPr>
-                        <a:t>end to end: energy in one pixel, worst field</a:t>
-                      </a:r>
-                    </a:p>
-                  </a:txBody>
-                  <a:tcPr marL="54864" marR="54864" marT="18288" marB="18288">
-                    <a:solidFill>
-                      <a:srgbClr val="FFFFFF"/>
-                    </a:solidFill>
-                  </a:tcPr>
-                </a:tc>
-                <a:tc>
-                  <a:txBody>
-                    <a:bodyPr wrap="square"/>
-                    <a:lstStyle/>
-                    <a:p>
-                      <a:r>
-                        <a:rPr sz="1100" b="0">
-                          <a:solidFill>
-                            <a:srgbClr val="282828"/>
-                          </a:solidFill>
-                          <a:latin typeface="Arial"/>
-                        </a:rPr>
-                        <a:t>0.85</a:t>
-                      </a:r>
-                    </a:p>
-                  </a:txBody>
-                  <a:tcPr marL="54864" marR="54864" marT="18288" marB="18288">
-                    <a:solidFill>
-                      <a:srgbClr val="FFFFFF"/>
-                    </a:solidFill>
-                  </a:tcPr>
-                </a:tc>
-                <a:tc>
-                  <a:txBody>
-                    <a:bodyPr wrap="square"/>
-                    <a:lstStyle/>
-                    <a:p>
-                      <a:r>
-                        <a:rPr sz="1100" b="0">
-                          <a:solidFill>
-                            <a:srgbClr val="282828"/>
-                          </a:solidFill>
-                          <a:latin typeface="Arial"/>
-                        </a:rPr>
-                        <a:t>0.30–0.39 (0.8 over the central third)</a:t>
-                      </a:r>
-                    </a:p>
-                  </a:txBody>
-                  <a:tcPr marL="54864" marR="54864" marT="18288" marB="18288">
-                    <a:solidFill>
-                      <a:srgbClr val="FFFFFF"/>
+                        <a:t>light admitted by the grating</a:t>
+                      </a:r>
+                    </a:p>
+                  </a:txBody>
+                  <a:tcPr marL="54864" marR="54864" marT="18288" marB="18288">
+                    <a:solidFill>
+                      <a:srgbClr val="ECF1F6"/>
+                    </a:solidFill>
+                  </a:tcPr>
+                </a:tc>
+                <a:tc>
+                  <a:txBody>
+                    <a:bodyPr wrap="square"/>
+                    <a:lstStyle/>
+                    <a:p>
+                      <a:r>
+                        <a:rPr sz="1100" b="0">
+                          <a:solidFill>
+                            <a:srgbClr val="282828"/>
+                          </a:solidFill>
+                          <a:latin typeface="Arial"/>
+                        </a:rPr>
+                        <a:t>98.9 % per field</a:t>
+                      </a:r>
+                    </a:p>
+                  </a:txBody>
+                  <a:tcPr marL="54864" marR="54864" marT="18288" marB="18288">
+                    <a:solidFill>
+                      <a:srgbClr val="ECF1F6"/>
+                    </a:solidFill>
+                  </a:tcPr>
+                </a:tc>
+                <a:tc>
+                  <a:txBody>
+                    <a:bodyPr wrap="square"/>
+                    <a:lstStyle/>
+                    <a:p>
+                      <a:r>
+                        <a:rPr sz="1100" b="0">
+                          <a:solidFill>
+                            <a:srgbClr val="282828"/>
+                          </a:solidFill>
+                          <a:latin typeface="Arial"/>
+                        </a:rPr>
+                        <a:t>98.7 % per field</a:t>
+                      </a:r>
+                    </a:p>
+                  </a:txBody>
+                  <a:tcPr marL="54864" marR="54864" marT="18288" marB="18288">
+                    <a:solidFill>
+                      <a:srgbClr val="ECF1F6"/>
                     </a:solidFill>
                   </a:tcPr>
                 </a:tc>
@@ -9358,74 +9426,6 @@
                           </a:solidFill>
                           <a:latin typeface="Arial"/>
                         </a:rPr>
-                        <a:t>light admitted by the grating</a:t>
-                      </a:r>
-                    </a:p>
-                  </a:txBody>
-                  <a:tcPr marL="54864" marR="54864" marT="18288" marB="18288">
-                    <a:solidFill>
-                      <a:srgbClr val="ECF1F6"/>
-                    </a:solidFill>
-                  </a:tcPr>
-                </a:tc>
-                <a:tc>
-                  <a:txBody>
-                    <a:bodyPr wrap="square"/>
-                    <a:lstStyle/>
-                    <a:p>
-                      <a:r>
-                        <a:rPr sz="1100" b="0">
-                          <a:solidFill>
-                            <a:srgbClr val="282828"/>
-                          </a:solidFill>
-                          <a:latin typeface="Arial"/>
-                        </a:rPr>
-                        <a:t>98.9 % per field</a:t>
-                      </a:r>
-                    </a:p>
-                  </a:txBody>
-                  <a:tcPr marL="54864" marR="54864" marT="18288" marB="18288">
-                    <a:solidFill>
-                      <a:srgbClr val="ECF1F6"/>
-                    </a:solidFill>
-                  </a:tcPr>
-                </a:tc>
-                <a:tc>
-                  <a:txBody>
-                    <a:bodyPr wrap="square"/>
-                    <a:lstStyle/>
-                    <a:p>
-                      <a:r>
-                        <a:rPr sz="1100" b="0">
-                          <a:solidFill>
-                            <a:srgbClr val="282828"/>
-                          </a:solidFill>
-                          <a:latin typeface="Arial"/>
-                        </a:rPr>
-                        <a:t>99 % per field</a:t>
-                      </a:r>
-                    </a:p>
-                  </a:txBody>
-                  <a:tcPr marL="54864" marR="54864" marT="18288" marB="18288">
-                    <a:solidFill>
-                      <a:srgbClr val="ECF1F6"/>
-                    </a:solidFill>
-                  </a:tcPr>
-                </a:tc>
-              </a:tr>
-              <a:tr h="280035">
-                <a:tc>
-                  <a:txBody>
-                    <a:bodyPr wrap="square"/>
-                    <a:lstStyle/>
-                    <a:p>
-                      <a:r>
-                        <a:rPr sz="1100" b="0">
-                          <a:solidFill>
-                            <a:srgbClr val="282828"/>
-                          </a:solidFill>
-                          <a:latin typeface="Arial"/>
-                        </a:rPr>
                         <a:t>clearance, worst pair</a:t>
                       </a:r>
                     </a:p>
@@ -9576,7 +9576,7 @@
                   </a:tcPr>
                 </a:tc>
               </a:tr>
-              <a:tr h="280035">
+              <a:tr h="468630">
                 <a:tc>
                   <a:txBody>
                     <a:bodyPr wrap="square"/>
@@ -9633,7 +9633,7 @@
                           </a:solidFill>
                           <a:latin typeface="Arial"/>
                         </a:rPr>
-                        <a:t>0.97 × 0.41 × 0.76 m, 300 L; 14.6 kg</a:t>
+                        <a:t>1.01 × 0.53 × 0.92 m, 494 L; 21.4 kg (the three-asphere record's block: 300 L, 14.6 kg — the zig-zag's M2 and M3 are full aperture)</a:t>
                       </a:r>
                     </a:p>
                   </a:txBody>
@@ -9644,7 +9644,7 @@
                   </a:tcPr>
                 </a:tc>
               </a:tr>
-              <a:tr h="280035">
+              <a:tr h="468630">
                 <a:tc>
                   <a:txBody>
                     <a:bodyPr wrap="square"/>
@@ -9860,7 +9860,7 @@
         </p:nvSpPr>
         <p:spPr>
           <a:xfrm>
-            <a:off x="411480" y="6028182"/>
+            <a:off x="411480" y="6593967"/>
             <a:ext cx="11368735" cy="274320"/>
           </a:xfrm>
           <a:prstGeom prst="rect">
@@ -9886,7 +9886,7 @@
                 </a:solidFill>
                 <a:latin typeface="Arial"/>
               </a:rPr>
-              <a:t>Records dyson5_jim_3a.txt, dyson5_t5f_cprime_centroid_roll000.txt, dyson5_rescore_1k5_launch.txt (the 1.5k module of record under both launches, 2026-10-08: its slit-filled smile is the older telescope's own 0.08 px, inside Joe's 0.1; its SRF 2.21 and energy 0.30–0.39 are the telescope's spots).  The four-module block (0.97 × 0.41 × 0.76 m, 14.6 kg of optics) of the last deck stands as the fallback.  The air gap at the window stands on both (six crossings, 0.81 uncoated).</a:t>
+              <a:t>Records dyson5_jim_3a.txt, dyson5_t5f_cprime_centroid_roll000.txt, tls1k5_e2e.txt and dyson5_cprime_1k5.in (the 1.5k module through the template, 2026-10-08: R5 ffc, a clearance wall row added after R4 touched M2 by 0.3 mm), dyson5_block4_cprime1k5.txt.  The earlier three-asphere 1.5k telescope re-scored under both launches: slit-filled smile 0.08, point-source 0.50, SRF 2.21, energy 0.30–0.39 (dyson5_rescore_1k5_launch.txt) — superseded.  The four-module block (0.97 × 0.41 × 0.76 m, 14.6 kg of optics) of the last deck stands as the fallback.  The air gap at the window stands on both (six crossings, 0.81 uncoated).</a:t>
             </a:r>
           </a:p>
         </p:txBody>

</xml_diff>

<commit_message>
deck_dyson_3k: slides 4-5 recast as 'what we did' for new readers (the challenge and where the last deck left it; Jim's answers and the paper; the 3k solution made a template; the template on the 1.5k) as the intro to what follows; Dave's two edits folded from the edit copy (SRF 'slit-limited'; 'the optimization sequence (ladder)'); edit copy re-synced
Co-Authored-By: Claude Fable 5.1 <noreply@anthropic.com>
</commit_message>
<xml_diff>
--- a/demo_session/deck_dyson_3k.pptx
+++ b/demo_session/deck_dyson_3k.pptx
@@ -4086,7 +4086,7 @@
                           </a:solidFill>
                           <a:latin typeface="Arial"/>
                         </a:rPr>
-                        <a:t>2.025 px (36.5 µm)</a:t>
+                        <a:t>2.025 px (36.5 µm), slit-limited</a:t>
                       </a:r>
                     </a:p>
                   </a:txBody>
@@ -5523,7 +5523,7 @@
                 </a:solidFill>
                 <a:latin typeface="Arial"/>
               </a:rPr>
-              <a:t>How the ladder was set: six rungs and three lessons</a:t>
+              <a:t>How the optimization sequence ("ladder") was set: six rungs and three lessons</a:t>
             </a:r>
           </a:p>
           <a:p>
@@ -13419,7 +13419,7 @@
                 </a:solidFill>
                 <a:latin typeface="Arial"/>
               </a:rPr>
-              <a:t>What changed; the template; the pair of 3k modules; the template's default run — seed, telescope of record, the module scored, how the ladder was set, the two smile conventions, the cone; the spectrometer; the template applied to the 1.5k; the comparison; the questions</a:t>
+              <a:t>What we did; the pair of 3k modules; the template's default run — seed, telescope of record, the module scored, how the ladder was set, the two smile conventions, the cone; the spectrometer; the template applied to the 1.5k; the comparison; the questions</a:t>
             </a:r>
           </a:p>
         </p:txBody>
@@ -13554,7 +13554,7 @@
                 </a:solidFill>
                 <a:latin typeface="Arial"/>
               </a:rPr>
-              <a:t> What changed since the last deck: Jim's answers and the paper</a:t>
+              <a:t> What we did: the challenge, and the background we were given</a:t>
             </a:r>
           </a:p>
           <a:p>
@@ -13588,7 +13588,7 @@
                 </a:solidFill>
                 <a:latin typeface="Arial"/>
               </a:rPr>
-              <a:t> The template: a long-slit telescope front end, parameterized</a:t>
+              <a:t> What we did: the 3k solution as a template, then the template on the 1.5k</a:t>
             </a:r>
           </a:p>
           <a:p>
@@ -13826,7 +13826,7 @@
                 </a:solidFill>
                 <a:latin typeface="Arial"/>
               </a:rPr>
-              <a:t> How the ladder was set: six rungs and three lessons</a:t>
+              <a:t> How the optimization sequence ("ladder") was set: six rungs and three lessons</a:t>
             </a:r>
           </a:p>
         </p:txBody>
@@ -18951,7 +18951,7 @@
                           </a:solidFill>
                           <a:latin typeface="Arial"/>
                         </a:rPr>
-                        <a:t>5</a:t>
+                        <a:t>4, 5</a:t>
                       </a:r>
                     </a:p>
                   </a:txBody>
@@ -18973,7 +18973,7 @@
                           </a:solidFill>
                           <a:latin typeface="Arial"/>
                         </a:rPr>
-                        <a:t>templates/10_telescopes/tma_longslit/ (README, tma_longslit_params.m, tma_longslit_run.m); BRIEF_to_dyson5.md addendum 48</a:t>
+                        <a:t>BRIEF_to_dyson5.md addenda 47–49; templates/10_telescopes/tma_longslit/ (README, tma_longslit_params.m, tma_longslit_run.m); REPORT_dyson5_cprime.md</a:t>
                       </a:r>
                     </a:p>
                   </a:txBody>
@@ -20681,7 +20681,7 @@
                 </a:solidFill>
                 <a:latin typeface="Arial"/>
               </a:rPr>
-              <a:t>What changed since the last deck: Jim's answers and the paper</a:t>
+              <a:t>What we did: the challenge, and the background we were given</a:t>
             </a:r>
           </a:p>
           <a:p>
@@ -20697,7 +20697,7 @@
                 </a:solidFill>
                 <a:latin typeface="Arial"/>
               </a:rPr>
-              <a:t>The trade leans to two 3k modules; the telescope is designed alone, telecentric at the slit, with its cone bounded; the air gap stands; the paper's form is the seed</a:t>
+              <a:t>An imaging spectrometer for a 180 km swath at 30 m pixels: a Dyson spectrometer per module, a telescope feeding its slit, two module sizes to trade; the last deck had the spectrometers at the pixel and the telescopes not; Jim's answers and the project's paper set the course</a:t>
             </a:r>
           </a:p>
         </p:txBody>
@@ -20789,7 +20789,7 @@
                 </a:solidFill>
                 <a:latin typeface="Arial"/>
               </a:rPr>
-              <a:t>Two modules, not four.</a:t>
+              <a:t>The challenge (Jim, Joe):</a:t>
             </a:r>
             <a:r>
               <a:rPr sz="1200" b="0">
@@ -20798,7 +20798,16 @@
                 </a:solidFill>
                 <a:latin typeface="Arial"/>
               </a:rPr>
-              <a:t>  Jim: four telescopes, spectrometers and detectors cost integration, test and calibration, not mass; detectors come as 2k × 2k and 3k × 0.5k, a 1.5k × 0.5k is NRE.  Materials are "almost always a tiny fraction of the instrument cost," so the </a:t>
+              <a:t> 6000 cross-track pixels of 18 µm over the swath, 380–2500 nm in 500 spectral pixels, F/1.8, f 330 mm, D 183 mm, smile and keystone under a tenth of a pixel, CRF under 1.5 px, SRF 1.5–2.0 px — as either </a:t>
+            </a:r>
+            <a:r>
+              <a:rPr sz="1200" b="1">
+                <a:solidFill>
+                  <a:srgbClr val="282828"/>
+                </a:solidFill>
+                <a:latin typeface="Arial"/>
+              </a:rPr>
+              <a:t>two 3k modules</a:t>
             </a:r>
             <a:r>
               <a:rPr sz="1200" b="0">
@@ -20807,6 +20816,15 @@
                 </a:solidFill>
                 <a:latin typeface="Arial"/>
               </a:rPr>
+              <a:t> (54 mm slits, 240 mm </a:t>
+            </a:r>
+            <a:r>
+              <a:rPr sz="1200" b="0">
+                <a:solidFill>
+                  <a:srgbClr val="282828"/>
+                </a:solidFill>
+                <a:latin typeface="Arial"/>
+              </a:rPr>
               <a:t>CaF</a:t>
             </a:r>
             <a:r>
@@ -20825,7 +20843,25 @@
                 </a:solidFill>
                 <a:latin typeface="Arial"/>
               </a:rPr>
-              <a:t> volume is not the discriminator.  The paper's own trade reached the same answer: two identical telescope + Dyson modules, each half of the 180 km swath.</a:t>
+              <a:t> Dysons) or </a:t>
+            </a:r>
+            <a:r>
+              <a:rPr sz="1200" b="1">
+                <a:solidFill>
+                  <a:srgbClr val="282828"/>
+                </a:solidFill>
+                <a:latin typeface="Arial"/>
+              </a:rPr>
+              <a:t>four 1.5k modules</a:t>
+            </a:r>
+            <a:r>
+              <a:rPr sz="1200" b="0">
+                <a:solidFill>
+                  <a:srgbClr val="282828"/>
+                </a:solidFill>
+                <a:latin typeface="Arial"/>
+              </a:rPr>
+              <a:t> (27 mm slits, 130 mm silica Dysons).  Every number by MACOS ray trace of a committed prescription.</a:t>
             </a:r>
           </a:p>
           <a:p>
@@ -20850,7 +20886,7 @@
                 </a:solidFill>
                 <a:latin typeface="Arial"/>
               </a:rPr>
-              <a:t>The telescope, designed separately.</a:t>
+              <a:t>Where the last deck (2026-10-06) left it:</a:t>
             </a:r>
             <a:r>
               <a:rPr sz="1200" b="0">
@@ -20859,7 +20895,7 @@
                 </a:solidFill>
                 <a:latin typeface="Arial"/>
               </a:rPr>
-              <a:t>  Jim: telescope and spectrometer each telecentric at the slit, the telescope a little faster than the spectrometer, and no rays at F/1.2.  The paper: the telescope optimized alone for uniform small spots along the slit under constraints on F/# anamorphicity, baffle clearance and working distance; then the Dyson added for end-to-end keystone and CRF.</a:t>
+              <a:t> both Dyson spectrometers at the pixel; the 1.5k telescope (three off-axis aspheres) near it; the 3k telescope not — CRF 4 px, 4–10 % of the energy in a pixel, marginal rays at F/1.2 into an F/1.8 spectrometer.</a:t>
             </a:r>
           </a:p>
           <a:p>
@@ -20884,7 +20920,7 @@
                 </a:solidFill>
                 <a:latin typeface="Arial"/>
               </a:rPr>
-              <a:t>The window is an order-sorting filter</a:t>
+              <a:t>What Jim answered (2026-10-07):</a:t>
             </a:r>
             <a:r>
               <a:rPr sz="1200" b="0">
@@ -20893,34 +20929,7 @@
                 </a:solidFill>
                 <a:latin typeface="Arial"/>
               </a:rPr>
-              <a:t> and cannot be bonded to </a:t>
-            </a:r>
-            <a:r>
-              <a:rPr sz="1200" b="0">
-                <a:solidFill>
-                  <a:srgbClr val="282828"/>
-                </a:solidFill>
-                <a:latin typeface="Arial"/>
-              </a:rPr>
-              <a:t>CaF</a:t>
-            </a:r>
-            <a:r>
-              <a:rPr sz="1200" b="0" baseline="-25000">
-                <a:solidFill>
-                  <a:srgbClr val="282828"/>
-                </a:solidFill>
-                <a:latin typeface="Arial"/>
-              </a:rPr>
-              <a:t>2</a:t>
-            </a:r>
-            <a:r>
-              <a:rPr sz="1200" b="0">
-                <a:solidFill>
-                  <a:srgbClr val="282828"/>
-                </a:solidFill>
-                <a:latin typeface="Arial"/>
-              </a:rPr>
-              <a:t> (CTE); fused silica to silica has a bad bonding history.  Six crossings, 0.81 uncoated, is the baseline.</a:t>
+              <a:t> two modules, not four — integration, test and calibration are the cost, not mass or glass, and 3k × 0.5k detectors are a standard format where 1.5k × 0.5k is NRE; design the telescope separately, telecentric at the slit, a little faster than the spectrometer, no F/1.2 rays; the window is an order-sorting filter in air (six crossings); tailor the AR and the blaze to the photon-starved long end; the Offner does not go below F/3.</a:t>
             </a:r>
           </a:p>
         </p:txBody>
@@ -20968,7 +20977,7 @@
                 </a:solidFill>
                 <a:latin typeface="Arial"/>
               </a:rPr>
-              <a:t>The paper's telescope</a:t>
+              <a:t>What the paper gave us</a:t>
             </a:r>
             <a:r>
               <a:rPr sz="1200" b="0">
@@ -20977,7 +20986,34 @@
                 </a:solidFill>
                 <a:latin typeface="Arial"/>
               </a:rPr>
-              <a:t> is a freeform TMA at f 345 mm, 192 mm, 8.9°, chosen over an even-asphere TMA for tolerance insensitivity, not nominal performance: spots 2–3 µm, "diffraction limited over most of the band," all aluminum at 280–300 K.</a:t>
+              <a:t> (Bradley et al., ICSO 2024, the SBG VSWIR design): the telescope form — a freeform zig-zag three-mirror anastigmat at f 345 mm, 192 mm, 8.9°, with a small convex M2 at the stop and no intermediate focus — optimized alone for small spots along the slit under constraints on F/# anamorphicity, clearance and working distance; its Dyson an aspheric </a:t>
+            </a:r>
+            <a:r>
+              <a:rPr sz="1200" b="0">
+                <a:solidFill>
+                  <a:srgbClr val="282828"/>
+                </a:solidFill>
+                <a:latin typeface="Arial"/>
+              </a:rPr>
+              <a:t>CaF</a:t>
+            </a:r>
+            <a:r>
+              <a:rPr sz="1200" b="0" baseline="-25000">
+                <a:solidFill>
+                  <a:srgbClr val="282828"/>
+                </a:solidFill>
+                <a:latin typeface="Arial"/>
+              </a:rPr>
+              <a:t>2</a:t>
+            </a:r>
+            <a:r>
+              <a:rPr sz="1200" b="0">
+                <a:solidFill>
+                  <a:srgbClr val="282828"/>
+                </a:solidFill>
+                <a:latin typeface="Arial"/>
+              </a:rPr>
+              <a:t> lens with a conic grating (their Option B); its bounds in micrometers (smile and keystone 1.8 µm; SRF 64.8 µm in co-added pixels; CRF and ARF 50.4 µm), which slide 3 converts to our pixel.</a:t>
             </a:r>
           </a:p>
           <a:p>
@@ -21002,7 +21038,7 @@
                 </a:solidFill>
                 <a:latin typeface="Arial"/>
               </a:rPr>
-              <a:t>The paper's spectrometer</a:t>
+              <a:t>So the work of this round</a:t>
             </a:r>
             <a:r>
               <a:rPr sz="1200" b="0">
@@ -21011,102 +21047,7 @@
                 </a:solidFill>
                 <a:latin typeface="Arial"/>
               </a:rPr>
-              <a:t> is an aspheric </a:t>
-            </a:r>
-            <a:r>
-              <a:rPr sz="1200" b="0">
-                <a:solidFill>
-                  <a:srgbClr val="282828"/>
-                </a:solidFill>
-                <a:latin typeface="Arial"/>
-              </a:rPr>
-              <a:t>CaF</a:t>
-            </a:r>
-            <a:r>
-              <a:rPr sz="1200" b="0" baseline="-25000">
-                <a:solidFill>
-                  <a:srgbClr val="282828"/>
-                </a:solidFill>
-                <a:latin typeface="Arial"/>
-              </a:rPr>
-              <a:t>2</a:t>
-            </a:r>
-            <a:r>
-              <a:rPr sz="1200" b="0">
-                <a:solidFill>
-                  <a:srgbClr val="282828"/>
-                </a:solidFill>
-                <a:latin typeface="Arial"/>
-              </a:rPr>
-              <a:t> Dyson lens with a conic grating (their Option B), no corrector lens, at 240 K; smaller than the telescope.</a:t>
-            </a:r>
-          </a:p>
-          <a:p>
-            <a:pPr>
-              <a:spcAft>
-                <a:spcPts val="600"/>
-              </a:spcAft>
-            </a:pPr>
-            <a:r>
-              <a:rPr sz="1200" b="0">
-                <a:solidFill>
-                  <a:srgbClr val="282828"/>
-                </a:solidFill>
-                <a:latin typeface="Arial"/>
-              </a:rPr>
-              <a:t>•  </a:t>
-            </a:r>
-            <a:r>
-              <a:rPr sz="1200" b="1">
-                <a:solidFill>
-                  <a:srgbClr val="282828"/>
-                </a:solidFill>
-                <a:latin typeface="Arial"/>
-              </a:rPr>
-              <a:t>The Offner</a:t>
-            </a:r>
-            <a:r>
-              <a:rPr sz="1200" b="0">
-                <a:solidFill>
-                  <a:srgbClr val="282828"/>
-                </a:solidFill>
-                <a:latin typeface="Arial"/>
-              </a:rPr>
-              <a:t> does not go much below F/3 at reasonable size (Jim), which confirms the F/1.8 Offner's exit in the last deck.</a:t>
-            </a:r>
-          </a:p>
-          <a:p>
-            <a:pPr>
-              <a:spcAft>
-                <a:spcPts val="600"/>
-              </a:spcAft>
-            </a:pPr>
-            <a:r>
-              <a:rPr sz="1200" b="0">
-                <a:solidFill>
-                  <a:srgbClr val="282828"/>
-                </a:solidFill>
-                <a:latin typeface="Arial"/>
-              </a:rPr>
-              <a:t>•  </a:t>
-            </a:r>
-            <a:r>
-              <a:rPr sz="1200" b="1">
-                <a:solidFill>
-                  <a:srgbClr val="282828"/>
-                </a:solidFill>
-                <a:latin typeface="Arial"/>
-              </a:rPr>
-              <a:t>AR and blaze</a:t>
-            </a:r>
-            <a:r>
-              <a:rPr sz="1200" b="0">
-                <a:solidFill>
-                  <a:srgbClr val="282828"/>
-                </a:solidFill>
-                <a:latin typeface="Arial"/>
-              </a:rPr>
-              <a:t> are tailored to the photon-starved long-wavelength end; throughput is a per-band number, not one figure.</a:t>
+              <a:t> was the 3k telescope to the pixel on that form, the same method on the 1.5k, the spectrometer toleranced, throughput by band — and the trade restated with both modules at the pixel.</a:t>
             </a:r>
           </a:p>
         </p:txBody>
@@ -21119,7 +21060,7 @@
         </p:nvSpPr>
         <p:spPr>
           <a:xfrm>
-            <a:off x="6400800" y="4075176"/>
+            <a:off x="6400800" y="3992880"/>
             <a:ext cx="5394960" cy="274320"/>
           </a:xfrm>
           <a:prstGeom prst="rect">
@@ -21145,7 +21086,7 @@
                 </a:solidFill>
                 <a:latin typeface="Arial"/>
               </a:rPr>
-              <a:t>Jim's comments of 2026-10-07 in line on the 10-06 note; the paper's numbers on this slide are its Tables 1–3 and Figs. 1 and 4.  Recorded in BRIEF_to_dyson5.md addendum 47.</a:t>
+              <a:t>Jim's comments in line on the 10-06 note; the paper's Tables 1–3 and Figs. 1 and 4.  Recorded in BRIEF_to_dyson5.md addendum 47.  The record deck of 10-06 (deck_dyson_record) stands as the spectrometer's design record.</a:t>
             </a:r>
           </a:p>
         </p:txBody>
@@ -21202,7 +21143,7 @@
                 </a:solidFill>
                 <a:latin typeface="Arial"/>
               </a:rPr>
-              <a:t>The template: a long-slit telescope front end, parameterized</a:t>
+              <a:t>What we did: the 3k solution as a template, then the template on the 1.5k</a:t>
             </a:r>
           </a:p>
           <a:p>
@@ -21218,7 +21159,7 @@
                 </a:solidFill>
                 <a:latin typeface="Arial"/>
               </a:rPr>
-              <a:t>One parameter file, four stages, the constraint rows a slit-fed spectrometer needs; the 3k module is its default run and the slides that follow are that run; the 1.5k is the same flow at another spec (slide 17)</a:t>
+              <a:t>The paper's form became a parameterized design flow — one parameter file, four stages, the constraint rows a slit-fed spectrometer needs — whose default run is the 3k module; run at the 1.5k spec it reached the pixel in five rungs with one new row; the slides that follow are those two runs</a:t>
             </a:r>
           </a:p>
         </p:txBody>
@@ -21310,7 +21251,7 @@
                 </a:solidFill>
                 <a:latin typeface="Arial"/>
               </a:rPr>
-              <a:t>What it designs:</a:t>
+              <a:t>The 3k solution (slides 8–14):</a:t>
             </a:r>
             <a:r>
               <a:rPr sz="1200" b="0">
@@ -21319,16 +21260,7 @@
                 </a:solidFill>
                 <a:latin typeface="Arial"/>
               </a:rPr>
-              <a:t> a three-mirror telescope of the SBG zig-zag form (weak concave M1, a small convex M2 at the stop, M3 with nearly all the power, no intermediate focus) that images a strip of sky onto a straight slit, </a:t>
-            </a:r>
-            <a:r>
-              <a:rPr sz="1200" b="1">
-                <a:solidFill>
-                  <a:srgbClr val="282828"/>
-                </a:solidFill>
-                <a:latin typeface="Arial"/>
-              </a:rPr>
-              <a:t>telecentric</a:t>
+              <a:t> the paper's layout digitized and scaled to Joe's focal length is the seed; the first order is closed-form telecentric with the stop at M2; three off-axis conic sections carry it; a pole-frame polynomial of degree 3–6 on each mirror brings every field of the 9.4° strip to a 1.02-pixel spot with the cone bounded; joined to the 240 mm </a:t>
             </a:r>
             <a:r>
               <a:rPr sz="1200" b="0">
@@ -21337,16 +21269,16 @@
                 </a:solidFill>
                 <a:latin typeface="Arial"/>
               </a:rPr>
-              <a:t> at the slit, with a </a:t>
-            </a:r>
-            <a:r>
-              <a:rPr sz="1200" b="1">
-                <a:solidFill>
-                  <a:srgbClr val="282828"/>
-                </a:solidFill>
-                <a:latin typeface="Arial"/>
-              </a:rPr>
-              <a:t>bounded cone</a:t>
+              <a:t>CaF</a:t>
+            </a:r>
+            <a:r>
+              <a:rPr sz="1200" b="0" baseline="-25000">
+                <a:solidFill>
+                  <a:srgbClr val="282828"/>
+                </a:solidFill>
+                <a:latin typeface="Arial"/>
+              </a:rPr>
+              <a:t>2</a:t>
             </a:r>
             <a:r>
               <a:rPr sz="1200" b="0">
@@ -21355,7 +21287,7 @@
                 </a:solidFill>
                 <a:latin typeface="Arial"/>
               </a:rPr>
-              <a:t> (no marginal ray faster than the spectrometer accepts, the F/# the same along and across the slit) and a long working distance behind M3.</a:t>
+              <a:t> Dyson it images at the pixel end to end.  Six rungs taught the weights and rows the flow now carries; the last tenth of a pixel of "smile" was the scorer's launch convention, not the optics.</a:t>
             </a:r>
           </a:p>
           <a:p>
@@ -21380,7 +21312,7 @@
                 </a:solidFill>
                 <a:latin typeface="Arial"/>
               </a:rPr>
-              <a:t>What it takes in</a:t>
+              <a:t>Made a template</a:t>
             </a:r>
             <a:r>
               <a:rPr sz="1200" b="0">
@@ -21389,41 +21321,7 @@
                 </a:solidFill>
                 <a:latin typeface="Arial"/>
               </a:rPr>
-              <a:t> (tma_longslit_params.m, the single source of truth): the spec — f, D, F/#, the strip, the slit, the pixel — the seed legs and incidence angles, the telecentric and cone bounds, the working distance, the row weights and the field set, the ladder of rungs, and the spectrometer to join.</a:t>
-            </a:r>
-          </a:p>
-          <a:p>
-            <a:pPr>
-              <a:spcAft>
-                <a:spcPts val="600"/>
-              </a:spcAft>
-            </a:pPr>
-            <a:r>
-              <a:rPr sz="1200" b="0">
-                <a:solidFill>
-                  <a:srgbClr val="282828"/>
-                </a:solidFill>
-                <a:latin typeface="Arial"/>
-              </a:rPr>
-              <a:t>•  </a:t>
-            </a:r>
-            <a:r>
-              <a:rPr sz="1200" b="1">
-                <a:solidFill>
-                  <a:srgbClr val="282828"/>
-                </a:solidFill>
-                <a:latin typeface="Arial"/>
-              </a:rPr>
-              <a:t>Four stages</a:t>
-            </a:r>
-            <a:r>
-              <a:rPr sz="1200" b="0">
-                <a:solidFill>
-                  <a:srgbClr val="282828"/>
-                </a:solidFill>
-                <a:latin typeface="Arial"/>
-              </a:rPr>
-              <a:t> (tma_longslit_run): first_order (paraxial, closed form, no engine); section (three off-axis conics on the chief, the stop an element stop on M2, emitted and measured per field); figure (the ladder: each rung an engine-traced Levenberg–Marquardt solve warm from the rung it names); e2e (the best rung that clears, joined to the spectrometer under both launches and rolls).</a:t>
+              <a:t> (templates/10_telescopes/tma_longslit/): the spec, the seed legs and incidences, the bounds, the weights, the field set, the ladder and the spectrometer to join live in one parameter file; four stages — first_order (closed form), section (the conics on the chief, measured per field), figure (the ladder, each rung an engine-traced solve warm from the last), e2e (the best clear rung joined to the spectrometer under both launches) — each writing its table, record and prescription; the deck of record pinned by a test that re-scores it by name.</a:t>
             </a:r>
           </a:p>
         </p:txBody>
@@ -21471,7 +21369,7 @@
                 </a:solidFill>
                 <a:latin typeface="Arial"/>
               </a:rPr>
-              <a:t>The rows per solve field:</a:t>
+              <a:t>The rows that make it a long-slit front end:</a:t>
             </a:r>
             <a:r>
               <a:rPr sz="1200" b="0">
@@ -21480,7 +21378,7 @@
                 </a:solidFill>
                 <a:latin typeface="Arial"/>
               </a:rPr>
-              <a:t> SPOT (every ray about the as-placed centroid, along-slit weighted); PLATE (the chief against f tan θ); BOW and CBOW (the chief's and the centroid's across-slit position); TELE (the chief angle to the slit normal); CONE (a hinge on the marginal F/# outside the bound, per axis); OFF (chief − centroid across the slit); WD (working distance); and, since the 1.5k run, CLEAR (the clearance rule, a hinge).</a:t>
+              <a:t> spot size along the slit (weighted); plate scale; the chief's and the centroid's across-slit bow; the chief angle to the slit normal (telecentric); a hinge on the marginal F/# outside the bound, per axis (the cone); the chief − centroid offset at the slit; working distance; and, since the 1.5k run, a clearance wall.  The first order is re-derived at every iterate, never penalized, so focal length, back focus and telecentricity hold exactly under the figure.</a:t>
             </a:r>
           </a:p>
           <a:p>
@@ -21505,7 +21403,7 @@
                 </a:solidFill>
                 <a:latin typeface="Arial"/>
               </a:rPr>
-              <a:t>The first order is re-derived, never penalized:</a:t>
+              <a:t>The template on the 1.5k (slide 17):</a:t>
             </a:r>
             <a:r>
               <a:rPr sz="1200" b="0">
@@ -21514,7 +21412,7 @@
                 </a:solidFill>
                 <a:latin typeface="Arial"/>
               </a:rPr>
-              <a:t> the local radii are not DOFs; every iterate re-solves them from the legs and incidences, so focal length, back focus and telecentricity hold exactly.  The figure is a pole-frame polynomial of degree 3–6 on each mirror, so the first order survives it.</a:t>
+              <a:t> the same seed, rows and weights at a ±2.35° strip and a 27 mm slit, joined to the 130 mm silica Dyson: 1.02 px at every field in five rungs; one deviation on the way — the first rung at the floor put the M3 → slit beam 0.3 mm inside M2, and a clearance wall row bought +2.4 mm with the floor held; end to end smile 0.009, CRF 1.03, 0.97 of the energy in a pixel.</a:t>
             </a:r>
           </a:p>
           <a:p>
@@ -21539,7 +21437,7 @@
                 </a:solidFill>
                 <a:latin typeface="Arial"/>
               </a:rPr>
-              <a:t>What it writes:</a:t>
+              <a:t>Then (slides 15–18):</a:t>
             </a:r>
             <a:r>
               <a:rPr sz="1200" b="0">
@@ -21548,7 +21446,7 @@
                 </a:solidFill>
                 <a:latin typeface="Arial"/>
               </a:rPr>
-              <a:t> per stage a table, a .txt record and a .mat; per rung a prescription; the deck of record pinned by the gate tTmaLongslit, which re-scores it by name.</a:t>
+              <a:t> the spectrometer toleranced and its Option B assessed, throughput by band, and the two-of-3k trade restated with both modules at the pixel.</a:t>
             </a:r>
           </a:p>
         </p:txBody>
@@ -21561,7 +21459,7 @@
         </p:nvSpPr>
         <p:spPr>
           <a:xfrm>
-            <a:off x="6400800" y="4727448"/>
+            <a:off x="6400800" y="5123688"/>
             <a:ext cx="5394960" cy="274320"/>
           </a:xfrm>
           <a:prstGeom prst="rect">
@@ -21587,7 +21485,7 @@
                 </a:solidFill>
                 <a:latin typeface="Arial"/>
               </a:rPr>
-              <a:t>templates/10_telescopes/tma_longslit/ (README, the runner, the demo tma_longslit.m, tma_longslit_1k5.m); BRIEF_to_dyson5.md addendum 48.  The dyson5 join (dyson5_t5f) is the spectrometer side's scorer; the template calls it, it does not own it.</a:t>
+              <a:t>BRIEF_to_dyson5.md addenda 48–49; REPORT_dyson5_cprime.md; the template README.  The dyson5 join (dyson5_t5f) is the spectrometer side's scorer; the template calls it, it does not own it.</a:t>
             </a:r>
           </a:p>
         </p:txBody>

</xml_diff>

<commit_message>
deck_dyson_3k: slide 12 title shortened to one line ('How the optimization "ladder" was set: six rungs, three lessons'); edit copy re-synced
Co-Authored-By: Claude Fable 5.1 <noreply@anthropic.com>
</commit_message>
<xml_diff>
--- a/demo_session/deck_dyson_3k.pptx
+++ b/demo_session/deck_dyson_3k.pptx
@@ -5523,7 +5523,7 @@
                 </a:solidFill>
                 <a:latin typeface="Arial"/>
               </a:rPr>
-              <a:t>How the optimization sequence ("ladder") was set: six rungs and three lessons</a:t>
+              <a:t>How the optimization "ladder" was set: six rungs, three lessons</a:t>
             </a:r>
           </a:p>
           <a:p>
@@ -13826,7 +13826,7 @@
                 </a:solidFill>
                 <a:latin typeface="Arial"/>
               </a:rPr>
-              <a:t> How the optimization sequence ("ladder") was set: six rungs and three lessons</a:t>
+              <a:t> How the optimization "ladder" was set: six rungs, three lessons</a:t>
             </a:r>
           </a:p>
         </p:txBody>

</xml_diff>

<commit_message>
deck_dyson_3k: retitled 'A Long-Slit Spectrometer Design Challenge' and the first slides rewritten for a new reader, depersonalized (Dave) -- the challenge posed by Joe Green and Jim McGuire as a test of MACOS and its design layer; slide 3 the specification and the scoring; slide 4 the challenge (the instrument, the two module sizes defined, a Dyson and a telescope per module, where round one left it, the answers that set this round, the published design); slide 5 the approach; later references to the challenge's numbers depersonalized; edit copy synced
Co-Authored-By: Claude Fable 5.1 <noreply@anthropic.com>
</commit_message>
<xml_diff>
--- a/demo_session/deck_dyson_3k.pptx
+++ b/demo_session/deck_dyson_3k.pptx
@@ -3149,7 +3149,7 @@
                 </a:solidFill>
                 <a:latin typeface="Arial"/>
               </a:rPr>
-              <a:t>A Long-Slit Telescope Template: the 3k and 1.5k Dyson Modules at the Pixel</a:t>
+              <a:t>A Long-Slit Spectrometer Design Challenge</a:t>
             </a:r>
           </a:p>
           <a:p>
@@ -3165,7 +3165,7 @@
                 </a:solidFill>
                 <a:latin typeface="Arial"/>
               </a:rPr>
-              <a:t>The design flow for a three-mirror telescope feeding a slit-fed spectrometer, established on the 3k module — the SBG VSWIR form at Joe's specification: smile 0.02, CRF 1.17 px, 0.85 of the energy in a pixel over the 9.4° strip — and applied to the 1.5k: smile 0.009, CRF 1.03, 0.97 in a pixel.</a:t>
+              <a:t>A VSWIR imaging spectrometer for a 180 km swath at 30 m pixels, designed end to end by ray trace: a Dyson spectrometer and a freeform three-mirror telescope per module, two module sizes, both at the pixel — smile 0.02, CRF 1.2 px, 0.85–0.97 of the energy in one pixel — and the telescope flow made a reusable template.</a:t>
             </a:r>
           </a:p>
           <a:p>
@@ -3252,7 +3252,7 @@
                 </a:solidFill>
                 <a:latin typeface="Arial"/>
               </a:rPr>
-              <a:t>Since the 2026-10-06 deck: Jim's answers and the project's paper settled the trade toward two 3k modules and pointed at the telescope form.  The form became a template; its default run is the 3k module at the pixel, and at the 1.5k spec it reached the pixel in five rungs with one new row.  Both modules meet the specification end to end; SRF is the two-pixel slit's floor.</a:t>
+              <a:t>The challenge was posed by Joe Green and Jim McGuire (JPL) as a test of MACOS and its design layer; this is its second round.  The first (2026-10-06) brought the spectrometers to the pixel and left the larger telescope short; their answers and the project's published design set this round's course.</a:t>
             </a:r>
           </a:p>
         </p:txBody>
@@ -3325,7 +3325,7 @@
                 </a:solidFill>
                 <a:latin typeface="Arial"/>
               </a:rPr>
-              <a:t>Both meet Joe's specification; together they image at the pixel over the strip; SRF is the two-pixel slit's floor</a:t>
+              <a:t>Both meet the challenge's specification; together they image at the pixel over the strip; SRF is the two-pixel slit's floor</a:t>
             </a:r>
           </a:p>
         </p:txBody>
@@ -3435,7 +3435,7 @@
                           </a:solidFill>
                           <a:latin typeface="Arial"/>
                         </a:rPr>
-                        <a:t>Joe</a:t>
+                        <a:t>challenge</a:t>
                       </a:r>
                     </a:p>
                   </a:txBody>
@@ -13419,7 +13419,7 @@
                 </a:solidFill>
                 <a:latin typeface="Arial"/>
               </a:rPr>
-              <a:t>What we did; the pair of 3k modules; the template's default run — seed, telescope of record, the module scored, how the ladder was set, the two smile conventions, the cone; the spectrometer; the template applied to the 1.5k; the comparison; the questions</a:t>
+              <a:t>The challenge and the approach; the pair of 3k modules; the template's default run — seed, telescope of record, the module scored, how the ladder was set, the two smile conventions, the cone; the spectrometer; the template applied to the 1.5k; the comparison; the questions</a:t>
             </a:r>
           </a:p>
         </p:txBody>
@@ -13520,7 +13520,7 @@
                 </a:solidFill>
                 <a:latin typeface="Arial"/>
               </a:rPr>
-              <a:t> The target and how it is scored</a:t>
+              <a:t> The specification, and how a design is scored against it</a:t>
             </a:r>
           </a:p>
           <a:p>
@@ -13554,7 +13554,7 @@
                 </a:solidFill>
                 <a:latin typeface="Arial"/>
               </a:rPr>
-              <a:t> What we did: the challenge, and the background we were given</a:t>
+              <a:t> The challenge: two module sizes, a spectrometer and a telescope in each</a:t>
             </a:r>
           </a:p>
           <a:p>
@@ -13588,7 +13588,7 @@
                 </a:solidFill>
                 <a:latin typeface="Arial"/>
               </a:rPr>
-              <a:t> What we did: the 3k solution as a template, then the template on the 1.5k</a:t>
+              <a:t> The approach: the 3k telescope solved as a template, the template run on the 1.5k</a:t>
             </a:r>
           </a:p>
           <a:p>
@@ -18880,7 +18880,7 @@
         </p:nvGraphicFramePr>
         <p:xfrm>
           <a:off x="411480" y="1298448"/>
-          <a:ext cx="11368735" cy="3549015"/>
+          <a:ext cx="11368735" cy="3737610"/>
         </p:xfrm>
         <a:graphic>
           <a:graphicData uri="http://schemas.openxmlformats.org/drawingml/2006/table">
@@ -18889,8 +18889,8 @@
                 <a:tableStyleId>{5C22544A-7EE6-4342-B048-85BDC9FD1C3A}</a:tableStyleId>
               </a:tblPr>
               <a:tblGrid>
-                <a:gridCol w="582168"/>
-                <a:gridCol w="10786567"/>
+                <a:gridCol w="654812"/>
+                <a:gridCol w="10713923"/>
               </a:tblGrid>
               <a:tr h="280035">
                 <a:tc>
@@ -18938,20 +18938,20 @@
                   </a:tcPr>
                 </a:tc>
               </a:tr>
-              <a:tr h="280035">
-                <a:tc>
-                  <a:txBody>
-                    <a:bodyPr wrap="square"/>
-                    <a:lstStyle/>
-                    <a:p>
-                      <a:r>
-                        <a:rPr sz="1100" b="0">
-                          <a:solidFill>
-                            <a:srgbClr val="282828"/>
-                          </a:solidFill>
-                          <a:latin typeface="Arial"/>
-                        </a:rPr>
-                        <a:t>4, 5</a:t>
+              <a:tr h="468630">
+                <a:tc>
+                  <a:txBody>
+                    <a:bodyPr wrap="square"/>
+                    <a:lstStyle/>
+                    <a:p>
+                      <a:r>
+                        <a:rPr sz="1100" b="0">
+                          <a:solidFill>
+                            <a:srgbClr val="282828"/>
+                          </a:solidFill>
+                          <a:latin typeface="Arial"/>
+                        </a:rPr>
+                        <a:t>3, 4, 5</a:t>
                       </a:r>
                     </a:p>
                   </a:txBody>
@@ -19456,7 +19456,7 @@
         </p:nvSpPr>
         <p:spPr>
           <a:xfrm>
-            <a:off x="411480" y="4993767"/>
+            <a:off x="411480" y="5182362"/>
             <a:ext cx="11368735" cy="274320"/>
           </a:xfrm>
           <a:prstGeom prst="rect">
@@ -19539,7 +19539,7 @@
                 </a:solidFill>
                 <a:latin typeface="Arial"/>
               </a:rPr>
-              <a:t>The target and how it is scored</a:t>
+              <a:t>The specification, and how a design is scored against it</a:t>
             </a:r>
           </a:p>
           <a:p>
@@ -19555,7 +19555,7 @@
                 </a:solidFill>
                 <a:latin typeface="Arial"/>
               </a:rPr>
-              <a:t>Joe's specification at Jim's ground sample; the metrics stated once, with the paper's bounds in the same units</a:t>
+              <a:t>The challenge's numbers beside the project's published design (the SBG VSWIR paper), the metrics defined once, the paper's bounds converted to this work's pixel</a:t>
             </a:r>
           </a:p>
         </p:txBody>
@@ -19614,7 +19614,7 @@
         </p:nvGraphicFramePr>
         <p:xfrm>
           <a:off x="411480" y="1298448"/>
-          <a:ext cx="5806438" cy="4211955"/>
+          <a:ext cx="5806438" cy="4589145"/>
         </p:xfrm>
         <a:graphic>
           <a:graphicData uri="http://schemas.openxmlformats.org/drawingml/2006/table">
@@ -19627,7 +19627,7 @@
                 <a:gridCol w="1512945"/>
                 <a:gridCol w="2780548"/>
               </a:tblGrid>
-              <a:tr h="280035">
+              <a:tr h="468630">
                 <a:tc>
                   <a:txBody>
                     <a:bodyPr wrap="square"/>
@@ -19662,7 +19662,7 @@
                           </a:solidFill>
                           <a:latin typeface="Arial"/>
                         </a:rPr>
-                        <a:t>Joe (this work)</a:t>
+                        <a:t>the challenge (this work)</a:t>
                       </a:r>
                     </a:p>
                   </a:txBody>
@@ -20307,7 +20307,7 @@
                   </a:tcPr>
                 </a:tc>
               </a:tr>
-              <a:tr h="280035">
+              <a:tr h="468630">
                 <a:tc>
                   <a:txBody>
                     <a:bodyPr wrap="square"/>
@@ -20342,7 +20342,7 @@
                           </a:solidFill>
                           <a:latin typeface="Arial"/>
                         </a:rPr>
-                        <a:t>9.4° (3k)</a:t>
+                        <a:t>9.4° (the 3k module); 4.7° (the 1.5k)</a:t>
                       </a:r>
                     </a:p>
                   </a:txBody>
@@ -20681,7 +20681,7 @@
                 </a:solidFill>
                 <a:latin typeface="Arial"/>
               </a:rPr>
-              <a:t>What we did: the challenge, and the background we were given</a:t>
+              <a:t>The challenge: two module sizes, a spectrometer and a telescope in each</a:t>
             </a:r>
           </a:p>
           <a:p>
@@ -20697,7 +20697,7 @@
                 </a:solidFill>
                 <a:latin typeface="Arial"/>
               </a:rPr>
-              <a:t>An imaging spectrometer for a 180 km swath at 30 m pixels: a Dyson spectrometer per module, a telescope feeding its slit, two module sizes to trade; the last deck had the spectrometers at the pixel and the telescopes not; Jim's answers and the project's paper set the course</a:t>
+              <a:t>6000 cross-track pixels over a 180 km swath, 380–2500 nm, F/1.8, at the pixel in smile, keystone and response width; two 3k modules or four 1.5k; every number a MACOS ray trace of a committed prescription</a:t>
             </a:r>
           </a:p>
         </p:txBody>
@@ -20789,7 +20789,7 @@
                 </a:solidFill>
                 <a:latin typeface="Arial"/>
               </a:rPr>
-              <a:t>The challenge (Jim, Joe):</a:t>
+              <a:t>The instrument:</a:t>
             </a:r>
             <a:r>
               <a:rPr sz="1200" b="0">
@@ -20798,70 +20798,7 @@
                 </a:solidFill>
                 <a:latin typeface="Arial"/>
               </a:rPr>
-              <a:t> 6000 cross-track pixels of 18 µm over the swath, 380–2500 nm in 500 spectral pixels, F/1.8, f 330 mm, D 183 mm, smile and keystone under a tenth of a pixel, CRF under 1.5 px, SRF 1.5–2.0 px — as either </a:t>
-            </a:r>
-            <a:r>
-              <a:rPr sz="1200" b="1">
-                <a:solidFill>
-                  <a:srgbClr val="282828"/>
-                </a:solidFill>
-                <a:latin typeface="Arial"/>
-              </a:rPr>
-              <a:t>two 3k modules</a:t>
-            </a:r>
-            <a:r>
-              <a:rPr sz="1200" b="0">
-                <a:solidFill>
-                  <a:srgbClr val="282828"/>
-                </a:solidFill>
-                <a:latin typeface="Arial"/>
-              </a:rPr>
-              <a:t> (54 mm slits, 240 mm </a:t>
-            </a:r>
-            <a:r>
-              <a:rPr sz="1200" b="0">
-                <a:solidFill>
-                  <a:srgbClr val="282828"/>
-                </a:solidFill>
-                <a:latin typeface="Arial"/>
-              </a:rPr>
-              <a:t>CaF</a:t>
-            </a:r>
-            <a:r>
-              <a:rPr sz="1200" b="0" baseline="-25000">
-                <a:solidFill>
-                  <a:srgbClr val="282828"/>
-                </a:solidFill>
-                <a:latin typeface="Arial"/>
-              </a:rPr>
-              <a:t>2</a:t>
-            </a:r>
-            <a:r>
-              <a:rPr sz="1200" b="0">
-                <a:solidFill>
-                  <a:srgbClr val="282828"/>
-                </a:solidFill>
-                <a:latin typeface="Arial"/>
-              </a:rPr>
-              <a:t> Dysons) or </a:t>
-            </a:r>
-            <a:r>
-              <a:rPr sz="1200" b="1">
-                <a:solidFill>
-                  <a:srgbClr val="282828"/>
-                </a:solidFill>
-                <a:latin typeface="Arial"/>
-              </a:rPr>
-              <a:t>four 1.5k modules</a:t>
-            </a:r>
-            <a:r>
-              <a:rPr sz="1200" b="0">
-                <a:solidFill>
-                  <a:srgbClr val="282828"/>
-                </a:solidFill>
-                <a:latin typeface="Arial"/>
-              </a:rPr>
-              <a:t> (27 mm slits, 130 mm silica Dysons).  Every number by MACOS ray trace of a committed prescription.</a:t>
+              <a:t> a push-broom imaging spectrometer — a straight slit imaged on the ground, swept along the track; the spectrometer disperses the slit across a 500-pixel band at 18 µm pixels.  The challenge fixes F/1.8, a 330 mm focal length, a 183 mm aperture, and the image-quality bounds of slide 3.</a:t>
             </a:r>
           </a:p>
           <a:p>
@@ -20886,7 +20823,7 @@
                 </a:solidFill>
                 <a:latin typeface="Arial"/>
               </a:rPr>
-              <a:t>Where the last deck (2026-10-06) left it:</a:t>
+              <a:t>The two module sizes.</a:t>
             </a:r>
             <a:r>
               <a:rPr sz="1200" b="0">
@@ -20895,7 +20832,70 @@
                 </a:solidFill>
                 <a:latin typeface="Arial"/>
               </a:rPr>
-              <a:t> both Dyson spectrometers at the pixel; the 1.5k telescope (three off-axis aspheres) near it; the 3k telescope not — CRF 4 px, 4–10 % of the energy in a pixel, marginal rays at F/1.2 into an F/1.8 spectrometer.</a:t>
+              <a:t>  A </a:t>
+            </a:r>
+            <a:r>
+              <a:rPr sz="1200" b="1">
+                <a:solidFill>
+                  <a:srgbClr val="282828"/>
+                </a:solidFill>
+                <a:latin typeface="Arial"/>
+              </a:rPr>
+              <a:t>3k module</a:t>
+            </a:r>
+            <a:r>
+              <a:rPr sz="1200" b="0">
+                <a:solidFill>
+                  <a:srgbClr val="282828"/>
+                </a:solidFill>
+                <a:latin typeface="Arial"/>
+              </a:rPr>
+              <a:t> has a 3000-pixel, 54 mm slit and needs a 240 mm </a:t>
+            </a:r>
+            <a:r>
+              <a:rPr sz="1200" b="0">
+                <a:solidFill>
+                  <a:srgbClr val="282828"/>
+                </a:solidFill>
+                <a:latin typeface="Arial"/>
+              </a:rPr>
+              <a:t>CaF</a:t>
+            </a:r>
+            <a:r>
+              <a:rPr sz="1200" b="0" baseline="-25000">
+                <a:solidFill>
+                  <a:srgbClr val="282828"/>
+                </a:solidFill>
+                <a:latin typeface="Arial"/>
+              </a:rPr>
+              <a:t>2</a:t>
+            </a:r>
+            <a:r>
+              <a:rPr sz="1200" b="0">
+                <a:solidFill>
+                  <a:srgbClr val="282828"/>
+                </a:solidFill>
+                <a:latin typeface="Arial"/>
+              </a:rPr>
+              <a:t> Dyson block; two of them cover the swath.  A </a:t>
+            </a:r>
+            <a:r>
+              <a:rPr sz="1200" b="1">
+                <a:solidFill>
+                  <a:srgbClr val="282828"/>
+                </a:solidFill>
+                <a:latin typeface="Arial"/>
+              </a:rPr>
+              <a:t>1.5k module</a:t>
+            </a:r>
+            <a:r>
+              <a:rPr sz="1200" b="0">
+                <a:solidFill>
+                  <a:srgbClr val="282828"/>
+                </a:solidFill>
+                <a:latin typeface="Arial"/>
+              </a:rPr>
+              <a:t> has a 1500-pixel, 27 mm slit and a 130 mm fused-silica block; four are needed.  Which to build is the trade the challenge asks for.</a:t>
             </a:r>
           </a:p>
           <a:p>
@@ -20920,7 +20920,7 @@
                 </a:solidFill>
                 <a:latin typeface="Arial"/>
               </a:rPr>
-              <a:t>What Jim answered (2026-10-07):</a:t>
+              <a:t>Each module is a Dyson spectrometer and a telescope.</a:t>
             </a:r>
             <a:r>
               <a:rPr sz="1200" b="0">
@@ -20929,7 +20929,7 @@
                 </a:solidFill>
                 <a:latin typeface="Arial"/>
               </a:rPr>
-              <a:t> two modules, not four — integration, test and calibration are the cost, not mass or glass, and 3k × 0.5k detectors are a standard format where 1.5k × 0.5k is NRE; design the telescope separately, telecentric at the slit, a little faster than the spectrometer, no F/1.2 rays; the window is an order-sorting filter in air (six crossings); tailor the AR and the blaze to the photon-starved long end; the Offner does not go below F/3.</a:t>
+              <a:t>  The Dyson (a concentric block with a concave grating on its curved face) was designed first and brought to the pixel in the first round; the telescope images a strip of sky onto the slit, telecentric there, with no marginal ray faster than the spectrometer accepts.</a:t>
             </a:r>
           </a:p>
         </p:txBody>
@@ -20977,7 +20977,7 @@
                 </a:solidFill>
                 <a:latin typeface="Arial"/>
               </a:rPr>
-              <a:t>What the paper gave us</a:t>
+              <a:t>Where the first round left it (2026-10-06):</a:t>
             </a:r>
             <a:r>
               <a:rPr sz="1200" b="0">
@@ -20986,34 +20986,7 @@
                 </a:solidFill>
                 <a:latin typeface="Arial"/>
               </a:rPr>
-              <a:t> (Bradley et al., ICSO 2024, the SBG VSWIR design): the telescope form — a freeform zig-zag three-mirror anastigmat at f 345 mm, 192 mm, 8.9°, with a small convex M2 at the stop and no intermediate focus — optimized alone for small spots along the slit under constraints on F/# anamorphicity, clearance and working distance; its Dyson an aspheric </a:t>
-            </a:r>
-            <a:r>
-              <a:rPr sz="1200" b="0">
-                <a:solidFill>
-                  <a:srgbClr val="282828"/>
-                </a:solidFill>
-                <a:latin typeface="Arial"/>
-              </a:rPr>
-              <a:t>CaF</a:t>
-            </a:r>
-            <a:r>
-              <a:rPr sz="1200" b="0" baseline="-25000">
-                <a:solidFill>
-                  <a:srgbClr val="282828"/>
-                </a:solidFill>
-                <a:latin typeface="Arial"/>
-              </a:rPr>
-              <a:t>2</a:t>
-            </a:r>
-            <a:r>
-              <a:rPr sz="1200" b="0">
-                <a:solidFill>
-                  <a:srgbClr val="282828"/>
-                </a:solidFill>
-                <a:latin typeface="Arial"/>
-              </a:rPr>
-              <a:t> lens with a conic grating (their Option B); its bounds in micrometers (smile and keystone 1.8 µm; SRF 64.8 µm in co-added pixels; CRF and ARF 50.4 µm), which slide 3 converts to our pixel.</a:t>
+              <a:t> both Dysons at the pixel; the 1.5k telescope (three off-axis aspheres) near it; the 3k telescope not — CRF 4 px, 4–10 % of the energy in a pixel, marginal rays at F/1.2 into an F/1.8 spectrometer.</a:t>
             </a:r>
           </a:p>
           <a:p>
@@ -21038,7 +21011,7 @@
                 </a:solidFill>
                 <a:latin typeface="Arial"/>
               </a:rPr>
-              <a:t>So the work of this round</a:t>
+              <a:t>The answers that set this round's course:</a:t>
             </a:r>
             <a:r>
               <a:rPr sz="1200" b="0">
@@ -21047,7 +21020,68 @@
                 </a:solidFill>
                 <a:latin typeface="Arial"/>
               </a:rPr>
-              <a:t> was the 3k telescope to the pixel on that form, the same method on the 1.5k, the spectrometer toleranced, throughput by band — and the trade restated with both modules at the pixel.</a:t>
+              <a:t> two modules, not four — integration, test and calibration are the cost, not mass or glass, and 3k × 0.5k detectors are a standard format where 1.5k × 0.5k is not; design the telescope separately, telecentric at the slit, a little faster than the spectrometer, no F/1.2 rays; the detector window is an order-sorting filter in air; tailor the coatings and the grating's blaze to the photon-starved long end.</a:t>
+            </a:r>
+          </a:p>
+          <a:p>
+            <a:pPr>
+              <a:spcAft>
+                <a:spcPts val="600"/>
+              </a:spcAft>
+            </a:pPr>
+            <a:r>
+              <a:rPr sz="1200" b="0">
+                <a:solidFill>
+                  <a:srgbClr val="282828"/>
+                </a:solidFill>
+                <a:latin typeface="Arial"/>
+              </a:rPr>
+              <a:t>•  </a:t>
+            </a:r>
+            <a:r>
+              <a:rPr sz="1200" b="1">
+                <a:solidFill>
+                  <a:srgbClr val="282828"/>
+                </a:solidFill>
+                <a:latin typeface="Arial"/>
+              </a:rPr>
+              <a:t>The project's published design</a:t>
+            </a:r>
+            <a:r>
+              <a:rPr sz="1200" b="0">
+                <a:solidFill>
+                  <a:srgbClr val="282828"/>
+                </a:solidFill>
+                <a:latin typeface="Arial"/>
+              </a:rPr>
+              <a:t> (Bradley et al., ICSO 2024): a freeform zig-zag three-mirror telescope at f 345 mm, 192 mm, 8.9°, with a small convex M2 at the stop and no intermediate focus, optimized alone for small spots along the slit; a Dyson with an aspheric </a:t>
+            </a:r>
+            <a:r>
+              <a:rPr sz="1200" b="0">
+                <a:solidFill>
+                  <a:srgbClr val="282828"/>
+                </a:solidFill>
+                <a:latin typeface="Arial"/>
+              </a:rPr>
+              <a:t>CaF</a:t>
+            </a:r>
+            <a:r>
+              <a:rPr sz="1200" b="0" baseline="-25000">
+                <a:solidFill>
+                  <a:srgbClr val="282828"/>
+                </a:solidFill>
+                <a:latin typeface="Arial"/>
+              </a:rPr>
+              <a:t>2</a:t>
+            </a:r>
+            <a:r>
+              <a:rPr sz="1200" b="0">
+                <a:solidFill>
+                  <a:srgbClr val="282828"/>
+                </a:solidFill>
+                <a:latin typeface="Arial"/>
+              </a:rPr>
+              <a:t> lens and a conic grating (their Option B); its bounds in micrometers (smile and keystone 1.8 µm; SRF 64.8 µm; CRF and ARF 50.4 µm).</a:t>
             </a:r>
           </a:p>
         </p:txBody>
@@ -21060,7 +21094,7 @@
         </p:nvSpPr>
         <p:spPr>
           <a:xfrm>
-            <a:off x="6400800" y="3992880"/>
+            <a:off x="6400800" y="5123687"/>
             <a:ext cx="5394960" cy="274320"/>
           </a:xfrm>
           <a:prstGeom prst="rect">
@@ -21086,7 +21120,7 @@
                 </a:solidFill>
                 <a:latin typeface="Arial"/>
               </a:rPr>
-              <a:t>Jim's comments in line on the 10-06 note; the paper's Tables 1–3 and Figs. 1 and 4.  Recorded in BRIEF_to_dyson5.md addendum 47.  The record deck of 10-06 (deck_dyson_record) stands as the spectrometer's design record.</a:t>
+              <a:t>The challenge and the first-round answers are recorded in BRIEF_to_dyson5.md (addenda 47–49); the first round's deck is deck_dyson_record (the spectrometers' design record).  The paper: Tables 1–3, Figs. 1 and 4.</a:t>
             </a:r>
           </a:p>
         </p:txBody>
@@ -21143,7 +21177,7 @@
                 </a:solidFill>
                 <a:latin typeface="Arial"/>
               </a:rPr>
-              <a:t>What we did: the 3k solution as a template, then the template on the 1.5k</a:t>
+              <a:t>The approach: the 3k telescope solved as a template, the template run on the 1.5k</a:t>
             </a:r>
           </a:p>
           <a:p>
@@ -21159,7 +21193,7 @@
                 </a:solidFill>
                 <a:latin typeface="Arial"/>
               </a:rPr>
-              <a:t>The paper's form became a parameterized design flow — one parameter file, four stages, the constraint rows a slit-fed spectrometer needs — whose default run is the 3k module; run at the 1.5k spec it reached the pixel in five rungs with one new row; the slides that follow are those two runs</a:t>
+              <a:t>The published form became a parameterized design flow — one parameter file, four stages, the constraint rows a slit-fed spectrometer needs — whose default run is the 3k module; run at the 1.5k spec it reached the pixel in five rungs with one new row; the slides that follow are those two runs</a:t>
             </a:r>
           </a:p>
         </p:txBody>
@@ -21251,7 +21285,7 @@
                 </a:solidFill>
                 <a:latin typeface="Arial"/>
               </a:rPr>
-              <a:t>The 3k solution (slides 8–14):</a:t>
+              <a:t>The 3k telescope (slides 8–14):</a:t>
             </a:r>
             <a:r>
               <a:rPr sz="1200" b="0">
@@ -21260,7 +21294,7 @@
                 </a:solidFill>
                 <a:latin typeface="Arial"/>
               </a:rPr>
-              <a:t> the paper's layout digitized and scaled to Joe's focal length is the seed; the first order is closed-form telecentric with the stop at M2; three off-axis conic sections carry it; a pole-frame polynomial of degree 3–6 on each mirror brings every field of the 9.4° strip to a 1.02-pixel spot with the cone bounded; joined to the 240 mm </a:t>
+              <a:t> the published layout digitized and scaled to the challenge's focal length is the seed; the first order is closed-form telecentric with the stop at M2; three off-axis conic sections carry it; a pole-frame polynomial of degree 3–6 on each mirror brings every field of the 9.4° strip to a 1.02-pixel spot with the cone bounded; joined to the 240 mm </a:t>
             </a:r>
             <a:r>
               <a:rPr sz="1200" b="0">
@@ -22326,7 +22360,7 @@
                 </a:solidFill>
                 <a:latin typeface="Arial"/>
               </a:rPr>
-              <a:t>The paper's layout digitized and scaled to Joe's focal length; with the stop at M2 the first order is telecentric in closed form, has no intermediate focus, and gives 299 mm of working distance for the Dyson</a:t>
+              <a:t>The published layout digitized and scaled to the challenge's focal length; with the stop at M2 the first order is telecentric in closed form, has no intermediate focus, and gives 299 mm of working distance for the Dyson</a:t>
             </a:r>
           </a:p>
         </p:txBody>

</xml_diff>

<commit_message>
deck_dyson_3k (Dave's four notes): slide 5 as terse sub-bullets under five heads; slide 10 the best number per spec-challenged row in bold; slide 13 retitled 'Smile end to end: the specification read two ways' with smile defined and the coma mechanism in plain words (the chief-angle suspect cleared, the chief-centroid offset predicts every rung, the two placements); slide 14 'The speed of the light at the slit, and the paper's larger beam' with cone/row/hinge replaced by plain language; cross-references follow
Co-Authored-By: Claude Fable 5.1 <noreply@anthropic.com>
</commit_message>
<xml_diff>
--- a/demo_session/deck_dyson_3k.pptx
+++ b/demo_session/deck_dyson_3k.pptx
@@ -6822,7 +6822,7 @@
                 </a:solidFill>
                 <a:latin typeface="Arial"/>
               </a:rPr>
-              <a:t>The remaining 0.14 px of "smile" was the launch convention</a:t>
+              <a:t>The remaining 0.14 px of "smile" was the point-source placement on the slit</a:t>
             </a:r>
             <a:r>
               <a:rPr sz="1500" b="0">
@@ -6862,7 +6862,7 @@
         </p:nvSpPr>
         <p:spPr>
           <a:xfrm>
-            <a:off x="411480" y="6468237"/>
+            <a:off x="411480" y="6715887"/>
             <a:ext cx="11368735" cy="274320"/>
           </a:xfrm>
           <a:prstGeom prst="rect">
@@ -6945,7 +6945,7 @@
                 </a:solidFill>
                 <a:latin typeface="Arial"/>
               </a:rPr>
-              <a:t>Smile is a convention: the launch, not the optics</a:t>
+              <a:t>Smile end to end: the specification read two ways</a:t>
             </a:r>
           </a:p>
           <a:p>
@@ -6961,7 +6961,7 @@
                 </a:solidFill>
                 <a:latin typeface="Arial"/>
               </a:rPr>
-              <a:t>The join lands each field's chief ray on the slit line and scores the centroid, so the telescope's coma — the chief-minus-centroid offset across the slit — read as smile; the Dyson fed with the telescope's chief angles does not move</a:t>
+              <a:t>Smile is the spectrometer's sideways drift of a wavelength's image along the slit; scored end to end it depends on where each field point is placed on the slit, and one placement adds the telescope's coma</a:t>
             </a:r>
           </a:p>
         </p:txBody>
@@ -7020,7 +7020,7 @@
         </p:nvGraphicFramePr>
         <p:xfrm>
           <a:off x="411480" y="1298448"/>
-          <a:ext cx="5806439" cy="2057400"/>
+          <a:ext cx="5806440" cy="1868805"/>
         </p:xfrm>
         <a:graphic>
           <a:graphicData uri="http://schemas.openxmlformats.org/drawingml/2006/table">
@@ -7029,7 +7029,7 @@
                 <a:tableStyleId>{5C22544A-7EE6-4342-B048-85BDC9FD1C3A}</a:tableStyleId>
               </a:tblPr>
               <a:tblGrid>
-                <a:gridCol w="3477767"/>
+                <a:gridCol w="3477768"/>
                 <a:gridCol w="582168"/>
                 <a:gridCol w="727456"/>
                 <a:gridCol w="509524"/>
@@ -7048,7 +7048,7 @@
                           </a:solidFill>
                           <a:latin typeface="Arial"/>
                         </a:rPr>
-                        <a:t>Dyson alone, each slit point's chief tilted by R7's angles</a:t>
+                        <a:t>Dyson alone, each slit point's input ray tilted by the telescope's angles</a:t>
                       </a:r>
                     </a:p>
                   </a:txBody>
@@ -7259,20 +7259,20 @@
                   </a:tcPr>
                 </a:tc>
               </a:tr>
-              <a:tr h="468630">
-                <a:tc>
-                  <a:txBody>
-                    <a:bodyPr wrap="square"/>
-                    <a:lstStyle/>
-                    <a:p>
-                      <a:r>
-                        <a:rPr sz="1100" b="0">
-                          <a:solidFill>
-                            <a:srgbClr val="282828"/>
-                          </a:solidFill>
-                          <a:latin typeface="Arial"/>
-                        </a:rPr>
-                        <a:t>along-track component (−0.51 mrad at the strip end)</a:t>
+              <a:tr h="280035">
+                <a:tc>
+                  <a:txBody>
+                    <a:bodyPr wrap="square"/>
+                    <a:lstStyle/>
+                    <a:p>
+                      <a:r>
+                        <a:rPr sz="1100" b="0">
+                          <a:solidFill>
+                            <a:srgbClr val="282828"/>
+                          </a:solidFill>
+                          <a:latin typeface="Arial"/>
+                        </a:rPr>
+                        <a:t>along-track tilt (−0.51 mrad at the strip end)</a:t>
                       </a:r>
                     </a:p>
                   </a:txBody>
@@ -7384,7 +7384,7 @@
                           </a:solidFill>
                           <a:latin typeface="Arial"/>
                         </a:rPr>
-                        <a:t>cross-track component (±0.27 mrad)</a:t>
+                        <a:t>cross-track tilt (±0.27 mrad)</a:t>
                       </a:r>
                     </a:p>
                   </a:txBody>
@@ -7719,7 +7719,7 @@
         </p:nvSpPr>
         <p:spPr>
           <a:xfrm>
-            <a:off x="411480" y="3502152"/>
+            <a:off x="411480" y="3313557"/>
             <a:ext cx="5806440" cy="274320"/>
           </a:xfrm>
           <a:prstGeom prst="rect">
@@ -7754,7 +7754,7 @@
                 </a:solidFill>
                 <a:latin typeface="Arial"/>
               </a:rPr>
-              <a:t>The chief angle is not the cause:</a:t>
+              <a:t>The first suspect, cleared:</a:t>
             </a:r>
             <a:r>
               <a:rPr sz="1200" b="0">
@@ -7763,7 +7763,7 @@
                 </a:solidFill>
                 <a:latin typeface="Arial"/>
               </a:rPr>
-              <a:t> keystone moves (the hook is live), smile does not, even at twice the angle.</a:t>
+              <a:t> the telescope's chief rays reach the slit up to 0.5 mrad off its normal, in a pattern shaped like smile.  Feeding the spectrometer alone with those angles moves keystone a little and smile not at all, even at twice the angle.</a:t>
             </a:r>
           </a:p>
         </p:txBody>
@@ -7778,7 +7778,7 @@
         </p:nvGraphicFramePr>
         <p:xfrm>
           <a:off x="6400800" y="1298448"/>
-          <a:ext cx="5394959" cy="1577340"/>
+          <a:ext cx="5394959" cy="1748790"/>
         </p:xfrm>
         <a:graphic>
           <a:graphicData uri="http://schemas.openxmlformats.org/drawingml/2006/table">
@@ -7788,10 +7788,10 @@
               </a:tblPr>
               <a:tblGrid>
                 <a:gridCol w="410464"/>
-                <a:gridCol w="3073772"/>
-                <a:gridCol w="1910723"/>
+                <a:gridCol w="2863433"/>
+                <a:gridCol w="2121062"/>
               </a:tblGrid>
-              <a:tr h="262890">
+              <a:tr h="434340">
                 <a:tc>
                   <a:txBody>
                     <a:bodyPr wrap="square"/>
@@ -7826,7 +7826,7 @@
                           </a:solidFill>
                           <a:latin typeface="Arial"/>
                         </a:rPr>
-                        <a:t>predicted from the telescope's offset</a:t>
+                        <a:t>predicted from the telescope's chief − centroid offset</a:t>
                       </a:r>
                     </a:p>
                   </a:txBody>
@@ -7848,7 +7848,7 @@
                           </a:solidFill>
                           <a:latin typeface="Arial"/>
                         </a:rPr>
-                        <a:t>e2e smile, chief launch</a:t>
+                        <a:t>smile end to end, point-source placement</a:t>
                       </a:r>
                     </a:p>
                   </a:txBody>
@@ -8211,7 +8211,7 @@
         </p:nvSpPr>
         <p:spPr>
           <a:xfrm>
-            <a:off x="6400800" y="3022091"/>
+            <a:off x="6400800" y="3193541"/>
             <a:ext cx="5394960" cy="274320"/>
           </a:xfrm>
           <a:prstGeom prst="rect">
@@ -8246,7 +8246,7 @@
                 </a:solidFill>
                 <a:latin typeface="Arial"/>
               </a:rPr>
-              <a:t>The offset predicts every rung:</a:t>
+              <a:t>The cause:</a:t>
             </a:r>
             <a:r>
               <a:rPr sz="1200" b="0">
@@ -8255,7 +8255,7 @@
                 </a:solidFill>
                 <a:latin typeface="Arial"/>
               </a:rPr>
-              <a:t> on R7 the chief sits 0 / 0.2 / 0.7 / 1.4 / 2.4 µm from the centroid across the slit at 0 / 1.2 / 2.4 / 3.5 / 4.7°; the spread of that offset is the e2e smile.</a:t>
+              <a:t> the telescope's image of a point is slightly comatic, so its center of light sits a little across the slit from its chief ray (on R7: 0 / 0.2 / 0.7 / 1.4 / 2.4 µm at 0 / 1.2 / 2.4 / 3.5 / 4.7° of field).  Place each field's chief ray on the slit line and that offset varies along the slit exactly as a smile would; its spread predicts every rung's number.</a:t>
             </a:r>
           </a:p>
           <a:p>
@@ -8280,7 +8280,7 @@
                 </a:solidFill>
                 <a:latin typeface="Arial"/>
               </a:rPr>
-              <a:t>Two conventions, both reported.</a:t>
+              <a:t>Two placements, both reported.</a:t>
             </a:r>
             <a:r>
               <a:rPr sz="1200" b="0">
@@ -8289,7 +8289,7 @@
                 </a:solidFill>
                 <a:latin typeface="Arial"/>
               </a:rPr>
-              <a:t>  Slit-filled (the paper's: its telescope-fed smile equals its spectrometer-alone smile): each field's centroid on the slit line — the spectrometer's smile, 0.022 px.  Point-source: the chief on the slit line — where a star's spectrum lands, 0.016 px on R9 (0.14 on R7).  R9's row on the offset closed the second without touching the first.</a:t>
+              <a:t>  Slit-filled — an extended scene fills the slit, so each field's center of light is on the slit line; this is the spectrometer's own smile and the paper's convention: 0.022 px.  Point-source — a star's chief ray on the slit line: where its spectrum lands, 0.016 px on R9 (0.14 on R7).  R9's added constraint on the offset closed the second without touching the first.</a:t>
             </a:r>
           </a:p>
         </p:txBody>
@@ -8302,7 +8302,7 @@
         </p:nvSpPr>
         <p:spPr>
           <a:xfrm>
-            <a:off x="6400800" y="5122164"/>
+            <a:off x="6400800" y="5887973"/>
             <a:ext cx="5394960" cy="274320"/>
           </a:xfrm>
           <a:prstGeom prst="rect">
@@ -8328,7 +8328,7 @@
                 </a:solidFill>
                 <a:latin typeface="Arial"/>
               </a:rPr>
-              <a:t>Diagnostic tls_dyson_chief_tilt (the spectrometer alone, the launch tilted per field); the join scorer dyson5_t5f now carries both launches (tel5f_launch chief | centroid), the record's rows reproduce under the first.</a:t>
+              <a:t>Diagnostic tls_dyson_chief_tilt (the spectrometer alone, each input tilted per field); the join scorer dyson5_t5f carries both placements (tel5f_launch chief | centroid); the record's rows reproduce under the first.</a:t>
             </a:r>
           </a:p>
         </p:txBody>
@@ -8385,7 +8385,7 @@
                 </a:solidFill>
                 <a:latin typeface="Arial"/>
               </a:rPr>
-              <a:t>The cone, the spec and the paper's beam</a:t>
+              <a:t>The speed of the light at the slit, and the paper's larger beam</a:t>
             </a:r>
           </a:p>
           <a:p>
@@ -8401,7 +8401,7 @@
                 </a:solidFill>
                 <a:latin typeface="Arial"/>
               </a:rPr>
-              <a:t>The marginal rays leave the telescope between F/1.80 and F/1.89 in the two directions, none below F/1.7; the along-slit F/1.89 is Joe's own aperture at Joe's focal length</a:t>
+              <a:t>The marginal rays reach the slit between F/1.80 and F/1.89 in the two directions, none faster than F/1.7; the F/1.89 along the slit follows from the challenge's own aperture and focal length</a:t>
             </a:r>
           </a:p>
         </p:txBody>
@@ -8493,7 +8493,7 @@
                 </a:solidFill>
                 <a:latin typeface="Arial"/>
               </a:rPr>
-              <a:t>Why it is a row:</a:t>
+              <a:t>Why it had to be constrained:</a:t>
             </a:r>
             <a:r>
               <a:rPr sz="1200" b="0">
@@ -8502,7 +8502,7 @@
                 </a:solidFill>
                 <a:latin typeface="Arial"/>
               </a:rPr>
-              <a:t> the last deck's 3k solve let its marginal rays run to F/1.19 into an F/1.8 spectrometer; the grating, sized for F/1.8, passed 95–98 % of the light, and nothing in the merit knew.  Jim: "I don't see why some rays correspond to an f/1.2 cone."  The paper constrains the F/# anamorphicity.</a:t>
+              <a:t> the first round's 3k solve let some rays reach the slit at F/1.19 — faster than the F/1.8 spectrometer accepts — so its grating, sized for F/1.8, passed only 95–98 % of the light, and nothing in the figure of merit knew.  The paper constrains the same thing (its "F/# anamorphicity" — the F-number must be the same along and across the slit).</a:t>
             </a:r>
           </a:p>
           <a:p>
@@ -8527,7 +8527,7 @@
                 </a:solidFill>
                 <a:latin typeface="Arial"/>
               </a:rPr>
-              <a:t>The row:</a:t>
+              <a:t>The constraint:</a:t>
             </a:r>
             <a:r>
               <a:rPr sz="1200" b="0">
@@ -8536,7 +8536,7 @@
                 </a:solidFill>
                 <a:latin typeface="Arial"/>
               </a:rPr>
-              <a:t> a hinge on the working F/# of the marginal rays at the slit, along and across, outside [1.7, 1.8], in every rung.  R9: F/1.889–1.894 along the slit, F/1.797–1.806 across; the grating admits 98.9 % at every field.</a:t>
+              <a:t> in every rung, a penalty on the F-number of the marginal rays at the slit, along and across, whenever it falls outside 1.7–1.8.  R9: F/1.889–1.894 along the slit, F/1.797–1.806 across; the grating admits 98.9 % of the light at every field.</a:t>
             </a:r>
           </a:p>
         </p:txBody>
@@ -8584,7 +8584,7 @@
                 </a:solidFill>
                 <a:latin typeface="Arial"/>
               </a:rPr>
-              <a:t>Along the slit it sits above 1.8, and that is the specification:</a:t>
+              <a:t>Along the slit it sits above F/1.8, and that is the specification:</a:t>
             </a:r>
             <a:r>
               <a:rPr sz="1200" b="0">
@@ -8593,7 +8593,7 @@
                 </a:solidFill>
                 <a:latin typeface="Arial"/>
               </a:rPr>
-              <a:t> D 183 mm at f 330 mm is F/1.803; a cone a little faster than the spectrometer's — Jim's "a little faster" — needs a larger entrance beam, the paper's 192 mm.  A spec question for Jim and Joe, not a solve question; the telescope holds Joe's numbers.</a:t>
+              <a:t> a 183 mm aperture at 330 mm is F/1.80 on axis; the telescope "a little faster than the spectrometer" that the first-round answers asked for needs a larger entrance beam — the paper's 192 mm.  A question for the challenge's authors (slide 19), not for the solve; the telescope holds the numbers given.</a:t>
             </a:r>
           </a:p>
           <a:p>
@@ -8627,7 +8627,7 @@
                 </a:solidFill>
                 <a:latin typeface="Arial"/>
               </a:rPr>
-              <a:t> the cone is F/1.80: the slit truncates the image in that direction, and the across-slit FWHM (the paper's ARF) is 1.02 px against its 2.8 px bound.</a:t>
+              <a:t> the light arrives at F/1.80; the slit truncates the image in that direction, and the across-slit image width (the paper's ARF) is 1.02 px against its 2.8 px bound.</a:t>
             </a:r>
           </a:p>
         </p:txBody>
@@ -8640,7 +8640,7 @@
         </p:nvSpPr>
         <p:spPr>
           <a:xfrm>
-            <a:off x="6400800" y="3200399"/>
+            <a:off x="6400800" y="3398519"/>
             <a:ext cx="5394960" cy="274320"/>
           </a:xfrm>
           <a:prstGeom prst="rect">
@@ -8666,7 +8666,7 @@
                 </a:solidFill>
                 <a:latin typeface="Arial"/>
               </a:rPr>
-              <a:t>REPORT_dyson5_cprime.md, R9 per-field table; F/# from the marginal rays as 1/(2 sin u).</a:t>
+              <a:t>REPORT_dyson5_cprime.md, R9 per-field table; F-number from the marginal rays as 1/(2 sin u).</a:t>
             </a:r>
           </a:p>
         </p:txBody>
@@ -13239,7 +13239,7 @@
                 </a:solidFill>
                 <a:latin typeface="Arial"/>
               </a:rPr>
-              <a:t>  Joe's 183 mm at f 330 mm is F/1.803, so the telescope's cone along the slit is F/1.89 and cannot be "a little faster than the spectrometer" without a larger beam; the paper's is 192 mm.  Is the aperture Joe's number or the paper's?</a:t>
+              <a:t>  Joe's 183 mm at f 330 mm is F/1.803, so the light reaches the slit at F/1.89 along it and cannot be "a little faster than the spectrometer" without a larger beam; the paper's is 192 mm.  Is the aperture Joe's number or the paper's?</a:t>
             </a:r>
           </a:p>
           <a:p>
@@ -13588,7 +13588,7 @@
                 </a:solidFill>
                 <a:latin typeface="Arial"/>
               </a:rPr>
-              <a:t> The approach: the 3k telescope solved as a template, the template run on the 1.5k</a:t>
+              <a:t> The approach: the 3k telescope as a template, the template on the 1.5k</a:t>
             </a:r>
           </a:p>
           <a:p>
@@ -13883,7 +13883,7 @@
                 </a:solidFill>
                 <a:latin typeface="Arial"/>
               </a:rPr>
-              <a:t> Smile is a convention: the launch, not the optics</a:t>
+              <a:t> Smile end to end: the specification read two ways</a:t>
             </a:r>
           </a:p>
           <a:p>
@@ -13917,7 +13917,7 @@
                 </a:solidFill>
                 <a:latin typeface="Arial"/>
               </a:rPr>
-              <a:t> The cone, the spec and the paper's beam</a:t>
+              <a:t> The speed of the light at the slit: the specification and the paper's beam</a:t>
             </a:r>
           </a:p>
           <a:p>
@@ -14454,7 +14454,7 @@
                 </a:solidFill>
                 <a:latin typeface="Arial"/>
               </a:rPr>
-              <a:t> the template tma_longslit is general (one parameter file: f, D, F/#, strip, slit, the cone bound, working distance, the seed legs); its default run is this module, tma_longslit_1k5 the other.  A note to Jim and Joe with this deck, superseding "the 3k module is not there yet."</a:t>
+              <a:t> the template tma_longslit is general (one parameter file: f, D, F/#, strip, slit, the speed bound at the slit, working distance, the seed legs); its default run is this module, tma_longslit_1k5 the other.  A note to Jim and Joe with this deck, superseding "the 3k module is not there yet."</a:t>
             </a:r>
           </a:p>
           <a:p>
@@ -14767,7 +14767,7 @@
                 </a:solidFill>
                 <a:latin typeface="Consolas"/>
               </a:rPr>
-              <a:t>&gt;&gt; P = tma_longslit_params;                        % f, D, F/#, strip, slit, pixel, the telecentric and cone bounds, the seed legs</a:t>
+              <a:t>&gt;&gt; P = tma_longslit_params;                        % f, D, F/#, strip, slit, pixel, the telecentric and speed bounds, the seed legs</a:t>
             </a:r>
           </a:p>
           <a:p>
@@ -21177,7 +21177,7 @@
                 </a:solidFill>
                 <a:latin typeface="Arial"/>
               </a:rPr>
-              <a:t>The approach: the 3k telescope solved as a template, the template run on the 1.5k</a:t>
+              <a:t>The approach: the 3k telescope as a template, the template on the 1.5k</a:t>
             </a:r>
           </a:p>
           <a:p>
@@ -21193,7 +21193,7 @@
                 </a:solidFill>
                 <a:latin typeface="Arial"/>
               </a:rPr>
-              <a:t>The published form became a parameterized design flow — one parameter file, four stages, the constraint rows a slit-fed spectrometer needs — whose default run is the 3k module; run at the 1.5k spec it reached the pixel in five rungs with one new row; the slides that follow are those two runs</a:t>
+              <a:t>The published form became a parameterized design flow whose default run is the 3k module; at the 1.5k spec it reached the pixel in five rungs with one new row; the slides that follow are those two runs</a:t>
             </a:r>
           </a:p>
         </p:txBody>
@@ -21285,43 +21285,114 @@
                 </a:solidFill>
                 <a:latin typeface="Arial"/>
               </a:rPr>
-              <a:t>The 3k telescope (slides 8–14):</a:t>
-            </a:r>
-            <a:r>
-              <a:rPr sz="1200" b="0">
-                <a:solidFill>
-                  <a:srgbClr val="282828"/>
-                </a:solidFill>
-                <a:latin typeface="Arial"/>
-              </a:rPr>
-              <a:t> the published layout digitized and scaled to the challenge's focal length is the seed; the first order is closed-form telecentric with the stop at M2; three off-axis conic sections carry it; a pole-frame polynomial of degree 3–6 on each mirror brings every field of the 9.4° strip to a 1.02-pixel spot with the cone bounded; joined to the 240 mm </a:t>
-            </a:r>
-            <a:r>
-              <a:rPr sz="1200" b="0">
-                <a:solidFill>
-                  <a:srgbClr val="282828"/>
+              <a:t>The 3k telescope (slides 8–14)</a:t>
+            </a:r>
+          </a:p>
+          <a:p>
+            <a:pPr marL="594360" indent="-137160">
+              <a:spcAft>
+                <a:spcPts val="500"/>
+              </a:spcAft>
+            </a:pPr>
+            <a:r>
+              <a:rPr sz="1050" b="0">
+                <a:solidFill>
+                  <a:srgbClr val="6E6E6E"/>
+                </a:solidFill>
+                <a:latin typeface="Arial"/>
+              </a:rPr>
+              <a:t>–  seed: the published layout, scaled to f 330 mm</a:t>
+            </a:r>
+          </a:p>
+          <a:p>
+            <a:pPr marL="594360" indent="-137160">
+              <a:spcAft>
+                <a:spcPts val="500"/>
+              </a:spcAft>
+            </a:pPr>
+            <a:r>
+              <a:rPr sz="1050" b="0">
+                <a:solidFill>
+                  <a:srgbClr val="6E6E6E"/>
+                </a:solidFill>
+                <a:latin typeface="Arial"/>
+              </a:rPr>
+              <a:t>–  first order: telecentric in closed form, the stop at M2, no intermediate focus</a:t>
+            </a:r>
+          </a:p>
+          <a:p>
+            <a:pPr marL="594360" indent="-137160">
+              <a:spcAft>
+                <a:spcPts val="500"/>
+              </a:spcAft>
+            </a:pPr>
+            <a:r>
+              <a:rPr sz="1050" b="0">
+                <a:solidFill>
+                  <a:srgbClr val="6E6E6E"/>
+                </a:solidFill>
+                <a:latin typeface="Arial"/>
+              </a:rPr>
+              <a:t>–  three off-axis conic sections carry it; a degree 3–6 polynomial on each mirror brings every field to a 1.02-pixel spot with the speed bounded</a:t>
+            </a:r>
+          </a:p>
+          <a:p>
+            <a:pPr marL="594360" indent="-137160">
+              <a:spcAft>
+                <a:spcPts val="500"/>
+              </a:spcAft>
+            </a:pPr>
+            <a:r>
+              <a:rPr sz="1050" b="0">
+                <a:solidFill>
+                  <a:srgbClr val="6E6E6E"/>
+                </a:solidFill>
+                <a:latin typeface="Arial"/>
+              </a:rPr>
+              <a:t>–  joined to the 240 mm </a:t>
+            </a:r>
+            <a:r>
+              <a:rPr sz="1050" b="0">
+                <a:solidFill>
+                  <a:srgbClr val="6E6E6E"/>
                 </a:solidFill>
                 <a:latin typeface="Arial"/>
               </a:rPr>
               <a:t>CaF</a:t>
             </a:r>
             <a:r>
-              <a:rPr sz="1200" b="0" baseline="-25000">
-                <a:solidFill>
-                  <a:srgbClr val="282828"/>
+              <a:rPr sz="1050" b="0" baseline="-25000">
+                <a:solidFill>
+                  <a:srgbClr val="6E6E6E"/>
                 </a:solidFill>
                 <a:latin typeface="Arial"/>
               </a:rPr>
               <a:t>2</a:t>
             </a:r>
             <a:r>
-              <a:rPr sz="1200" b="0">
-                <a:solidFill>
-                  <a:srgbClr val="282828"/>
-                </a:solidFill>
-                <a:latin typeface="Arial"/>
-              </a:rPr>
-              <a:t> Dyson it images at the pixel end to end.  Six rungs taught the weights and rows the flow now carries; the last tenth of a pixel of "smile" was the scorer's launch convention, not the optics.</a:t>
+              <a:rPr sz="1050" b="0">
+                <a:solidFill>
+                  <a:srgbClr val="6E6E6E"/>
+                </a:solidFill>
+                <a:latin typeface="Arial"/>
+              </a:rPr>
+              <a:t> Dyson: at the pixel end to end</a:t>
+            </a:r>
+          </a:p>
+          <a:p>
+            <a:pPr marL="594360" indent="-137160">
+              <a:spcAft>
+                <a:spcPts val="500"/>
+              </a:spcAft>
+            </a:pPr>
+            <a:r>
+              <a:rPr sz="1050" b="0">
+                <a:solidFill>
+                  <a:srgbClr val="6E6E6E"/>
+                </a:solidFill>
+                <a:latin typeface="Arial"/>
+              </a:rPr>
+              <a:t>–  six rungs set the weights and rows the flow now carries; the last 0.1 px of "smile" was the scorer's convention, not the optics</a:t>
             </a:r>
           </a:p>
           <a:p>
@@ -21355,7 +21426,55 @@
                 </a:solidFill>
                 <a:latin typeface="Arial"/>
               </a:rPr>
-              <a:t> (templates/10_telescopes/tma_longslit/): the spec, the seed legs and incidences, the bounds, the weights, the field set, the ladder and the spectrometer to join live in one parameter file; four stages — first_order (closed form), section (the conics on the chief, measured per field), figure (the ladder, each rung an engine-traced solve warm from the last), e2e (the best clear rung joined to the spectrometer under both launches) — each writing its table, record and prescription; the deck of record pinned by a test that re-scores it by name.</a:t>
+              <a:t> (templates/10_telescopes/tma_longslit/)</a:t>
+            </a:r>
+          </a:p>
+          <a:p>
+            <a:pPr marL="594360" indent="-137160">
+              <a:spcAft>
+                <a:spcPts val="500"/>
+              </a:spcAft>
+            </a:pPr>
+            <a:r>
+              <a:rPr sz="1050" b="0">
+                <a:solidFill>
+                  <a:srgbClr val="6E6E6E"/>
+                </a:solidFill>
+                <a:latin typeface="Arial"/>
+              </a:rPr>
+              <a:t>–  one parameter file: spec, seed legs and angles, bounds, weights, field set, the ladder, the spectrometer to join</a:t>
+            </a:r>
+          </a:p>
+          <a:p>
+            <a:pPr marL="594360" indent="-137160">
+              <a:spcAft>
+                <a:spcPts val="500"/>
+              </a:spcAft>
+            </a:pPr>
+            <a:r>
+              <a:rPr sz="1050" b="0">
+                <a:solidFill>
+                  <a:srgbClr val="6E6E6E"/>
+                </a:solidFill>
+                <a:latin typeface="Arial"/>
+              </a:rPr>
+              <a:t>–  four stages: first_order → section → figure (the ladder of engine-traced solves) → e2e (joined, both launches)</a:t>
+            </a:r>
+          </a:p>
+          <a:p>
+            <a:pPr marL="594360" indent="-137160">
+              <a:spcAft>
+                <a:spcPts val="500"/>
+              </a:spcAft>
+            </a:pPr>
+            <a:r>
+              <a:rPr sz="1050" b="0">
+                <a:solidFill>
+                  <a:srgbClr val="6E6E6E"/>
+                </a:solidFill>
+                <a:latin typeface="Arial"/>
+              </a:rPr>
+              <a:t>–  each stage writes its table, record and prescription; a test re-scores the deck of record by name</a:t>
             </a:r>
           </a:p>
         </p:txBody>
@@ -21403,16 +21522,103 @@
                 </a:solidFill>
                 <a:latin typeface="Arial"/>
               </a:rPr>
-              <a:t>The rows that make it a long-slit front end:</a:t>
-            </a:r>
-            <a:r>
-              <a:rPr sz="1200" b="0">
-                <a:solidFill>
-                  <a:srgbClr val="282828"/>
-                </a:solidFill>
-                <a:latin typeface="Arial"/>
-              </a:rPr>
-              <a:t> spot size along the slit (weighted); plate scale; the chief's and the centroid's across-slit bow; the chief angle to the slit normal (telecentric); a hinge on the marginal F/# outside the bound, per axis (the cone); the chief − centroid offset at the slit; working distance; and, since the 1.5k run, a clearance wall.  The first order is re-derived at every iterate, never penalized, so focal length, back focus and telecentricity hold exactly under the figure.</a:t>
+              <a:t>The constraints that make it a long-slit front end</a:t>
+            </a:r>
+          </a:p>
+          <a:p>
+            <a:pPr marL="594360" indent="-137160">
+              <a:spcAft>
+                <a:spcPts val="500"/>
+              </a:spcAft>
+            </a:pPr>
+            <a:r>
+              <a:rPr sz="1050" b="0">
+                <a:solidFill>
+                  <a:srgbClr val="6E6E6E"/>
+                </a:solidFill>
+                <a:latin typeface="Arial"/>
+              </a:rPr>
+              <a:t>–  spot size along the slit (weighted); plate scale</a:t>
+            </a:r>
+          </a:p>
+          <a:p>
+            <a:pPr marL="594360" indent="-137160">
+              <a:spcAft>
+                <a:spcPts val="500"/>
+              </a:spcAft>
+            </a:pPr>
+            <a:r>
+              <a:rPr sz="1050" b="0">
+                <a:solidFill>
+                  <a:srgbClr val="6E6E6E"/>
+                </a:solidFill>
+                <a:latin typeface="Arial"/>
+              </a:rPr>
+              <a:t>–  the chief ray's and the centroid's across-slit position</a:t>
+            </a:r>
+          </a:p>
+          <a:p>
+            <a:pPr marL="594360" indent="-137160">
+              <a:spcAft>
+                <a:spcPts val="500"/>
+              </a:spcAft>
+            </a:pPr>
+            <a:r>
+              <a:rPr sz="1050" b="0">
+                <a:solidFill>
+                  <a:srgbClr val="6E6E6E"/>
+                </a:solidFill>
+                <a:latin typeface="Arial"/>
+              </a:rPr>
+              <a:t>–  the chief ray's angle to the slit normal (telecentric)</a:t>
+            </a:r>
+          </a:p>
+          <a:p>
+            <a:pPr marL="594360" indent="-137160">
+              <a:spcAft>
+                <a:spcPts val="500"/>
+              </a:spcAft>
+            </a:pPr>
+            <a:r>
+              <a:rPr sz="1050" b="0">
+                <a:solidFill>
+                  <a:srgbClr val="6E6E6E"/>
+                </a:solidFill>
+                <a:latin typeface="Arial"/>
+              </a:rPr>
+              <a:t>–  a penalty on any marginal ray faster than the spectrometer accepts, along and across the slit</a:t>
+            </a:r>
+          </a:p>
+          <a:p>
+            <a:pPr marL="594360" indent="-137160">
+              <a:spcAft>
+                <a:spcPts val="500"/>
+              </a:spcAft>
+            </a:pPr>
+            <a:r>
+              <a:rPr sz="1050" b="0">
+                <a:solidFill>
+                  <a:srgbClr val="6E6E6E"/>
+                </a:solidFill>
+                <a:latin typeface="Arial"/>
+              </a:rPr>
+              <a:t>–  the chief − centroid offset at the slit; working distance; since the 1.5k run, a clearance wall</a:t>
+            </a:r>
+          </a:p>
+          <a:p>
+            <a:pPr marL="594360" indent="-137160">
+              <a:spcAft>
+                <a:spcPts val="500"/>
+              </a:spcAft>
+            </a:pPr>
+            <a:r>
+              <a:rPr sz="1050" b="0">
+                <a:solidFill>
+                  <a:srgbClr val="6E6E6E"/>
+                </a:solidFill>
+                <a:latin typeface="Arial"/>
+              </a:rPr>
+              <a:t>–  the first order is re-derived at every iterate, never penalized</a:t>
             </a:r>
           </a:p>
           <a:p>
@@ -21437,16 +21643,71 @@
                 </a:solidFill>
                 <a:latin typeface="Arial"/>
               </a:rPr>
-              <a:t>The template on the 1.5k (slide 17):</a:t>
-            </a:r>
-            <a:r>
-              <a:rPr sz="1200" b="0">
-                <a:solidFill>
-                  <a:srgbClr val="282828"/>
-                </a:solidFill>
-                <a:latin typeface="Arial"/>
-              </a:rPr>
-              <a:t> the same seed, rows and weights at a ±2.35° strip and a 27 mm slit, joined to the 130 mm silica Dyson: 1.02 px at every field in five rungs; one deviation on the way — the first rung at the floor put the M3 → slit beam 0.3 mm inside M2, and a clearance wall row bought +2.4 mm with the floor held; end to end smile 0.009, CRF 1.03, 0.97 of the energy in a pixel.</a:t>
+              <a:t>The template on the 1.5k (slide 17)</a:t>
+            </a:r>
+          </a:p>
+          <a:p>
+            <a:pPr marL="594360" indent="-137160">
+              <a:spcAft>
+                <a:spcPts val="500"/>
+              </a:spcAft>
+            </a:pPr>
+            <a:r>
+              <a:rPr sz="1050" b="0">
+                <a:solidFill>
+                  <a:srgbClr val="6E6E6E"/>
+                </a:solidFill>
+                <a:latin typeface="Arial"/>
+              </a:rPr>
+              <a:t>–  same seed, rows and weights; strip ±2.35°, slit 27 mm; joined to the 130 mm silica Dyson</a:t>
+            </a:r>
+          </a:p>
+          <a:p>
+            <a:pPr marL="594360" indent="-137160">
+              <a:spcAft>
+                <a:spcPts val="500"/>
+              </a:spcAft>
+            </a:pPr>
+            <a:r>
+              <a:rPr sz="1050" b="0">
+                <a:solidFill>
+                  <a:srgbClr val="6E6E6E"/>
+                </a:solidFill>
+                <a:latin typeface="Arial"/>
+              </a:rPr>
+              <a:t>–  1.02 px at every field in five rungs</a:t>
+            </a:r>
+          </a:p>
+          <a:p>
+            <a:pPr marL="594360" indent="-137160">
+              <a:spcAft>
+                <a:spcPts val="500"/>
+              </a:spcAft>
+            </a:pPr>
+            <a:r>
+              <a:rPr sz="1050" b="0">
+                <a:solidFill>
+                  <a:srgbClr val="6E6E6E"/>
+                </a:solidFill>
+                <a:latin typeface="Arial"/>
+              </a:rPr>
+              <a:t>–  one deviation: the first rung at the floor put the M3 → slit beam 0.3 mm inside M2; a clearance wall bought +2.4 mm</a:t>
+            </a:r>
+          </a:p>
+          <a:p>
+            <a:pPr marL="594360" indent="-137160">
+              <a:spcAft>
+                <a:spcPts val="500"/>
+              </a:spcAft>
+            </a:pPr>
+            <a:r>
+              <a:rPr sz="1050" b="0">
+                <a:solidFill>
+                  <a:srgbClr val="6E6E6E"/>
+                </a:solidFill>
+                <a:latin typeface="Arial"/>
+              </a:rPr>
+              <a:t>–  end to end: smile 0.009, CRF 1.03, 0.97 of the energy in a pixel</a:t>
             </a:r>
           </a:p>
           <a:p>
@@ -21480,7 +21741,7 @@
                 </a:solidFill>
                 <a:latin typeface="Arial"/>
               </a:rPr>
-              <a:t> the spectrometer toleranced and its Option B assessed, throughput by band, and the two-of-3k trade restated with both modules at the pixel.</a:t>
+              <a:t> the spectrometer toleranced and its Option B, throughput by band, the trade restated</a:t>
             </a:r>
           </a:p>
         </p:txBody>
@@ -21493,7 +21754,7 @@
         </p:nvSpPr>
         <p:spPr>
           <a:xfrm>
-            <a:off x="6400800" y="5123688"/>
+            <a:off x="6400800" y="6250178"/>
             <a:ext cx="5394960" cy="274320"/>
           </a:xfrm>
           <a:prstGeom prst="rect">

</xml_diff>

<commit_message>
deck_dyson_3k: Dave's edit-copy pass folded -- 'the telescope design flow', slide 3 subtitle in his words (in common terms, micrometers at the detector), slide 5 and 15 titles, 'Two of 3k or four of 1.5k?' with 'The paper's answer is two', Next steps 'More on...'; edit copy synced
Co-Authored-By: Claude Fable 5.1 <noreply@anthropic.com>
</commit_message>
<xml_diff>
--- a/demo_session/deck_dyson_3k.pptx
+++ b/demo_session/deck_dyson_3k.pptx
@@ -3165,7 +3165,7 @@
                 </a:solidFill>
                 <a:latin typeface="Arial"/>
               </a:rPr>
-              <a:t>A VSWIR imaging spectrometer for a 180 km swath at 30 m pixels, designed end to end by ray trace: a Dyson spectrometer and a freeform three-mirror telescope per module, two module sizes, both at the pixel — smile 0.02, CRF 1.2 px, 0.85–0.97 of the energy in one pixel — and the telescope flow made a reusable template.</a:t>
+              <a:t>A VSWIR imaging spectrometer for a 180 km swath at 30 m pixels, designed end to end by ray trace: a Dyson spectrometer and a freeform three-mirror telescope per module, two module sizes, both at the pixel — smile 0.02, CRF 1.2 px, 0.85–0.97 of the energy in one pixel — and the telescope design flow made a reusable template.</a:t>
             </a:r>
           </a:p>
           <a:p>
@@ -8723,7 +8723,7 @@
                 </a:solidFill>
                 <a:latin typeface="Arial"/>
               </a:rPr>
-              <a:t>The spectrometer: toleranced, and a conic grating for margin</a:t>
+              <a:t>Spectrometer tolerances, and a conic grating for margin</a:t>
             </a:r>
           </a:p>
           <a:p>
@@ -12011,7 +12011,7 @@
                 </a:solidFill>
                 <a:latin typeface="Arial"/>
               </a:rPr>
-              <a:t>Two of 3k or four of 1.5k, updated</a:t>
+              <a:t>Two of 3k or four of 1.5k?</a:t>
             </a:r>
           </a:p>
           <a:p>
@@ -12027,7 +12027,7 @@
                 </a:solidFill>
                 <a:latin typeface="Arial"/>
               </a:rPr>
-              <a:t>Both modules now image at the pixel end to end; the trade is labor, detectors and integration, not optics or glass — and Jim's and the paper's answer is two</a:t>
+              <a:t>Both modules image at the pixel end to end; the trade is labor, detectors and integration, not optics or glass.  The paper's answer is two</a:t>
             </a:r>
           </a:p>
         </p:txBody>
@@ -13588,7 +13588,7 @@
                 </a:solidFill>
                 <a:latin typeface="Arial"/>
               </a:rPr>
-              <a:t> The approach: the 3k telescope as a template, the template on the 1.5k</a:t>
+              <a:t> The 3k telescope solution provides a template; the template run on the 1.5k</a:t>
             </a:r>
           </a:p>
           <a:p>
@@ -13951,7 +13951,7 @@
                 </a:solidFill>
                 <a:latin typeface="Arial"/>
               </a:rPr>
-              <a:t> The spectrometer: toleranced, and a conic grating for margin</a:t>
+              <a:t> Spectrometer tolerances, and a conic grating for margin</a:t>
             </a:r>
           </a:p>
           <a:p>
@@ -14053,7 +14053,7 @@
                 </a:solidFill>
                 <a:latin typeface="Arial"/>
               </a:rPr>
-              <a:t> Two of 3k or four of 1.5k, updated</a:t>
+              <a:t> Two of 3k or four of 1.5k?</a:t>
             </a:r>
           </a:p>
           <a:p>
@@ -14262,7 +14262,7 @@
                 </a:solidFill>
                 <a:latin typeface="Arial"/>
               </a:rPr>
-              <a:t>The spectrometer's tolerances and form; the telescope's tolerances and sizing; the record</a:t>
+              <a:t>More on the spectrometer's tolerances and form; the telescope's tolerances and sizing; the record</a:t>
             </a:r>
           </a:p>
         </p:txBody>
@@ -19555,7 +19555,7 @@
                 </a:solidFill>
                 <a:latin typeface="Arial"/>
               </a:rPr>
-              <a:t>The challenge's numbers beside the project's published design (the SBG VSWIR paper), the metrics defined once, the paper's bounds restated in detector pixels of 18 µm, where the paper mixes micrometers and co-added 2-pixel bins</a:t>
+              <a:t>The challenge's numbers beside a published design (the SBG VSWIR paper), in common terms (micrometers at the detector)</a:t>
             </a:r>
           </a:p>
         </p:txBody>
@@ -21177,7 +21177,7 @@
                 </a:solidFill>
                 <a:latin typeface="Arial"/>
               </a:rPr>
-              <a:t>The approach: the 3k telescope as a template, the template on the 1.5k</a:t>
+              <a:t>The 3k telescope solution provides a template; the template run on the 1.5k</a:t>
             </a:r>
           </a:p>
           <a:p>

</xml_diff>

<commit_message>
deck_dyson_3k FINAL (Dave 2026-10-09): DRAFT mark removed, export mark on; edit copy synced; Dave's sent version of the note to Jim and Joe recorded
Co-Authored-By: Claude Fable 5.1 <noreply@anthropic.com>
</commit_message>
<xml_diff>
--- a/demo_session/deck_dyson_3k.pptx
+++ b/demo_session/deck_dyson_3k.pptx
@@ -3200,22 +3200,6 @@
               <a:t>October 2026.  Working record; no proprietary prescription is used.</a:t>
             </a:r>
           </a:p>
-          <a:p>
-            <a:pPr>
-              <a:spcAft>
-                <a:spcPts val="800"/>
-              </a:spcAft>
-            </a:pPr>
-            <a:r>
-              <a:rPr sz="1500" b="0">
-                <a:solidFill>
-                  <a:srgbClr val="6E6E6E"/>
-                </a:solidFill>
-                <a:latin typeface="Arial"/>
-              </a:rPr>
-              <a:t>DRAFT — pending review.</a:t>
-            </a:r>
-          </a:p>
         </p:txBody>
       </p:sp>
       <p:sp>
@@ -3253,6 +3237,45 @@
                 <a:latin typeface="Arial"/>
               </a:rPr>
               <a:t>The challenge was posed by Joe Green and Jim McGuire (JPL) as a test of MACOS and its design layer; this is its second round.  The first (2026-10-06) brought the spectrometers to the pixel and left the larger telescope short; their answers and the project's published design set this round's course.</a:t>
+            </a:r>
+          </a:p>
+        </p:txBody>
+      </p:sp>
+      <p:sp>
+        <p:nvSpPr>
+          <p:cNvPr id="4" name="TextBox 3"/>
+          <p:cNvSpPr txBox="1"/>
+          <p:nvPr/>
+        </p:nvSpPr>
+        <p:spPr>
+          <a:xfrm>
+            <a:off x="813816" y="6309360"/>
+            <a:ext cx="10543032" cy="292608"/>
+          </a:xfrm>
+          <a:prstGeom prst="rect">
+            <a:avLst/>
+          </a:prstGeom>
+          <a:noFill/>
+        </p:spPr>
+        <p:txBody>
+          <a:bodyPr wrap="square">
+            <a:spAutoFit/>
+          </a:bodyPr>
+          <a:lstStyle/>
+          <a:p>
+            <a:pPr algn="ctr">
+              <a:spcAft>
+                <a:spcPts val="0"/>
+              </a:spcAft>
+            </a:pPr>
+            <a:r>
+              <a:rPr sz="950" b="0">
+                <a:solidFill>
+                  <a:srgbClr val="6E6E6E"/>
+                </a:solidFill>
+                <a:latin typeface="Arial"/>
+              </a:rPr>
+              <a:t>This document has been reviewed and determined not to contain export-controlled information</a:t>
             </a:r>
           </a:p>
         </p:txBody>

</xml_diff>